<commit_message>
Awards methodology deck: regenerate slides + chart-core tweak
Working-tree changes that predate the award-classification cleanup session,
committed on request so nothing is left uncommitted: updated deck PPTX/PDF,
regenerated QA slide PNGs (plus new axis/badge/route/timeline crops), a new
recompete-timing slide copy module, and a deck_core/charts.py edit.

Co-Authored-By: Claude Opus 4.8 (1M context) <noreply@anthropic.com>
</commit_message>
<xml_diff>
--- a/projects/other/awards_methodology/20260622_Awards Methodology_vS.pptx
+++ b/projects/other/awards_methodology/20260622_Awards Methodology_vS.pptx
@@ -5,12 +5,13 @@
     <p:sldMasterId id="2147483648" r:id="rId1"/>
   </p:sldMasterIdLst>
   <p:handoutMasterIdLst>
-    <p:handoutMasterId r:id="rId5"/>
+    <p:handoutMasterId r:id="rId6"/>
   </p:handoutMasterIdLst>
   <p:sldIdLst>
     <p:sldId id="256" r:id="rId2"/>
     <p:sldId id="257" r:id="rId3"/>
     <p:sldId id="258" r:id="rId4"/>
+    <p:sldId id="259" r:id="rId5"/>
   </p:sldIdLst>
   <p:sldSz cx="12192000" cy="6858000"/>
   <p:notesSz cx="6934200" cy="9220200"/>
@@ -30,6 +31,271 @@
     </a:lvl1pPr>
   </p:defaultTextStyle>
 </p:presentation>
+</file>
+
+<file path=ppt/charts/chart1.xml><?xml version="1.0" encoding="utf-8"?>
+<c:chartSpace xmlns:c="http://schemas.openxmlformats.org/drawingml/2006/chart" xmlns:a="http://schemas.openxmlformats.org/drawingml/2006/main" xmlns:r="http://schemas.openxmlformats.org/officeDocument/2006/relationships">
+  <c:lang val="en-US"/>
+  <c:roundedCorners val="0"/>
+  <c:chart>
+    <c:autoTitleDeleted val="1"/>
+    <c:plotArea>
+      <c:layout>
+        <c:manualLayout>
+          <c:layoutTarget val="inner"/>
+          <c:xMode val="edge"/>
+          <c:yMode val="edge"/>
+          <c:x val="0.312"/>
+          <c:y val="0.089"/>
+          <c:w val="0.682"/>
+          <c:h val="0.898"/>
+        </c:manualLayout>
+      </c:layout>
+      <c:barChart>
+        <c:barDir val="bar"/>
+        <c:grouping val="stacked"/>
+        <c:varyColors val="0"/>
+        <c:ser>
+          <c:idx val="0"/>
+          <c:order val="0"/>
+          <c:tx>
+            <c:strRef>
+              <c:f>Sheet1!$B$1</c:f>
+              <c:strCache>
+                <c:ptCount val="1"/>
+                <c:pt idx="0">
+                  <c:v>Active / base term</c:v>
+                </c:pt>
+              </c:strCache>
+            </c:strRef>
+          </c:tx>
+          <c:spPr>
+            <a:noFill/>
+            <a:ln w="12700">
+              <a:solidFill>
+                <a:srgbClr val="000000"/>
+              </a:solidFill>
+            </a:ln>
+          </c:spPr>
+          <c:invertIfNegative val="0"/>
+          <c:cat>
+            <c:strRef>
+              <c:f>Sheet1!$A$2:$A$6</c:f>
+              <c:strCache>
+                <c:ptCount val="5"/>
+                <c:pt idx="0">
+                  <c:v>Definitive contract</c:v>
+                </c:pt>
+                <c:pt idx="1">
+                  <c:v>Single-award IDIQ</c:v>
+                </c:pt>
+                <c:pt idx="2">
+                  <c:v>Multiple-award IDIQ</c:v>
+                </c:pt>
+                <c:pt idx="3">
+                  <c:v>BPA</c:v>
+                </c:pt>
+                <c:pt idx="4">
+                  <c:v>OT</c:v>
+                </c:pt>
+              </c:strCache>
+            </c:strRef>
+          </c:cat>
+          <c:val>
+            <c:numRef>
+              <c:f>Sheet1!$B$2:$B$6</c:f>
+              <c:numCache>
+                <c:formatCode>General</c:formatCode>
+                <c:ptCount val="5"/>
+                <c:pt idx="0">
+                  <c:v>2.16</c:v>
+                </c:pt>
+                <c:pt idx="1">
+                  <c:v>2.01</c:v>
+                </c:pt>
+                <c:pt idx="2">
+                  <c:v>1.71</c:v>
+                </c:pt>
+                <c:pt idx="3">
+                  <c:v>1.54</c:v>
+                </c:pt>
+                <c:pt idx="4">
+                  <c:v>2.11</c:v>
+                </c:pt>
+              </c:numCache>
+            </c:numRef>
+          </c:val>
+        </c:ser>
+        <c:ser>
+          <c:idx val="1"/>
+          <c:order val="1"/>
+          <c:tx>
+            <c:strRef>
+              <c:f>Sheet1!$C$1</c:f>
+              <c:strCache>
+                <c:ptCount val="1"/>
+                <c:pt idx="0">
+                  <c:v>Option / extension capacity</c:v>
+                </c:pt>
+              </c:strCache>
+            </c:strRef>
+          </c:tx>
+          <c:spPr>
+            <a:noFill/>
+            <a:ln w="12700">
+              <a:solidFill>
+                <a:srgbClr val="000000"/>
+              </a:solidFill>
+              <a:prstDash val="dash"/>
+            </a:ln>
+          </c:spPr>
+          <c:invertIfNegative val="0"/>
+          <c:cat>
+            <c:strRef>
+              <c:f>Sheet1!$A$2:$A$6</c:f>
+              <c:strCache>
+                <c:ptCount val="5"/>
+                <c:pt idx="0">
+                  <c:v>Definitive contract</c:v>
+                </c:pt>
+                <c:pt idx="1">
+                  <c:v>Single-award IDIQ</c:v>
+                </c:pt>
+                <c:pt idx="2">
+                  <c:v>Multiple-award IDIQ</c:v>
+                </c:pt>
+                <c:pt idx="3">
+                  <c:v>BPA</c:v>
+                </c:pt>
+                <c:pt idx="4">
+                  <c:v>OT</c:v>
+                </c:pt>
+              </c:strCache>
+            </c:strRef>
+          </c:cat>
+          <c:val>
+            <c:numRef>
+              <c:f>Sheet1!$C$2:$C$6</c:f>
+              <c:numCache>
+                <c:formatCode>General</c:formatCode>
+                <c:ptCount val="5"/>
+                <c:pt idx="0">
+                  <c:v>1.3</c:v>
+                </c:pt>
+                <c:pt idx="1">
+                  <c:v>1.1</c:v>
+                </c:pt>
+                <c:pt idx="2">
+                  <c:v>1.01</c:v>
+                </c:pt>
+                <c:pt idx="3">
+                  <c:v>0.94</c:v>
+                </c:pt>
+                <c:pt idx="4">
+                  <c:v>1.22</c:v>
+                </c:pt>
+              </c:numCache>
+            </c:numRef>
+          </c:val>
+        </c:ser>
+        <c:gapWidth val="300"/>
+        <c:overlap val="100"/>
+        <c:axId val="111111111"/>
+        <c:axId val="222222222"/>
+      </c:barChart>
+      <c:catAx>
+        <c:axId val="111111111"/>
+        <c:scaling>
+          <c:orientation val="maxMin"/>
+        </c:scaling>
+        <c:delete val="0"/>
+        <c:axPos val="l"/>
+        <c:numFmt formatCode="General" sourceLinked="1"/>
+        <c:majorTickMark val="out"/>
+        <c:minorTickMark val="none"/>
+        <c:tickLblPos val="nextTo"/>
+        <c:spPr>
+          <a:ln w="9525" cap="flat">
+            <a:solidFill>
+              <a:srgbClr val="FFFFFF"/>
+            </a:solidFill>
+            <a:prstDash val="solid"/>
+          </a:ln>
+        </c:spPr>
+        <c:txPr>
+          <a:bodyPr rot="0" spcFirstLastPara="1" vertOverflow="ellipsis" wrap="square" anchor="ctr" anchorCtr="1"/>
+          <a:lstStyle/>
+          <a:p>
+            <a:pPr>
+              <a:defRPr sz="800" b="1">
+                <a:solidFill>
+                  <a:srgbClr val="000000"/>
+                </a:solidFill>
+                <a:latin typeface="Arial"/>
+                <a:ea typeface="Arial"/>
+                <a:cs typeface="Arial"/>
+              </a:defRPr>
+            </a:pPr>
+            <a:endParaRPr lang="en-US"/>
+          </a:p>
+        </c:txPr>
+        <c:crossAx val="222222222"/>
+        <c:crosses val="autoZero"/>
+        <c:auto val="1"/>
+        <c:lblAlgn val="ctr"/>
+        <c:lblOffset val="100"/>
+        <c:noMultiLvlLbl val="0"/>
+      </c:catAx>
+      <c:valAx>
+        <c:axId val="222222222"/>
+        <c:scaling>
+          <c:orientation val="minMax"/>
+          <c:max val="4.25"/>
+          <c:min val="0"/>
+        </c:scaling>
+        <c:delete val="0"/>
+        <c:axPos val="b"/>
+        <c:numFmt formatCode="General" sourceLinked="0"/>
+        <c:majorTickMark val="none"/>
+        <c:minorTickMark val="none"/>
+        <c:tickLblPos val="none"/>
+        <c:spPr>
+          <a:ln w="9525" cap="flat">
+            <a:solidFill>
+              <a:srgbClr val="FFFFFF"/>
+            </a:solidFill>
+            <a:prstDash val="solid"/>
+          </a:ln>
+        </c:spPr>
+        <c:txPr>
+          <a:bodyPr rot="0" spcFirstLastPara="1" vertOverflow="ellipsis" wrap="square" anchor="ctr" anchorCtr="1"/>
+          <a:lstStyle/>
+          <a:p>
+            <a:pPr>
+              <a:defRPr sz="800" b="0">
+                <a:solidFill>
+                  <a:srgbClr val="000000"/>
+                </a:solidFill>
+                <a:latin typeface="Arial"/>
+                <a:ea typeface="Arial"/>
+                <a:cs typeface="Arial"/>
+              </a:defRPr>
+            </a:pPr>
+            <a:endParaRPr lang="en-US"/>
+          </a:p>
+        </c:txPr>
+        <c:crossAx val="111111111"/>
+        <c:crosses val="autoZero"/>
+        <c:crossBetween val="between"/>
+      </c:valAx>
+    </c:plotArea>
+    <c:plotVisOnly val="1"/>
+    <c:dispBlanksAs val="gap"/>
+  </c:chart>
+  <c:externalData r:id="rId1">
+    <c:autoUpdate val="0"/>
+  </c:externalData>
+</c:chartSpace>
 </file>
 
 <file path=ppt/handoutMasters/handoutMaster1.xml><?xml version="1.0" encoding="utf-8"?>
@@ -6267,6 +6533,3316 @@
                 <a:ea typeface="Arial"/>
                 <a:cs typeface="Arial"/>
               </a:rPr>
+              <a:t> / Recompete Addressability</a:t>
+            </a:r>
+          </a:p>
+        </p:txBody>
+      </p:sp>
+      <p:sp>
+        <p:nvSpPr>
+          <p:cNvPr id="4" name="PrelimChip"/>
+          <p:cNvSpPr txBox="1"/>
+          <p:nvPr/>
+        </p:nvSpPr>
+        <p:spPr>
+          <a:xfrm>
+            <a:off x="10267829" y="111556"/>
+            <a:ext cx="1467612" cy="290000"/>
+          </a:xfrm>
+          <a:prstGeom prst="rect">
+            <a:avLst/>
+          </a:prstGeom>
+          <a:solidFill>
+            <a:srgbClr val="FFFFCC"/>
+          </a:solidFill>
+          <a:ln w="19050">
+            <a:solidFill>
+              <a:srgbClr val="000000"/>
+            </a:solidFill>
+          </a:ln>
+        </p:spPr>
+        <p:txBody>
+          <a:bodyPr wrap="square" anchor="ctr" lIns="45720" tIns="9144" rIns="45720" bIns="9144"/>
+          <a:lstStyle/>
+          <a:p>
+            <a:pPr algn="ctr"/>
+            <a:r>
+              <a:rPr lang="en-US" sz="1200" b="1" kern="1200" dirty="0">
+                <a:solidFill>
+                  <a:srgbClr val="000000"/>
+                </a:solidFill>
+                <a:latin typeface="Arial"/>
+                <a:ea typeface="Arial"/>
+                <a:cs typeface="Arial"/>
+              </a:rPr>
+              <a:t>Preliminary</a:t>
+            </a:r>
+          </a:p>
+        </p:txBody>
+      </p:sp>
+      <p:sp>
+        <p:nvSpPr>
+          <p:cNvPr id="3" name="Title"/>
+          <p:cNvSpPr>
+            <a:spLocks noGrp="1"/>
+          </p:cNvSpPr>
+          <p:nvPr>
+            <p:ph type="title"/>
+          </p:nvPr>
+        </p:nvSpPr>
+        <p:spPr>
+          <a:xfrm>
+            <a:off x="453079" y="554500"/>
+            <a:ext cx="11282362" cy="640080"/>
+          </a:xfrm>
+        </p:spPr>
+        <p:txBody>
+          <a:bodyPr rIns="0"/>
+          <a:lstStyle/>
+          <a:p>
+            <a:r>
+              <a:rPr lang="en-US" sz="2000" kern="1200" dirty="0">
+                <a:solidFill>
+                  <a:srgbClr val="162029"/>
+                </a:solidFill>
+                <a:latin typeface="Arial"/>
+                <a:ea typeface="Arial"/>
+                <a:cs typeface="Arial"/>
+              </a:rPr>
+              <a:t>Recompete Timing | A vehicle's last date to order sets the recompete clock, not its last task order's end date.</a:t>
+            </a:r>
+          </a:p>
+        </p:txBody>
+      </p:sp>
+      <p:graphicFrame>
+        <p:nvGraphicFramePr>
+          <p:cNvPr id="10" name="RecompeteTimelineChart"/>
+          <p:cNvGraphicFramePr/>
+          <p:nvPr/>
+        </p:nvGraphicFramePr>
+        <p:xfrm>
+          <a:off x="453079" y="2240280"/>
+          <a:ext cx="5687568" cy="2871216"/>
+        </p:xfrm>
+        <a:graphic>
+          <a:graphicData uri="http://schemas.openxmlformats.org/drawingml/2006/chart">
+            <c:chart xmlns:c="http://schemas.openxmlformats.org/drawingml/2006/chart" xmlns:r="http://schemas.openxmlformats.org/officeDocument/2006/relationships" r:id="rId2"/>
+          </a:graphicData>
+        </a:graphic>
+      </p:graphicFrame>
+      <p:sp>
+        <p:nvSpPr>
+          <p:cNvPr id="11" name="ClockReframe"/>
+          <p:cNvSpPr txBox="1"/>
+          <p:nvPr/>
+        </p:nvSpPr>
+        <p:spPr>
+          <a:xfrm>
+            <a:off x="453079" y="1371600"/>
+            <a:ext cx="7168896" cy="630936"/>
+          </a:xfrm>
+          <a:prstGeom prst="rect">
+            <a:avLst/>
+          </a:prstGeom>
+          <a:noFill/>
+          <a:ln>
+            <a:noFill/>
+          </a:ln>
+        </p:spPr>
+        <p:txBody>
+          <a:bodyPr wrap="square" anchor="t" lIns="0" tIns="0" rIns="0" bIns="0"/>
+          <a:lstStyle/>
+          <a:p>
+            <a:pPr>
+              <a:lnSpc>
+                <a:spcPct val="108000"/>
+              </a:lnSpc>
+              <a:buNone/>
+            </a:pPr>
+            <a:r>
+              <a:rPr lang="en-US" sz="1100" b="1" dirty="0">
+                <a:solidFill>
+                  <a:srgbClr val="000000"/>
+                </a:solidFill>
+                <a:latin typeface="Arial"/>
+                <a:ea typeface="Arial"/>
+                <a:cs typeface="Arial"/>
+              </a:rPr>
+              <a:t>Recompete is when authority to place new orders ends, not when the latest task order ends.</a:t>
+            </a:r>
+          </a:p>
+          <a:p>
+            <a:pPr>
+              <a:lnSpc>
+                <a:spcPct val="108000"/>
+              </a:lnSpc>
+              <a:buNone/>
+            </a:pPr>
+            <a:r>
+              <a:rPr lang="en-US" sz="900" dirty="0">
+                <a:solidFill>
+                  <a:srgbClr val="000000"/>
+                </a:solidFill>
+                <a:latin typeface="Arial"/>
+                <a:ea typeface="Arial"/>
+                <a:cs typeface="Arial"/>
+              </a:rPr>
+              <a:t>For an Indefinite Delivery Vehicle (IDV), the parent's last date to order controls; orders placed during the ordering period can keep performing after it. Reading the latest child-order end as the recompete date is the common false signal.</a:t>
+            </a:r>
+          </a:p>
+        </p:txBody>
+      </p:sp>
+      <p:cxnSp>
+        <p:nvCxnSpPr>
+          <p:cNvPr id="12" name="SectionDivider"/>
+          <p:cNvCxnSpPr/>
+          <p:nvPr/>
+        </p:nvCxnSpPr>
+        <p:spPr>
+          <a:xfrm>
+            <a:off x="7722559" y="1371600"/>
+            <a:ext cx="1" cy="3858768"/>
+          </a:xfrm>
+          <a:prstGeom prst="line">
+            <a:avLst/>
+          </a:prstGeom>
+          <a:ln w="6350">
+            <a:solidFill>
+              <a:srgbClr val="BFBFBF"/>
+            </a:solidFill>
+          </a:ln>
+        </p:spPr>
+      </p:cxnSp>
+      <p:cxnSp>
+        <p:nvCxnSpPr>
+          <p:cNvPr id="13" name="TriggerLegendTick"/>
+          <p:cNvCxnSpPr/>
+          <p:nvPr/>
+        </p:nvCxnSpPr>
+        <p:spPr>
+          <a:xfrm>
+            <a:off x="3580327" y="2093976"/>
+            <a:ext cx="1" cy="164592"/>
+          </a:xfrm>
+          <a:prstGeom prst="line">
+            <a:avLst/>
+          </a:prstGeom>
+          <a:ln w="25400">
+            <a:solidFill>
+              <a:srgbClr val="6E91B1"/>
+            </a:solidFill>
+          </a:ln>
+        </p:spPr>
+      </p:cxnSp>
+      <p:sp>
+        <p:nvSpPr>
+          <p:cNvPr id="14" name="TriggerLegend"/>
+          <p:cNvSpPr txBox="1"/>
+          <p:nvPr/>
+        </p:nvSpPr>
+        <p:spPr>
+          <a:xfrm>
+            <a:off x="3671767" y="2048256"/>
+            <a:ext cx="1069848" cy="256032"/>
+          </a:xfrm>
+          <a:prstGeom prst="rect">
+            <a:avLst/>
+          </a:prstGeom>
+          <a:noFill/>
+          <a:ln>
+            <a:noFill/>
+          </a:ln>
+        </p:spPr>
+        <p:txBody>
+          <a:bodyPr wrap="square" anchor="ctr" lIns="0" tIns="0" rIns="0" bIns="0"/>
+          <a:lstStyle/>
+          <a:p>
+            <a:pPr algn="l">
+              <a:lnSpc>
+                <a:spcPct val="105000"/>
+              </a:lnSpc>
+              <a:buNone/>
+            </a:pPr>
+            <a:r>
+              <a:rPr lang="en-US" sz="800" b="0" i="1" dirty="0">
+                <a:solidFill>
+                  <a:srgbClr val="000000"/>
+                </a:solidFill>
+                <a:latin typeface="Arial"/>
+                <a:ea typeface="Arial"/>
+                <a:cs typeface="Arial"/>
+              </a:rPr>
+              <a:t>last date to order
+(recompete trigger)</a:t>
+            </a:r>
+          </a:p>
+        </p:txBody>
+      </p:sp>
+      <p:sp>
+        <p:nvSpPr>
+          <p:cNvPr id="15" name="TailLegend"/>
+          <p:cNvSpPr txBox="1"/>
+          <p:nvPr/>
+        </p:nvSpPr>
+        <p:spPr>
+          <a:xfrm>
+            <a:off x="4750759" y="2048256"/>
+            <a:ext cx="1444752" cy="329184"/>
+          </a:xfrm>
+          <a:prstGeom prst="rect">
+            <a:avLst/>
+          </a:prstGeom>
+          <a:noFill/>
+          <a:ln>
+            <a:noFill/>
+          </a:ln>
+        </p:spPr>
+        <p:txBody>
+          <a:bodyPr wrap="square" anchor="ctr" lIns="0" tIns="0" rIns="0" bIns="0"/>
+          <a:lstStyle/>
+          <a:p>
+            <a:pPr algn="l">
+              <a:lnSpc>
+                <a:spcPct val="105000"/>
+              </a:lnSpc>
+              <a:buNone/>
+            </a:pPr>
+            <a:r>
+              <a:rPr lang="en-US" sz="750" b="0" i="1" dirty="0">
+                <a:solidFill>
+                  <a:srgbClr val="7F7F7F"/>
+                </a:solidFill>
+                <a:latin typeface="Arial"/>
+                <a:ea typeface="Arial"/>
+                <a:cs typeface="Arial"/>
+              </a:rPr>
+              <a:t>child-order performance tail
+(continues past the trigger)</a:t>
+            </a:r>
+          </a:p>
+        </p:txBody>
+      </p:sp>
+      <p:cxnSp>
+        <p:nvCxnSpPr>
+          <p:cNvPr id="16" name="TimeAxis"/>
+          <p:cNvCxnSpPr/>
+          <p:nvPr/>
+        </p:nvCxnSpPr>
+        <p:spPr>
+          <a:xfrm>
+            <a:off x="2227600" y="2395728"/>
+            <a:ext cx="3878921" cy="1"/>
+          </a:xfrm>
+          <a:prstGeom prst="line">
+            <a:avLst/>
+          </a:prstGeom>
+          <a:ln w="9525">
+            <a:solidFill>
+              <a:srgbClr val="000000"/>
+            </a:solidFill>
+            <a:tailEnd type="triangle" w="med" len="med"/>
+          </a:ln>
+        </p:spPr>
+      </p:cxnSp>
+      <p:cxnSp>
+        <p:nvCxnSpPr>
+          <p:cNvPr id="17" name="TodayLine"/>
+          <p:cNvCxnSpPr/>
+          <p:nvPr/>
+        </p:nvCxnSpPr>
+        <p:spPr>
+          <a:xfrm>
+            <a:off x="2227600" y="2368296"/>
+            <a:ext cx="1" cy="2962656"/>
+          </a:xfrm>
+          <a:prstGeom prst="line">
+            <a:avLst/>
+          </a:prstGeom>
+          <a:ln w="6350">
+            <a:solidFill>
+              <a:srgbClr val="BFBFBF"/>
+            </a:solidFill>
+            <a:prstDash val="dash"/>
+          </a:ln>
+        </p:spPr>
+      </p:cxnSp>
+      <p:cxnSp>
+        <p:nvCxnSpPr>
+          <p:cNvPr id="18" name="DecisionHorizonLine"/>
+          <p:cNvCxnSpPr/>
+          <p:nvPr/>
+        </p:nvCxnSpPr>
+        <p:spPr>
+          <a:xfrm>
+            <a:off x="5531528" y="2368296"/>
+            <a:ext cx="1" cy="2962656"/>
+          </a:xfrm>
+          <a:prstGeom prst="line">
+            <a:avLst/>
+          </a:prstGeom>
+          <a:ln w="6350">
+            <a:solidFill>
+              <a:srgbClr val="BFBFBF"/>
+            </a:solidFill>
+            <a:prstDash val="dash"/>
+          </a:ln>
+        </p:spPr>
+      </p:cxnSp>
+      <p:sp>
+        <p:nvSpPr>
+          <p:cNvPr id="19" name="TodayLabel"/>
+          <p:cNvSpPr txBox="1"/>
+          <p:nvPr/>
+        </p:nvSpPr>
+        <p:spPr>
+          <a:xfrm>
+            <a:off x="1989856" y="2176272"/>
+            <a:ext cx="530352" cy="164592"/>
+          </a:xfrm>
+          <a:prstGeom prst="rect">
+            <a:avLst/>
+          </a:prstGeom>
+          <a:noFill/>
+          <a:ln>
+            <a:noFill/>
+          </a:ln>
+        </p:spPr>
+        <p:txBody>
+          <a:bodyPr wrap="square" anchor="ctr" lIns="0" tIns="0" rIns="0" bIns="0"/>
+          <a:lstStyle/>
+          <a:p>
+            <a:pPr algn="ctr">
+              <a:lnSpc>
+                <a:spcPct val="105000"/>
+              </a:lnSpc>
+              <a:buNone/>
+            </a:pPr>
+            <a:r>
+              <a:rPr lang="en-US" sz="800" b="1" i="0" dirty="0">
+                <a:solidFill>
+                  <a:srgbClr val="000000"/>
+                </a:solidFill>
+                <a:latin typeface="Arial"/>
+                <a:ea typeface="Arial"/>
+                <a:cs typeface="Arial"/>
+              </a:rPr>
+              <a:t>TODAY</a:t>
+            </a:r>
+          </a:p>
+        </p:txBody>
+      </p:sp>
+      <p:sp>
+        <p:nvSpPr>
+          <p:cNvPr id="20" name="DecisionHorizonLabel"/>
+          <p:cNvSpPr txBox="1"/>
+          <p:nvPr/>
+        </p:nvSpPr>
+        <p:spPr>
+          <a:xfrm>
+            <a:off x="5110904" y="2414016"/>
+            <a:ext cx="841248" cy="128016"/>
+          </a:xfrm>
+          <a:prstGeom prst="rect">
+            <a:avLst/>
+          </a:prstGeom>
+          <a:noFill/>
+          <a:ln>
+            <a:noFill/>
+          </a:ln>
+        </p:spPr>
+        <p:txBody>
+          <a:bodyPr wrap="square" anchor="ctr" lIns="0" tIns="0" rIns="0" bIns="0"/>
+          <a:lstStyle/>
+          <a:p>
+            <a:pPr algn="ctr">
+              <a:lnSpc>
+                <a:spcPct val="105000"/>
+              </a:lnSpc>
+              <a:buNone/>
+            </a:pPr>
+            <a:r>
+              <a:rPr lang="en-US" sz="750" b="0" i="1" dirty="0">
+                <a:solidFill>
+                  <a:srgbClr val="7F7F7F"/>
+                </a:solidFill>
+                <a:latin typeface="Arial"/>
+                <a:ea typeface="Arial"/>
+                <a:cs typeface="Arial"/>
+              </a:rPr>
+              <a:t>decision horizon</a:t>
+            </a:r>
+          </a:p>
+        </p:txBody>
+      </p:sp>
+      <p:sp>
+        <p:nvSpPr>
+          <p:cNvPr id="21" name="BarLabel_Definitive"/>
+          <p:cNvSpPr txBox="1"/>
+          <p:nvPr/>
+        </p:nvSpPr>
+        <p:spPr>
+          <a:xfrm>
+            <a:off x="2227600" y="2685073"/>
+            <a:ext cx="1971404" cy="137160"/>
+          </a:xfrm>
+          <a:prstGeom prst="rect">
+            <a:avLst/>
+          </a:prstGeom>
+          <a:noFill/>
+          <a:ln>
+            <a:noFill/>
+          </a:ln>
+        </p:spPr>
+        <p:txBody>
+          <a:bodyPr wrap="square" anchor="ctr" lIns="0" tIns="0" rIns="0" bIns="0"/>
+          <a:lstStyle/>
+          <a:p>
+            <a:pPr algn="ctr">
+              <a:lnSpc>
+                <a:spcPct val="105000"/>
+              </a:lnSpc>
+              <a:buNone/>
+            </a:pPr>
+            <a:r>
+              <a:rPr lang="en-US" sz="750" b="0" i="0" dirty="0">
+                <a:solidFill>
+                  <a:srgbClr val="000000"/>
+                </a:solidFill>
+                <a:latin typeface="Arial"/>
+                <a:ea typeface="Arial"/>
+                <a:cs typeface="Arial"/>
+              </a:rPr>
+              <a:t>base term</a:t>
+            </a:r>
+          </a:p>
+        </p:txBody>
+      </p:sp>
+      <p:sp>
+        <p:nvSpPr>
+          <p:cNvPr id="22" name="ExtLabel_Definitive"/>
+          <p:cNvSpPr txBox="1"/>
+          <p:nvPr/>
+        </p:nvSpPr>
+        <p:spPr>
+          <a:xfrm>
+            <a:off x="4199004" y="2685073"/>
+            <a:ext cx="1186494" cy="137160"/>
+          </a:xfrm>
+          <a:prstGeom prst="rect">
+            <a:avLst/>
+          </a:prstGeom>
+          <a:noFill/>
+          <a:ln>
+            <a:noFill/>
+          </a:ln>
+        </p:spPr>
+        <p:txBody>
+          <a:bodyPr wrap="square" anchor="ctr" lIns="0" tIns="0" rIns="0" bIns="0"/>
+          <a:lstStyle/>
+          <a:p>
+            <a:pPr algn="ctr">
+              <a:lnSpc>
+                <a:spcPct val="105000"/>
+              </a:lnSpc>
+              <a:buNone/>
+            </a:pPr>
+            <a:r>
+              <a:rPr lang="en-US" sz="700" b="0" i="1" dirty="0">
+                <a:solidFill>
+                  <a:srgbClr val="7F7F7F"/>
+                </a:solidFill>
+                <a:latin typeface="Arial"/>
+                <a:ea typeface="Arial"/>
+                <a:cs typeface="Arial"/>
+              </a:rPr>
+              <a:t>option capacity</a:t>
+            </a:r>
+          </a:p>
+        </p:txBody>
+      </p:sp>
+      <p:cxnSp>
+        <p:nvCxnSpPr>
+          <p:cNvPr id="23" name="Trigger_Definitive"/>
+          <p:cNvCxnSpPr/>
+          <p:nvPr/>
+        </p:nvCxnSpPr>
+        <p:spPr>
+          <a:xfrm>
+            <a:off x="4199004" y="2570773"/>
+            <a:ext cx="1" cy="393192"/>
+          </a:xfrm>
+          <a:prstGeom prst="line">
+            <a:avLst/>
+          </a:prstGeom>
+          <a:ln w="25400">
+            <a:solidFill>
+              <a:srgbClr val="6E91B1"/>
+            </a:solidFill>
+          </a:ln>
+        </p:spPr>
+      </p:cxnSp>
+      <p:cxnSp>
+        <p:nvCxnSpPr>
+          <p:cNvPr id="24" name="TriggerDrop_Definitive"/>
+          <p:cNvCxnSpPr/>
+          <p:nvPr/>
+        </p:nvCxnSpPr>
+        <p:spPr>
+          <a:xfrm>
+            <a:off x="4199004" y="2822233"/>
+            <a:ext cx="1" cy="192024"/>
+          </a:xfrm>
+          <a:prstGeom prst="line">
+            <a:avLst/>
+          </a:prstGeom>
+          <a:ln w="9525">
+            <a:solidFill>
+              <a:srgbClr val="000000"/>
+            </a:solidFill>
+          </a:ln>
+        </p:spPr>
+      </p:cxnSp>
+      <p:cxnSp>
+        <p:nvCxnSpPr>
+          <p:cNvPr id="25" name="RouteToGate_Definitive"/>
+          <p:cNvCxnSpPr/>
+          <p:nvPr/>
+        </p:nvCxnSpPr>
+        <p:spPr>
+          <a:xfrm>
+            <a:off x="4199004" y="3014257"/>
+            <a:ext cx="2033083" cy="1"/>
+          </a:xfrm>
+          <a:prstGeom prst="line">
+            <a:avLst/>
+          </a:prstGeom>
+          <a:ln w="9525">
+            <a:solidFill>
+              <a:srgbClr val="000000"/>
+            </a:solidFill>
+            <a:tailEnd type="triangle" w="med" len="med"/>
+          </a:ln>
+        </p:spPr>
+      </p:cxnSp>
+      <p:sp>
+        <p:nvSpPr>
+          <p:cNvPr id="26" name="BarLabel_SA_IDIQ"/>
+          <p:cNvSpPr txBox="1"/>
+          <p:nvPr/>
+        </p:nvSpPr>
+        <p:spPr>
+          <a:xfrm>
+            <a:off x="2227600" y="3200743"/>
+            <a:ext cx="1834501" cy="137160"/>
+          </a:xfrm>
+          <a:prstGeom prst="rect">
+            <a:avLst/>
+          </a:prstGeom>
+          <a:noFill/>
+          <a:ln>
+            <a:noFill/>
+          </a:ln>
+        </p:spPr>
+        <p:txBody>
+          <a:bodyPr wrap="square" anchor="ctr" lIns="0" tIns="0" rIns="0" bIns="0"/>
+          <a:lstStyle/>
+          <a:p>
+            <a:pPr algn="ctr">
+              <a:lnSpc>
+                <a:spcPct val="105000"/>
+              </a:lnSpc>
+              <a:buNone/>
+            </a:pPr>
+            <a:r>
+              <a:rPr lang="en-US" sz="750" b="0" i="0" dirty="0">
+                <a:solidFill>
+                  <a:srgbClr val="000000"/>
+                </a:solidFill>
+                <a:latin typeface="Arial"/>
+                <a:ea typeface="Arial"/>
+                <a:cs typeface="Arial"/>
+              </a:rPr>
+              <a:t>parent ordering period</a:t>
+            </a:r>
+          </a:p>
+        </p:txBody>
+      </p:sp>
+      <p:sp>
+        <p:nvSpPr>
+          <p:cNvPr id="27" name="ChildLabel_SA_IDIQ"/>
+          <p:cNvSpPr txBox="1"/>
+          <p:nvPr/>
+        </p:nvSpPr>
+        <p:spPr>
+          <a:xfrm>
+            <a:off x="2227600" y="3333331"/>
+            <a:ext cx="438912" cy="118872"/>
+          </a:xfrm>
+          <a:prstGeom prst="rect">
+            <a:avLst/>
+          </a:prstGeom>
+          <a:noFill/>
+          <a:ln>
+            <a:noFill/>
+          </a:ln>
+        </p:spPr>
+        <p:txBody>
+          <a:bodyPr wrap="square" anchor="ctr" lIns="0" tIns="0" rIns="0" bIns="0"/>
+          <a:lstStyle/>
+          <a:p>
+            <a:pPr algn="l">
+              <a:lnSpc>
+                <a:spcPct val="105000"/>
+              </a:lnSpc>
+              <a:buNone/>
+            </a:pPr>
+            <a:r>
+              <a:rPr lang="en-US" sz="750" b="0" i="1" dirty="0">
+                <a:solidFill>
+                  <a:srgbClr val="7F7F7F"/>
+                </a:solidFill>
+                <a:latin typeface="Arial"/>
+                <a:ea typeface="Arial"/>
+                <a:cs typeface="Arial"/>
+              </a:rPr>
+              <a:t>orders</a:t>
+            </a:r>
+          </a:p>
+        </p:txBody>
+      </p:sp>
+      <p:sp>
+        <p:nvSpPr>
+          <p:cNvPr id="28" name="ChildTail_SA_IDIQ_1"/>
+          <p:cNvSpPr/>
+          <p:nvPr/>
+        </p:nvSpPr>
+        <p:spPr>
+          <a:xfrm>
+            <a:off x="2702197" y="3342475"/>
+            <a:ext cx="2811077" cy="54864"/>
+          </a:xfrm>
+          <a:prstGeom prst="rect">
+            <a:avLst/>
+          </a:prstGeom>
+          <a:noFill/>
+          <a:ln w="9525">
+            <a:solidFill>
+              <a:srgbClr val="7F7F7F"/>
+            </a:solidFill>
+          </a:ln>
+        </p:spPr>
+      </p:sp>
+      <p:sp>
+        <p:nvSpPr>
+          <p:cNvPr id="29" name="ChildTail_SA_IDIQ_2"/>
+          <p:cNvSpPr/>
+          <p:nvPr/>
+        </p:nvSpPr>
+        <p:spPr>
+          <a:xfrm>
+            <a:off x="3797422" y="3433915"/>
+            <a:ext cx="2126561" cy="54864"/>
+          </a:xfrm>
+          <a:prstGeom prst="rect">
+            <a:avLst/>
+          </a:prstGeom>
+          <a:noFill/>
+          <a:ln w="9525">
+            <a:solidFill>
+              <a:srgbClr val="7F7F7F"/>
+            </a:solidFill>
+          </a:ln>
+        </p:spPr>
+      </p:sp>
+      <p:cxnSp>
+        <p:nvCxnSpPr>
+          <p:cNvPr id="30" name="Trigger_SA_IDIQ"/>
+          <p:cNvCxnSpPr/>
+          <p:nvPr/>
+        </p:nvCxnSpPr>
+        <p:spPr>
+          <a:xfrm>
+            <a:off x="5066057" y="3086443"/>
+            <a:ext cx="1" cy="393192"/>
+          </a:xfrm>
+          <a:prstGeom prst="line">
+            <a:avLst/>
+          </a:prstGeom>
+          <a:ln w="25400">
+            <a:solidFill>
+              <a:srgbClr val="6E91B1"/>
+            </a:solidFill>
+          </a:ln>
+        </p:spPr>
+      </p:cxnSp>
+      <p:cxnSp>
+        <p:nvCxnSpPr>
+          <p:cNvPr id="31" name="RouteToGate_SA_IDIQ"/>
+          <p:cNvCxnSpPr/>
+          <p:nvPr/>
+        </p:nvCxnSpPr>
+        <p:spPr>
+          <a:xfrm>
+            <a:off x="5066057" y="3269323"/>
+            <a:ext cx="1166030" cy="1"/>
+          </a:xfrm>
+          <a:prstGeom prst="line">
+            <a:avLst/>
+          </a:prstGeom>
+          <a:ln w="9525">
+            <a:solidFill>
+              <a:srgbClr val="000000"/>
+            </a:solidFill>
+            <a:tailEnd type="triangle" w="med" len="med"/>
+          </a:ln>
+        </p:spPr>
+      </p:cxnSp>
+      <p:sp>
+        <p:nvSpPr>
+          <p:cNvPr id="32" name="BarLabel_MA_IDIQ"/>
+          <p:cNvSpPr txBox="1"/>
+          <p:nvPr/>
+        </p:nvSpPr>
+        <p:spPr>
+          <a:xfrm>
+            <a:off x="2227600" y="3716413"/>
+            <a:ext cx="1560695" cy="137160"/>
+          </a:xfrm>
+          <a:prstGeom prst="rect">
+            <a:avLst/>
+          </a:prstGeom>
+          <a:noFill/>
+          <a:ln>
+            <a:noFill/>
+          </a:ln>
+        </p:spPr>
+        <p:txBody>
+          <a:bodyPr wrap="square" anchor="ctr" lIns="0" tIns="0" rIns="0" bIns="0"/>
+          <a:lstStyle/>
+          <a:p>
+            <a:pPr algn="ctr">
+              <a:lnSpc>
+                <a:spcPct val="105000"/>
+              </a:lnSpc>
+              <a:buNone/>
+            </a:pPr>
+            <a:r>
+              <a:rPr lang="en-US" sz="750" b="0" i="0" dirty="0">
+                <a:solidFill>
+                  <a:srgbClr val="000000"/>
+                </a:solidFill>
+                <a:latin typeface="Arial"/>
+                <a:ea typeface="Arial"/>
+                <a:cs typeface="Arial"/>
+              </a:rPr>
+              <a:t>parent vehicle</a:t>
+            </a:r>
+          </a:p>
+        </p:txBody>
+      </p:sp>
+      <p:sp>
+        <p:nvSpPr>
+          <p:cNvPr id="33" name="ChildLabel_MA_IDIQ"/>
+          <p:cNvSpPr txBox="1"/>
+          <p:nvPr/>
+        </p:nvSpPr>
+        <p:spPr>
+          <a:xfrm>
+            <a:off x="2227600" y="3849001"/>
+            <a:ext cx="438912" cy="118872"/>
+          </a:xfrm>
+          <a:prstGeom prst="rect">
+            <a:avLst/>
+          </a:prstGeom>
+          <a:noFill/>
+          <a:ln>
+            <a:noFill/>
+          </a:ln>
+        </p:spPr>
+        <p:txBody>
+          <a:bodyPr wrap="square" anchor="ctr" lIns="0" tIns="0" rIns="0" bIns="0"/>
+          <a:lstStyle/>
+          <a:p>
+            <a:pPr algn="l">
+              <a:lnSpc>
+                <a:spcPct val="105000"/>
+              </a:lnSpc>
+              <a:buNone/>
+            </a:pPr>
+            <a:r>
+              <a:rPr lang="en-US" sz="750" b="0" i="1" dirty="0">
+                <a:solidFill>
+                  <a:srgbClr val="7F7F7F"/>
+                </a:solidFill>
+                <a:latin typeface="Arial"/>
+                <a:ea typeface="Arial"/>
+                <a:cs typeface="Arial"/>
+              </a:rPr>
+              <a:t>orders</a:t>
+            </a:r>
+          </a:p>
+        </p:txBody>
+      </p:sp>
+      <p:sp>
+        <p:nvSpPr>
+          <p:cNvPr id="34" name="ChildTail_MA_IDIQ_1"/>
+          <p:cNvSpPr/>
+          <p:nvPr/>
+        </p:nvSpPr>
+        <p:spPr>
+          <a:xfrm>
+            <a:off x="2638309" y="3858145"/>
+            <a:ext cx="2601159" cy="54864"/>
+          </a:xfrm>
+          <a:prstGeom prst="rect">
+            <a:avLst/>
+          </a:prstGeom>
+          <a:noFill/>
+          <a:ln w="9525">
+            <a:solidFill>
+              <a:srgbClr val="7F7F7F"/>
+            </a:solidFill>
+          </a:ln>
+        </p:spPr>
+      </p:sp>
+      <p:sp>
+        <p:nvSpPr>
+          <p:cNvPr id="35" name="ChildTail_MA_IDIQ_2"/>
+          <p:cNvSpPr/>
+          <p:nvPr/>
+        </p:nvSpPr>
+        <p:spPr>
+          <a:xfrm>
+            <a:off x="3505362" y="3949585"/>
+            <a:ext cx="2473382" cy="54864"/>
+          </a:xfrm>
+          <a:prstGeom prst="rect">
+            <a:avLst/>
+          </a:prstGeom>
+          <a:noFill/>
+          <a:ln w="9525">
+            <a:solidFill>
+              <a:srgbClr val="7F7F7F"/>
+            </a:solidFill>
+          </a:ln>
+        </p:spPr>
+      </p:sp>
+      <p:sp>
+        <p:nvSpPr>
+          <p:cNvPr id="36" name="ChildTail_MA_IDIQ_3"/>
+          <p:cNvSpPr/>
+          <p:nvPr/>
+        </p:nvSpPr>
+        <p:spPr>
+          <a:xfrm>
+            <a:off x="4171623" y="4041025"/>
+            <a:ext cx="1825375" cy="54864"/>
+          </a:xfrm>
+          <a:prstGeom prst="rect">
+            <a:avLst/>
+          </a:prstGeom>
+          <a:noFill/>
+          <a:ln w="9525">
+            <a:solidFill>
+              <a:srgbClr val="7F7F7F"/>
+            </a:solidFill>
+          </a:ln>
+        </p:spPr>
+      </p:sp>
+      <p:cxnSp>
+        <p:nvCxnSpPr>
+          <p:cNvPr id="37" name="Trigger_MA_IDIQ"/>
+          <p:cNvCxnSpPr/>
+          <p:nvPr/>
+        </p:nvCxnSpPr>
+        <p:spPr>
+          <a:xfrm>
+            <a:off x="4710109" y="3602113"/>
+            <a:ext cx="1" cy="393192"/>
+          </a:xfrm>
+          <a:prstGeom prst="line">
+            <a:avLst/>
+          </a:prstGeom>
+          <a:ln w="25400">
+            <a:solidFill>
+              <a:srgbClr val="6E91B1"/>
+            </a:solidFill>
+          </a:ln>
+        </p:spPr>
+      </p:cxnSp>
+      <p:cxnSp>
+        <p:nvCxnSpPr>
+          <p:cNvPr id="38" name="RouteToGate_MA_IDIQ"/>
+          <p:cNvCxnSpPr/>
+          <p:nvPr/>
+        </p:nvCxnSpPr>
+        <p:spPr>
+          <a:xfrm>
+            <a:off x="4710109" y="3784993"/>
+            <a:ext cx="1521978" cy="1"/>
+          </a:xfrm>
+          <a:prstGeom prst="line">
+            <a:avLst/>
+          </a:prstGeom>
+          <a:ln w="9525">
+            <a:solidFill>
+              <a:srgbClr val="000000"/>
+            </a:solidFill>
+            <a:tailEnd type="triangle" w="med" len="med"/>
+          </a:ln>
+        </p:spPr>
+      </p:cxnSp>
+      <p:sp>
+        <p:nvSpPr>
+          <p:cNvPr id="39" name="BarLabel_BPA"/>
+          <p:cNvSpPr txBox="1"/>
+          <p:nvPr/>
+        </p:nvSpPr>
+        <p:spPr>
+          <a:xfrm>
+            <a:off x="2227600" y="4232083"/>
+            <a:ext cx="1405538" cy="137160"/>
+          </a:xfrm>
+          <a:prstGeom prst="rect">
+            <a:avLst/>
+          </a:prstGeom>
+          <a:noFill/>
+          <a:ln>
+            <a:noFill/>
+          </a:ln>
+        </p:spPr>
+        <p:txBody>
+          <a:bodyPr wrap="square" anchor="ctr" lIns="0" tIns="0" rIns="0" bIns="0"/>
+          <a:lstStyle/>
+          <a:p>
+            <a:pPr algn="ctr">
+              <a:lnSpc>
+                <a:spcPct val="105000"/>
+              </a:lnSpc>
+              <a:buNone/>
+            </a:pPr>
+            <a:r>
+              <a:rPr lang="en-US" sz="750" b="0" i="0" dirty="0">
+                <a:solidFill>
+                  <a:srgbClr val="000000"/>
+                </a:solidFill>
+                <a:latin typeface="Arial"/>
+                <a:ea typeface="Arial"/>
+                <a:cs typeface="Arial"/>
+              </a:rPr>
+              <a:t>agreement / call period</a:t>
+            </a:r>
+          </a:p>
+        </p:txBody>
+      </p:sp>
+      <p:sp>
+        <p:nvSpPr>
+          <p:cNvPr id="40" name="ChildLabel_BPA"/>
+          <p:cNvSpPr txBox="1"/>
+          <p:nvPr/>
+        </p:nvSpPr>
+        <p:spPr>
+          <a:xfrm>
+            <a:off x="2227600" y="4364671"/>
+            <a:ext cx="438912" cy="118872"/>
+          </a:xfrm>
+          <a:prstGeom prst="rect">
+            <a:avLst/>
+          </a:prstGeom>
+          <a:noFill/>
+          <a:ln>
+            <a:noFill/>
+          </a:ln>
+        </p:spPr>
+        <p:txBody>
+          <a:bodyPr wrap="square" anchor="ctr" lIns="0" tIns="0" rIns="0" bIns="0"/>
+          <a:lstStyle/>
+          <a:p>
+            <a:pPr algn="l">
+              <a:lnSpc>
+                <a:spcPct val="105000"/>
+              </a:lnSpc>
+              <a:buNone/>
+            </a:pPr>
+            <a:r>
+              <a:rPr lang="en-US" sz="750" b="0" i="1" dirty="0">
+                <a:solidFill>
+                  <a:srgbClr val="7F7F7F"/>
+                </a:solidFill>
+                <a:latin typeface="Arial"/>
+                <a:ea typeface="Arial"/>
+                <a:cs typeface="Arial"/>
+              </a:rPr>
+              <a:t>calls</a:t>
+            </a:r>
+          </a:p>
+        </p:txBody>
+      </p:sp>
+      <p:sp>
+        <p:nvSpPr>
+          <p:cNvPr id="41" name="ChildTail_BPA_1"/>
+          <p:cNvSpPr/>
+          <p:nvPr/>
+        </p:nvSpPr>
+        <p:spPr>
+          <a:xfrm>
+            <a:off x="2793466" y="4373815"/>
+            <a:ext cx="2519017" cy="54864"/>
+          </a:xfrm>
+          <a:prstGeom prst="rect">
+            <a:avLst/>
+          </a:prstGeom>
+          <a:noFill/>
+          <a:ln w="9525">
+            <a:solidFill>
+              <a:srgbClr val="7F7F7F"/>
+            </a:solidFill>
+          </a:ln>
+        </p:spPr>
+      </p:sp>
+      <p:sp>
+        <p:nvSpPr>
+          <p:cNvPr id="42" name="ChildTail_BPA_2"/>
+          <p:cNvSpPr/>
+          <p:nvPr/>
+        </p:nvSpPr>
+        <p:spPr>
+          <a:xfrm>
+            <a:off x="3687899" y="4465255"/>
+            <a:ext cx="2217830" cy="54864"/>
+          </a:xfrm>
+          <a:prstGeom prst="rect">
+            <a:avLst/>
+          </a:prstGeom>
+          <a:noFill/>
+          <a:ln w="9525">
+            <a:solidFill>
+              <a:srgbClr val="7F7F7F"/>
+            </a:solidFill>
+          </a:ln>
+        </p:spPr>
+      </p:sp>
+      <p:cxnSp>
+        <p:nvCxnSpPr>
+          <p:cNvPr id="43" name="Trigger_BPA"/>
+          <p:cNvCxnSpPr/>
+          <p:nvPr/>
+        </p:nvCxnSpPr>
+        <p:spPr>
+          <a:xfrm>
+            <a:off x="4491064" y="4117783"/>
+            <a:ext cx="1" cy="393192"/>
+          </a:xfrm>
+          <a:prstGeom prst="line">
+            <a:avLst/>
+          </a:prstGeom>
+          <a:ln w="25400">
+            <a:solidFill>
+              <a:srgbClr val="6E91B1"/>
+            </a:solidFill>
+          </a:ln>
+        </p:spPr>
+      </p:cxnSp>
+      <p:cxnSp>
+        <p:nvCxnSpPr>
+          <p:cNvPr id="44" name="RouteToGate_BPA"/>
+          <p:cNvCxnSpPr/>
+          <p:nvPr/>
+        </p:nvCxnSpPr>
+        <p:spPr>
+          <a:xfrm>
+            <a:off x="4491064" y="4300663"/>
+            <a:ext cx="1741023" cy="1"/>
+          </a:xfrm>
+          <a:prstGeom prst="line">
+            <a:avLst/>
+          </a:prstGeom>
+          <a:ln w="9525">
+            <a:solidFill>
+              <a:srgbClr val="000000"/>
+            </a:solidFill>
+            <a:tailEnd type="triangle" w="med" len="med"/>
+          </a:ln>
+        </p:spPr>
+      </p:cxnSp>
+      <p:sp>
+        <p:nvSpPr>
+          <p:cNvPr id="45" name="BarLabel_OT"/>
+          <p:cNvSpPr txBox="1"/>
+          <p:nvPr/>
+        </p:nvSpPr>
+        <p:spPr>
+          <a:xfrm>
+            <a:off x="2227600" y="4747753"/>
+            <a:ext cx="1925770" cy="137160"/>
+          </a:xfrm>
+          <a:prstGeom prst="rect">
+            <a:avLst/>
+          </a:prstGeom>
+          <a:noFill/>
+          <a:ln>
+            <a:noFill/>
+          </a:ln>
+        </p:spPr>
+        <p:txBody>
+          <a:bodyPr wrap="square" anchor="ctr" lIns="0" tIns="0" rIns="0" bIns="0"/>
+          <a:lstStyle/>
+          <a:p>
+            <a:pPr algn="ctr">
+              <a:lnSpc>
+                <a:spcPct val="105000"/>
+              </a:lnSpc>
+              <a:buNone/>
+            </a:pPr>
+            <a:r>
+              <a:rPr lang="en-US" sz="750" b="0" i="0" dirty="0">
+                <a:solidFill>
+                  <a:srgbClr val="000000"/>
+                </a:solidFill>
+                <a:latin typeface="Arial"/>
+                <a:ea typeface="Arial"/>
+                <a:cs typeface="Arial"/>
+              </a:rPr>
+              <a:t>agreement-specific term</a:t>
+            </a:r>
+          </a:p>
+        </p:txBody>
+      </p:sp>
+      <p:sp>
+        <p:nvSpPr>
+          <p:cNvPr id="46" name="ChildLabel_OT"/>
+          <p:cNvSpPr txBox="1"/>
+          <p:nvPr/>
+        </p:nvSpPr>
+        <p:spPr>
+          <a:xfrm>
+            <a:off x="2227600" y="4880341"/>
+            <a:ext cx="438912" cy="118872"/>
+          </a:xfrm>
+          <a:prstGeom prst="rect">
+            <a:avLst/>
+          </a:prstGeom>
+          <a:noFill/>
+          <a:ln>
+            <a:noFill/>
+          </a:ln>
+        </p:spPr>
+        <p:txBody>
+          <a:bodyPr wrap="square" anchor="ctr" lIns="0" tIns="0" rIns="0" bIns="0"/>
+          <a:lstStyle/>
+          <a:p>
+            <a:pPr algn="l">
+              <a:lnSpc>
+                <a:spcPct val="105000"/>
+              </a:lnSpc>
+              <a:buNone/>
+            </a:pPr>
+            <a:r>
+              <a:rPr lang="en-US" sz="750" b="0" i="1" dirty="0">
+                <a:solidFill>
+                  <a:srgbClr val="7F7F7F"/>
+                </a:solidFill>
+                <a:latin typeface="Arial"/>
+                <a:ea typeface="Arial"/>
+                <a:cs typeface="Arial"/>
+              </a:rPr>
+              <a:t>orders</a:t>
+            </a:r>
+          </a:p>
+        </p:txBody>
+      </p:sp>
+      <p:sp>
+        <p:nvSpPr>
+          <p:cNvPr id="47" name="ChildTail_OT_1"/>
+          <p:cNvSpPr/>
+          <p:nvPr/>
+        </p:nvSpPr>
+        <p:spPr>
+          <a:xfrm>
+            <a:off x="3185921" y="4889485"/>
+            <a:ext cx="2920600" cy="54864"/>
+          </a:xfrm>
+          <a:prstGeom prst="rect">
+            <a:avLst/>
+          </a:prstGeom>
+          <a:noFill/>
+          <a:ln w="9525">
+            <a:solidFill>
+              <a:srgbClr val="7F7F7F"/>
+            </a:solidFill>
+          </a:ln>
+        </p:spPr>
+      </p:sp>
+      <p:cxnSp>
+        <p:nvCxnSpPr>
+          <p:cNvPr id="48" name="Trigger_OT"/>
+          <p:cNvCxnSpPr/>
+          <p:nvPr/>
+        </p:nvCxnSpPr>
+        <p:spPr>
+          <a:xfrm>
+            <a:off x="5266848" y="4633453"/>
+            <a:ext cx="1" cy="393192"/>
+          </a:xfrm>
+          <a:prstGeom prst="line">
+            <a:avLst/>
+          </a:prstGeom>
+          <a:ln w="25400">
+            <a:solidFill>
+              <a:srgbClr val="6E91B1"/>
+            </a:solidFill>
+          </a:ln>
+        </p:spPr>
+      </p:cxnSp>
+      <p:cxnSp>
+        <p:nvCxnSpPr>
+          <p:cNvPr id="49" name="RouteToGate_OT"/>
+          <p:cNvCxnSpPr/>
+          <p:nvPr/>
+        </p:nvCxnSpPr>
+        <p:spPr>
+          <a:xfrm>
+            <a:off x="5266848" y="4816333"/>
+            <a:ext cx="965239" cy="1"/>
+          </a:xfrm>
+          <a:prstGeom prst="line">
+            <a:avLst/>
+          </a:prstGeom>
+          <a:ln w="9525">
+            <a:solidFill>
+              <a:srgbClr val="000000"/>
+            </a:solidFill>
+            <a:tailEnd type="triangle" w="med" len="med"/>
+          </a:ln>
+        </p:spPr>
+      </p:cxnSp>
+      <p:sp>
+        <p:nvSpPr>
+          <p:cNvPr id="50" name="StandaloneDecisionLabel"/>
+          <p:cNvSpPr txBox="1"/>
+          <p:nvPr/>
+        </p:nvSpPr>
+        <p:spPr>
+          <a:xfrm>
+            <a:off x="3824100" y="2845093"/>
+            <a:ext cx="749808" cy="128016"/>
+          </a:xfrm>
+          <a:prstGeom prst="rect">
+            <a:avLst/>
+          </a:prstGeom>
+          <a:noFill/>
+          <a:ln>
+            <a:noFill/>
+          </a:ln>
+        </p:spPr>
+        <p:txBody>
+          <a:bodyPr wrap="square" anchor="ctr" lIns="0" tIns="0" rIns="0" bIns="0"/>
+          <a:lstStyle/>
+          <a:p>
+            <a:pPr algn="ctr">
+              <a:lnSpc>
+                <a:spcPct val="105000"/>
+              </a:lnSpc>
+              <a:buNone/>
+            </a:pPr>
+            <a:r>
+              <a:rPr lang="en-US" sz="700" b="0" i="1" dirty="0">
+                <a:solidFill>
+                  <a:srgbClr val="7F7F7F"/>
+                </a:solidFill>
+                <a:latin typeface="Arial"/>
+                <a:ea typeface="Arial"/>
+                <a:cs typeface="Arial"/>
+              </a:rPr>
+              <a:t>option decision</a:t>
+            </a:r>
+          </a:p>
+        </p:txBody>
+      </p:sp>
+      <p:sp>
+        <p:nvSpPr>
+          <p:cNvPr id="51" name="StandaloneUltimateLabel"/>
+          <p:cNvSpPr txBox="1"/>
+          <p:nvPr/>
+        </p:nvSpPr>
+        <p:spPr>
+          <a:xfrm>
+            <a:off x="4964874" y="2845093"/>
+            <a:ext cx="841248" cy="128016"/>
+          </a:xfrm>
+          <a:prstGeom prst="rect">
+            <a:avLst/>
+          </a:prstGeom>
+          <a:noFill/>
+          <a:ln>
+            <a:noFill/>
+          </a:ln>
+        </p:spPr>
+        <p:txBody>
+          <a:bodyPr wrap="square" anchor="ctr" lIns="0" tIns="0" rIns="0" bIns="0"/>
+          <a:lstStyle/>
+          <a:p>
+            <a:pPr algn="ctr">
+              <a:lnSpc>
+                <a:spcPct val="105000"/>
+              </a:lnSpc>
+              <a:buNone/>
+            </a:pPr>
+            <a:r>
+              <a:rPr lang="en-US" sz="700" b="0" i="1" dirty="0">
+                <a:solidFill>
+                  <a:srgbClr val="7F7F7F"/>
+                </a:solidFill>
+                <a:latin typeface="Arial"/>
+                <a:ea typeface="Arial"/>
+                <a:cs typeface="Arial"/>
+              </a:rPr>
+              <a:t>ultimate end</a:t>
+            </a:r>
+          </a:p>
+        </p:txBody>
+      </p:sp>
+      <p:sp>
+        <p:nvSpPr>
+          <p:cNvPr id="52" name="AddressableBadge"/>
+          <p:cNvSpPr txBox="1"/>
+          <p:nvPr/>
+        </p:nvSpPr>
+        <p:spPr>
+          <a:xfrm>
+            <a:off x="6232087" y="2359152"/>
+            <a:ext cx="1444752" cy="365760"/>
+          </a:xfrm>
+          <a:prstGeom prst="rect">
+            <a:avLst/>
+          </a:prstGeom>
+          <a:solidFill>
+            <a:srgbClr val="3D5972"/>
+          </a:solidFill>
+          <a:ln w="19050">
+            <a:solidFill>
+              <a:srgbClr val="000000"/>
+            </a:solidFill>
+          </a:ln>
+        </p:spPr>
+        <p:txBody>
+          <a:bodyPr wrap="none" anchor="ctr" lIns="45720" tIns="9144" rIns="45720" bIns="9144"/>
+          <a:lstStyle/>
+          <a:p>
+            <a:pPr algn="ctr">
+              <a:lnSpc>
+                <a:spcPct val="100000"/>
+              </a:lnSpc>
+              <a:buNone/>
+            </a:pPr>
+            <a:r>
+              <a:rPr lang="en-US" sz="1400" b="1" dirty="0">
+                <a:solidFill>
+                  <a:srgbClr val="FFFFFF"/>
+                </a:solidFill>
+                <a:latin typeface="Arial"/>
+                <a:ea typeface="Arial"/>
+                <a:cs typeface="Arial"/>
+              </a:rPr>
+              <a:t>ADDRESSABLE?</a:t>
+            </a:r>
+          </a:p>
+        </p:txBody>
+      </p:sp>
+      <p:sp>
+        <p:nvSpPr>
+          <p:cNvPr id="53" name="AddressableGuardrail"/>
+          <p:cNvSpPr txBox="1"/>
+          <p:nvPr/>
+        </p:nvSpPr>
+        <p:spPr>
+          <a:xfrm>
+            <a:off x="6232087" y="2724912"/>
+            <a:ext cx="1444752" cy="2414016"/>
+          </a:xfrm>
+          <a:prstGeom prst="rect">
+            <a:avLst/>
+          </a:prstGeom>
+          <a:solidFill>
+            <a:srgbClr val="B6C8D8"/>
+          </a:solidFill>
+          <a:ln w="12700">
+            <a:solidFill>
+              <a:srgbClr val="000000"/>
+            </a:solidFill>
+          </a:ln>
+        </p:spPr>
+        <p:txBody>
+          <a:bodyPr wrap="square" anchor="t" lIns="114300" tIns="76200" rIns="114300" bIns="76200"/>
+          <a:lstStyle/>
+          <a:p>
+            <a:pPr>
+              <a:lnSpc>
+                <a:spcPct val="105000"/>
+              </a:lnSpc>
+              <a:spcAft>
+                <a:spcPts val="400"/>
+              </a:spcAft>
+              <a:buNone/>
+            </a:pPr>
+            <a:r>
+              <a:rPr lang="en-US" sz="900" b="1" dirty="0">
+                <a:solidFill>
+                  <a:srgbClr val="000000"/>
+                </a:solidFill>
+                <a:latin typeface="Arial"/>
+                <a:ea typeface="Arial"/>
+                <a:cs typeface="Arial"/>
+              </a:rPr>
+              <a:t>Expired does not mean addressable.</a:t>
+            </a:r>
+          </a:p>
+          <a:p>
+            <a:pPr>
+              <a:lnSpc>
+                <a:spcPct val="105000"/>
+              </a:lnSpc>
+              <a:buNone/>
+            </a:pPr>
+            <a:r>
+              <a:rPr lang="en-US" sz="850" b="1" dirty="0">
+                <a:solidFill>
+                  <a:srgbClr val="000000"/>
+                </a:solidFill>
+                <a:latin typeface="Arial"/>
+                <a:ea typeface="Arial"/>
+                <a:cs typeface="Arial"/>
+              </a:rPr>
+              <a:t>1  SUCCESSOR CHECK</a:t>
+            </a:r>
+          </a:p>
+          <a:p>
+            <a:pPr>
+              <a:lnSpc>
+                <a:spcPct val="105000"/>
+              </a:lnSpc>
+              <a:spcAft>
+                <a:spcPts val="300"/>
+              </a:spcAft>
+              <a:buNone/>
+            </a:pPr>
+            <a:r>
+              <a:rPr lang="en-US" sz="850" dirty="0">
+                <a:solidFill>
+                  <a:srgbClr val="000000"/>
+                </a:solidFill>
+                <a:latin typeface="Arial"/>
+                <a:ea typeface="Arial"/>
+                <a:cs typeface="Arial"/>
+              </a:rPr>
+              <a:t>Has a follow-on already been awarded? If yes, classify it as superseded, not overdue.</a:t>
+            </a:r>
+          </a:p>
+          <a:p>
+            <a:pPr>
+              <a:lnSpc>
+                <a:spcPct val="105000"/>
+              </a:lnSpc>
+              <a:buNone/>
+            </a:pPr>
+            <a:r>
+              <a:rPr lang="en-US" sz="850" b="1" dirty="0">
+                <a:solidFill>
+                  <a:srgbClr val="000000"/>
+                </a:solidFill>
+                <a:latin typeface="Arial"/>
+                <a:ea typeface="Arial"/>
+                <a:cs typeface="Arial"/>
+              </a:rPr>
+              <a:t>2  ACCESS CHECK</a:t>
+            </a:r>
+          </a:p>
+          <a:p>
+            <a:pPr>
+              <a:lnSpc>
+                <a:spcPct val="105000"/>
+              </a:lnSpc>
+              <a:buNone/>
+            </a:pPr>
+            <a:r>
+              <a:rPr lang="en-US" sz="850" dirty="0">
+                <a:solidFill>
+                  <a:srgbClr val="000000"/>
+                </a:solidFill>
+                <a:latin typeface="Arial"/>
+                <a:ea typeface="Arial"/>
+                <a:cs typeface="Arial"/>
+              </a:rPr>
+              <a:t>Can the company compete? FAR 16.505 may limit the next order to existing vehicle holders.</a:t>
+            </a:r>
+          </a:p>
+        </p:txBody>
+      </p:sp>
+      <p:graphicFrame>
+        <p:nvGraphicFramePr>
+          <p:cNvPr id="54" name="VehicleClockRules"/>
+          <p:cNvGraphicFramePr>
+            <a:graphicFrameLocks noGrp="1"/>
+          </p:cNvGraphicFramePr>
+          <p:nvPr/>
+        </p:nvGraphicFramePr>
+        <p:xfrm>
+          <a:off x="7804855" y="1371600"/>
+          <a:ext cx="3930586" cy="2766060"/>
+        </p:xfrm>
+        <a:graphic>
+          <a:graphicData uri="http://schemas.openxmlformats.org/drawingml/2006/table">
+            <a:tbl>
+              <a:tblPr firstRow="1" firstCol="1" bandRow="0">
+                <a:tableStyleId>{2D5ABB26-0587-4C30-8999-92F81FD0307C}</a:tableStyleId>
+              </a:tblPr>
+              <a:tblGrid>
+                <a:gridCol w="1051560"/>
+                <a:gridCol w="960120"/>
+                <a:gridCol w="658368"/>
+                <a:gridCol w="1260538"/>
+              </a:tblGrid>
+              <a:tr h="274320">
+                <a:tc>
+                  <a:txBody>
+                    <a:bodyPr anchor="ctr"/>
+                    <a:lstStyle/>
+                    <a:p>
+                      <a:pPr algn="l">
+                        <a:lnSpc>
+                          <a:spcPct val="115000"/>
+                        </a:lnSpc>
+                      </a:pPr>
+                      <a:r>
+                        <a:rPr lang="en-US" sz="750" b="1" dirty="0">
+                          <a:solidFill>
+                            <a:srgbClr val="000000"/>
+                          </a:solidFill>
+                          <a:latin typeface="Arial"/>
+                          <a:ea typeface="Arial"/>
+                          <a:cs typeface="Arial"/>
+                        </a:rPr>
+                        <a:t>Vehicle type</a:t>
+                      </a:r>
+                    </a:p>
+                  </a:txBody>
+                  <a:tcPr marL="45720" marR="45720" marT="45720" marB="45720" anchor="ctr">
+                    <a:lnL>
+                      <a:noFill/>
+                    </a:lnL>
+                    <a:lnR>
+                      <a:noFill/>
+                    </a:lnR>
+                    <a:lnT>
+                      <a:noFill/>
+                    </a:lnT>
+                    <a:lnB w="19050" cap="flat" cmpd="sng" algn="ctr">
+                      <a:solidFill>
+                        <a:srgbClr val="000000"/>
+                      </a:solidFill>
+                      <a:prstDash val="solid"/>
+                    </a:lnB>
+                    <a:noFill/>
+                  </a:tcPr>
+                </a:tc>
+                <a:tc>
+                  <a:txBody>
+                    <a:bodyPr anchor="ctr"/>
+                    <a:lstStyle/>
+                    <a:p>
+                      <a:pPr algn="l">
+                        <a:lnSpc>
+                          <a:spcPct val="115000"/>
+                        </a:lnSpc>
+                      </a:pPr>
+                      <a:r>
+                        <a:rPr lang="en-US" sz="750" b="1" dirty="0">
+                          <a:solidFill>
+                            <a:srgbClr val="000000"/>
+                          </a:solidFill>
+                          <a:latin typeface="Arial"/>
+                          <a:ea typeface="Arial"/>
+                          <a:cs typeface="Arial"/>
+                        </a:rPr>
+                        <a:t>Recompete clock</a:t>
+                      </a:r>
+                    </a:p>
+                  </a:txBody>
+                  <a:tcPr marL="45720" marR="45720" marT="45720" marB="45720" anchor="ctr">
+                    <a:lnL>
+                      <a:noFill/>
+                    </a:lnL>
+                    <a:lnR>
+                      <a:noFill/>
+                    </a:lnR>
+                    <a:lnT>
+                      <a:noFill/>
+                    </a:lnT>
+                    <a:lnB w="19050" cap="flat" cmpd="sng" algn="ctr">
+                      <a:solidFill>
+                        <a:srgbClr val="000000"/>
+                      </a:solidFill>
+                      <a:prstDash val="solid"/>
+                    </a:lnB>
+                    <a:noFill/>
+                  </a:tcPr>
+                </a:tc>
+                <a:tc>
+                  <a:txBody>
+                    <a:bodyPr anchor="ctr"/>
+                    <a:lstStyle/>
+                    <a:p>
+                      <a:pPr algn="ctr">
+                        <a:lnSpc>
+                          <a:spcPct val="115000"/>
+                        </a:lnSpc>
+                      </a:pPr>
+                      <a:r>
+                        <a:rPr lang="en-US" sz="750" b="1" dirty="0">
+                          <a:solidFill>
+                            <a:srgbClr val="000000"/>
+                          </a:solidFill>
+                          <a:latin typeface="Arial"/>
+                          <a:ea typeface="Arial"/>
+                          <a:cs typeface="Arial"/>
+                        </a:rPr>
+                        <a:t>Confidence</a:t>
+                      </a:r>
+                    </a:p>
+                  </a:txBody>
+                  <a:tcPr marL="45720" marR="45720" marT="45720" marB="45720" anchor="ctr">
+                    <a:lnL>
+                      <a:noFill/>
+                    </a:lnL>
+                    <a:lnR>
+                      <a:noFill/>
+                    </a:lnR>
+                    <a:lnT>
+                      <a:noFill/>
+                    </a:lnT>
+                    <a:lnB w="19050" cap="flat" cmpd="sng" algn="ctr">
+                      <a:solidFill>
+                        <a:srgbClr val="000000"/>
+                      </a:solidFill>
+                      <a:prstDash val="solid"/>
+                    </a:lnB>
+                    <a:noFill/>
+                  </a:tcPr>
+                </a:tc>
+                <a:tc>
+                  <a:txBody>
+                    <a:bodyPr anchor="ctr"/>
+                    <a:lstStyle/>
+                    <a:p>
+                      <a:pPr algn="l">
+                        <a:lnSpc>
+                          <a:spcPct val="115000"/>
+                        </a:lnSpc>
+                      </a:pPr>
+                      <a:r>
+                        <a:rPr lang="en-US" sz="750" b="1" dirty="0">
+                          <a:solidFill>
+                            <a:srgbClr val="000000"/>
+                          </a:solidFill>
+                          <a:latin typeface="Arial"/>
+                          <a:ea typeface="Arial"/>
+                          <a:cs typeface="Arial"/>
+                        </a:rPr>
+                        <a:t>Note</a:t>
+                      </a:r>
+                    </a:p>
+                  </a:txBody>
+                  <a:tcPr marL="45720" marR="45720" marT="45720" marB="45720" anchor="ctr">
+                    <a:lnL>
+                      <a:noFill/>
+                    </a:lnL>
+                    <a:lnR>
+                      <a:noFill/>
+                    </a:lnR>
+                    <a:lnT>
+                      <a:noFill/>
+                    </a:lnT>
+                    <a:lnB w="19050" cap="flat" cmpd="sng" algn="ctr">
+                      <a:solidFill>
+                        <a:srgbClr val="000000"/>
+                      </a:solidFill>
+                      <a:prstDash val="solid"/>
+                    </a:lnB>
+                    <a:noFill/>
+                  </a:tcPr>
+                </a:tc>
+              </a:tr>
+              <a:tr h="434340">
+                <a:tc>
+                  <a:txBody>
+                    <a:bodyPr anchor="ctr"/>
+                    <a:lstStyle/>
+                    <a:p>
+                      <a:pPr algn="l">
+                        <a:lnSpc>
+                          <a:spcPct val="115000"/>
+                        </a:lnSpc>
+                      </a:pPr>
+                      <a:r>
+                        <a:rPr lang="en-US" sz="750" b="1" dirty="0">
+                          <a:solidFill>
+                            <a:srgbClr val="000000"/>
+                          </a:solidFill>
+                          <a:latin typeface="Arial"/>
+                          <a:ea typeface="Arial"/>
+                          <a:cs typeface="Arial"/>
+                        </a:rPr>
+                        <a:t>Standalone definitive contract</a:t>
+                      </a:r>
+                    </a:p>
+                  </a:txBody>
+                  <a:tcPr marL="45720" marR="45720" marT="45720" marB="45720" anchor="ctr">
+                    <a:lnL>
+                      <a:noFill/>
+                    </a:lnL>
+                    <a:lnR>
+                      <a:noFill/>
+                    </a:lnR>
+                    <a:lnT>
+                      <a:noFill/>
+                    </a:lnT>
+                    <a:lnB w="12700" cap="flat" cmpd="sng" algn="ctr">
+                      <a:solidFill>
+                        <a:srgbClr val="000000"/>
+                      </a:solidFill>
+                      <a:prstDash val="solid"/>
+                    </a:lnB>
+                    <a:noFill/>
+                  </a:tcPr>
+                </a:tc>
+                <a:tc>
+                  <a:txBody>
+                    <a:bodyPr anchor="ctr"/>
+                    <a:lstStyle/>
+                    <a:p>
+                      <a:pPr algn="l">
+                        <a:lnSpc>
+                          <a:spcPct val="115000"/>
+                        </a:lnSpc>
+                      </a:pPr>
+                      <a:r>
+                        <a:rPr lang="en-US" sz="750" b="0" dirty="0">
+                          <a:solidFill>
+                            <a:srgbClr val="000000"/>
+                          </a:solidFill>
+                          <a:latin typeface="Arial"/>
+                          <a:ea typeface="Arial"/>
+                          <a:cs typeface="Arial"/>
+                        </a:rPr>
+                        <a:t>Current and ultimate completion</a:t>
+                      </a:r>
+                    </a:p>
+                  </a:txBody>
+                  <a:tcPr marL="45720" marR="45720" marT="45720" marB="45720" anchor="ctr">
+                    <a:lnL>
+                      <a:noFill/>
+                    </a:lnL>
+                    <a:lnR>
+                      <a:noFill/>
+                    </a:lnR>
+                    <a:lnT>
+                      <a:noFill/>
+                    </a:lnT>
+                    <a:lnB w="12700" cap="flat" cmpd="sng" algn="ctr">
+                      <a:solidFill>
+                        <a:srgbClr val="000000"/>
+                      </a:solidFill>
+                      <a:prstDash val="solid"/>
+                    </a:lnB>
+                    <a:noFill/>
+                  </a:tcPr>
+                </a:tc>
+                <a:tc>
+                  <a:txBody>
+                    <a:bodyPr anchor="ctr"/>
+                    <a:lstStyle/>
+                    <a:p>
+                      <a:pPr algn="ctr">
+                        <a:lnSpc>
+                          <a:spcPct val="115000"/>
+                        </a:lnSpc>
+                      </a:pPr>
+                      <a:r>
+                        <a:rPr lang="en-US" sz="750" b="0" dirty="0">
+                          <a:solidFill>
+                            <a:srgbClr val="FFFFFF"/>
+                          </a:solidFill>
+                          <a:latin typeface="Arial"/>
+                          <a:ea typeface="Arial"/>
+                          <a:cs typeface="Arial"/>
+                        </a:rPr>
+                        <a:t>High</a:t>
+                      </a:r>
+                    </a:p>
+                  </a:txBody>
+                  <a:tcPr marL="45720" marR="45720" marT="45720" marB="45720" anchor="ctr">
+                    <a:lnL>
+                      <a:noFill/>
+                    </a:lnL>
+                    <a:lnR>
+                      <a:noFill/>
+                    </a:lnR>
+                    <a:lnT>
+                      <a:noFill/>
+                    </a:lnT>
+                    <a:lnB w="12700" cap="flat" cmpd="sng" algn="ctr">
+                      <a:solidFill>
+                        <a:srgbClr val="000000"/>
+                      </a:solidFill>
+                      <a:prstDash val="solid"/>
+                    </a:lnB>
+                    <a:solidFill>
+                      <a:srgbClr val="6E91B1"/>
+                    </a:solidFill>
+                  </a:tcPr>
+                </a:tc>
+                <a:tc>
+                  <a:txBody>
+                    <a:bodyPr anchor="ctr"/>
+                    <a:lstStyle/>
+                    <a:p>
+                      <a:pPr algn="l">
+                        <a:lnSpc>
+                          <a:spcPct val="115000"/>
+                        </a:lnSpc>
+                      </a:pPr>
+                      <a:r>
+                        <a:rPr lang="en-US" sz="750" b="0" dirty="0">
+                          <a:solidFill>
+                            <a:srgbClr val="000000"/>
+                          </a:solidFill>
+                          <a:latin typeface="Arial"/>
+                          <a:ea typeface="Arial"/>
+                          <a:cs typeface="Arial"/>
+                        </a:rPr>
+                        <a:t>Current may be an option decision; ultimate is the outer horizon.</a:t>
+                      </a:r>
+                    </a:p>
+                  </a:txBody>
+                  <a:tcPr marL="45720" marR="45720" marT="45720" marB="45720" anchor="ctr">
+                    <a:lnL>
+                      <a:noFill/>
+                    </a:lnL>
+                    <a:lnR>
+                      <a:noFill/>
+                    </a:lnR>
+                    <a:lnT>
+                      <a:noFill/>
+                    </a:lnT>
+                    <a:lnB w="12700" cap="flat" cmpd="sng" algn="ctr">
+                      <a:solidFill>
+                        <a:srgbClr val="000000"/>
+                      </a:solidFill>
+                      <a:prstDash val="solid"/>
+                    </a:lnB>
+                    <a:noFill/>
+                  </a:tcPr>
+                </a:tc>
+              </a:tr>
+              <a:tr h="662940">
+                <a:tc>
+                  <a:txBody>
+                    <a:bodyPr anchor="ctr"/>
+                    <a:lstStyle/>
+                    <a:p>
+                      <a:pPr algn="l">
+                        <a:lnSpc>
+                          <a:spcPct val="115000"/>
+                        </a:lnSpc>
+                      </a:pPr>
+                      <a:r>
+                        <a:rPr lang="en-US" sz="750" b="1" dirty="0">
+                          <a:solidFill>
+                            <a:srgbClr val="000000"/>
+                          </a:solidFill>
+                          <a:latin typeface="Arial"/>
+                          <a:ea typeface="Arial"/>
+                          <a:cs typeface="Arial"/>
+                        </a:rPr>
+                        <a:t>Indefinite-delivery / indefinite-quantity (IDIQ), single- or multiple-award</a:t>
+                      </a:r>
+                    </a:p>
+                  </a:txBody>
+                  <a:tcPr marL="45720" marR="45720" marT="45720" marB="45720" anchor="ctr">
+                    <a:lnL>
+                      <a:noFill/>
+                    </a:lnL>
+                    <a:lnR>
+                      <a:noFill/>
+                    </a:lnR>
+                    <a:lnT>
+                      <a:noFill/>
+                    </a:lnT>
+                    <a:lnB w="12700" cap="flat" cmpd="sng" algn="ctr">
+                      <a:solidFill>
+                        <a:srgbClr val="000000"/>
+                      </a:solidFill>
+                      <a:prstDash val="solid"/>
+                    </a:lnB>
+                    <a:noFill/>
+                  </a:tcPr>
+                </a:tc>
+                <a:tc>
+                  <a:txBody>
+                    <a:bodyPr anchor="ctr"/>
+                    <a:lstStyle/>
+                    <a:p>
+                      <a:pPr algn="l">
+                        <a:lnSpc>
+                          <a:spcPct val="115000"/>
+                        </a:lnSpc>
+                      </a:pPr>
+                      <a:r>
+                        <a:rPr lang="en-US" sz="750" b="0" dirty="0">
+                          <a:solidFill>
+                            <a:srgbClr val="000000"/>
+                          </a:solidFill>
+                          <a:latin typeface="Arial"/>
+                          <a:ea typeface="Arial"/>
+                          <a:cs typeface="Arial"/>
+                        </a:rPr>
+                        <a:t>Parent last date to order; child end for holders-only work</a:t>
+                      </a:r>
+                    </a:p>
+                  </a:txBody>
+                  <a:tcPr marL="45720" marR="45720" marT="45720" marB="45720" anchor="ctr">
+                    <a:lnL>
+                      <a:noFill/>
+                    </a:lnL>
+                    <a:lnR>
+                      <a:noFill/>
+                    </a:lnR>
+                    <a:lnT>
+                      <a:noFill/>
+                    </a:lnT>
+                    <a:lnB w="12700" cap="flat" cmpd="sng" algn="ctr">
+                      <a:solidFill>
+                        <a:srgbClr val="000000"/>
+                      </a:solidFill>
+                      <a:prstDash val="solid"/>
+                    </a:lnB>
+                    <a:noFill/>
+                  </a:tcPr>
+                </a:tc>
+                <a:tc>
+                  <a:txBody>
+                    <a:bodyPr anchor="ctr"/>
+                    <a:lstStyle/>
+                    <a:p>
+                      <a:pPr algn="ctr">
+                        <a:lnSpc>
+                          <a:spcPct val="115000"/>
+                        </a:lnSpc>
+                      </a:pPr>
+                      <a:r>
+                        <a:rPr lang="en-US" sz="750" b="0" dirty="0">
+                          <a:solidFill>
+                            <a:srgbClr val="FFFFFF"/>
+                          </a:solidFill>
+                          <a:latin typeface="Arial"/>
+                          <a:ea typeface="Arial"/>
+                          <a:cs typeface="Arial"/>
+                        </a:rPr>
+                        <a:t>High (parent)</a:t>
+                      </a:r>
+                    </a:p>
+                  </a:txBody>
+                  <a:tcPr marL="45720" marR="45720" marT="45720" marB="45720" anchor="ctr">
+                    <a:lnL>
+                      <a:noFill/>
+                    </a:lnL>
+                    <a:lnR>
+                      <a:noFill/>
+                    </a:lnR>
+                    <a:lnT>
+                      <a:noFill/>
+                    </a:lnT>
+                    <a:lnB w="12700" cap="flat" cmpd="sng" algn="ctr">
+                      <a:solidFill>
+                        <a:srgbClr val="000000"/>
+                      </a:solidFill>
+                      <a:prstDash val="solid"/>
+                    </a:lnB>
+                    <a:solidFill>
+                      <a:srgbClr val="6E91B1"/>
+                    </a:solidFill>
+                  </a:tcPr>
+                </a:tc>
+                <a:tc>
+                  <a:txBody>
+                    <a:bodyPr anchor="ctr"/>
+                    <a:lstStyle/>
+                    <a:p>
+                      <a:pPr algn="l">
+                        <a:lnSpc>
+                          <a:spcPct val="115000"/>
+                        </a:lnSpc>
+                      </a:pPr>
+                      <a:r>
+                        <a:rPr lang="en-US" sz="750" b="0" dirty="0">
+                          <a:solidFill>
+                            <a:srgbClr val="000000"/>
+                          </a:solidFill>
+                          <a:latin typeface="Arial"/>
+                          <a:ea typeface="Arial"/>
+                          <a:cs typeface="Arial"/>
+                        </a:rPr>
+                        <a:t>Parent governs vehicle; child follow-on may be holders-only.</a:t>
+                      </a:r>
+                    </a:p>
+                  </a:txBody>
+                  <a:tcPr marL="45720" marR="45720" marT="45720" marB="45720" anchor="ctr">
+                    <a:lnL>
+                      <a:noFill/>
+                    </a:lnL>
+                    <a:lnR>
+                      <a:noFill/>
+                    </a:lnR>
+                    <a:lnT>
+                      <a:noFill/>
+                    </a:lnT>
+                    <a:lnB w="12700" cap="flat" cmpd="sng" algn="ctr">
+                      <a:solidFill>
+                        <a:srgbClr val="000000"/>
+                      </a:solidFill>
+                      <a:prstDash val="solid"/>
+                    </a:lnB>
+                    <a:noFill/>
+                  </a:tcPr>
+                </a:tc>
+              </a:tr>
+              <a:tr h="320040">
+                <a:tc>
+                  <a:txBody>
+                    <a:bodyPr anchor="ctr"/>
+                    <a:lstStyle/>
+                    <a:p>
+                      <a:pPr algn="l">
+                        <a:lnSpc>
+                          <a:spcPct val="115000"/>
+                        </a:lnSpc>
+                      </a:pPr>
+                      <a:r>
+                        <a:rPr lang="en-US" sz="750" b="1" dirty="0">
+                          <a:solidFill>
+                            <a:srgbClr val="000000"/>
+                          </a:solidFill>
+                          <a:latin typeface="Arial"/>
+                          <a:ea typeface="Arial"/>
+                          <a:cs typeface="Arial"/>
+                        </a:rPr>
+                        <a:t>Task order or delivery order</a:t>
+                      </a:r>
+                    </a:p>
+                  </a:txBody>
+                  <a:tcPr marL="45720" marR="45720" marT="45720" marB="45720" anchor="ctr">
+                    <a:lnL>
+                      <a:noFill/>
+                    </a:lnL>
+                    <a:lnR>
+                      <a:noFill/>
+                    </a:lnR>
+                    <a:lnT>
+                      <a:noFill/>
+                    </a:lnT>
+                    <a:lnB w="12700" cap="flat" cmpd="sng" algn="ctr">
+                      <a:solidFill>
+                        <a:srgbClr val="000000"/>
+                      </a:solidFill>
+                      <a:prstDash val="solid"/>
+                    </a:lnB>
+                    <a:noFill/>
+                  </a:tcPr>
+                </a:tc>
+                <a:tc>
+                  <a:txBody>
+                    <a:bodyPr anchor="ctr"/>
+                    <a:lstStyle/>
+                    <a:p>
+                      <a:pPr algn="l">
+                        <a:lnSpc>
+                          <a:spcPct val="115000"/>
+                        </a:lnSpc>
+                      </a:pPr>
+                      <a:r>
+                        <a:rPr lang="en-US" sz="750" b="0" dirty="0">
+                          <a:solidFill>
+                            <a:srgbClr val="000000"/>
+                          </a:solidFill>
+                          <a:latin typeface="Arial"/>
+                          <a:ea typeface="Arial"/>
+                          <a:cs typeface="Arial"/>
+                        </a:rPr>
+                        <a:t>Child ultimate completion</a:t>
+                      </a:r>
+                    </a:p>
+                  </a:txBody>
+                  <a:tcPr marL="45720" marR="45720" marT="45720" marB="45720" anchor="ctr">
+                    <a:lnL>
+                      <a:noFill/>
+                    </a:lnL>
+                    <a:lnR>
+                      <a:noFill/>
+                    </a:lnR>
+                    <a:lnT>
+                      <a:noFill/>
+                    </a:lnT>
+                    <a:lnB w="12700" cap="flat" cmpd="sng" algn="ctr">
+                      <a:solidFill>
+                        <a:srgbClr val="000000"/>
+                      </a:solidFill>
+                      <a:prstDash val="solid"/>
+                    </a:lnB>
+                    <a:noFill/>
+                  </a:tcPr>
+                </a:tc>
+                <a:tc>
+                  <a:txBody>
+                    <a:bodyPr anchor="ctr"/>
+                    <a:lstStyle/>
+                    <a:p>
+                      <a:pPr algn="ctr">
+                        <a:lnSpc>
+                          <a:spcPct val="115000"/>
+                        </a:lnSpc>
+                      </a:pPr>
+                      <a:r>
+                        <a:rPr lang="en-US" sz="750" b="0" dirty="0">
+                          <a:solidFill>
+                            <a:srgbClr val="000000"/>
+                          </a:solidFill>
+                          <a:latin typeface="Arial"/>
+                          <a:ea typeface="Arial"/>
+                          <a:cs typeface="Arial"/>
+                        </a:rPr>
+                        <a:t>Medium</a:t>
+                      </a:r>
+                    </a:p>
+                  </a:txBody>
+                  <a:tcPr marL="45720" marR="45720" marT="45720" marB="45720" anchor="ctr">
+                    <a:lnL>
+                      <a:noFill/>
+                    </a:lnL>
+                    <a:lnR>
+                      <a:noFill/>
+                    </a:lnR>
+                    <a:lnT>
+                      <a:noFill/>
+                    </a:lnT>
+                    <a:lnB w="12700" cap="flat" cmpd="sng" algn="ctr">
+                      <a:solidFill>
+                        <a:srgbClr val="000000"/>
+                      </a:solidFill>
+                      <a:prstDash val="solid"/>
+                    </a:lnB>
+                    <a:solidFill>
+                      <a:srgbClr val="B6C8D8"/>
+                    </a:solidFill>
+                  </a:tcPr>
+                </a:tc>
+                <a:tc>
+                  <a:txBody>
+                    <a:bodyPr anchor="ctr"/>
+                    <a:lstStyle/>
+                    <a:p>
+                      <a:pPr algn="l">
+                        <a:lnSpc>
+                          <a:spcPct val="115000"/>
+                        </a:lnSpc>
+                      </a:pPr>
+                      <a:r>
+                        <a:rPr lang="en-US" sz="750" b="0" dirty="0">
+                          <a:solidFill>
+                            <a:srgbClr val="000000"/>
+                          </a:solidFill>
+                          <a:latin typeface="Arial"/>
+                          <a:ea typeface="Arial"/>
+                          <a:cs typeface="Arial"/>
+                        </a:rPr>
+                        <a:t>Follow-on may be holders-only.</a:t>
+                      </a:r>
+                    </a:p>
+                  </a:txBody>
+                  <a:tcPr marL="45720" marR="45720" marT="45720" marB="45720" anchor="ctr">
+                    <a:lnL>
+                      <a:noFill/>
+                    </a:lnL>
+                    <a:lnR>
+                      <a:noFill/>
+                    </a:lnR>
+                    <a:lnT>
+                      <a:noFill/>
+                    </a:lnT>
+                    <a:lnB w="12700" cap="flat" cmpd="sng" algn="ctr">
+                      <a:solidFill>
+                        <a:srgbClr val="000000"/>
+                      </a:solidFill>
+                      <a:prstDash val="solid"/>
+                    </a:lnB>
+                    <a:noFill/>
+                  </a:tcPr>
+                </a:tc>
+              </a:tr>
+              <a:tr h="320040">
+                <a:tc>
+                  <a:txBody>
+                    <a:bodyPr anchor="ctr"/>
+                    <a:lstStyle/>
+                    <a:p>
+                      <a:pPr algn="l">
+                        <a:lnSpc>
+                          <a:spcPct val="115000"/>
+                        </a:lnSpc>
+                      </a:pPr>
+                      <a:r>
+                        <a:rPr lang="en-US" sz="750" b="1" dirty="0">
+                          <a:solidFill>
+                            <a:srgbClr val="000000"/>
+                          </a:solidFill>
+                          <a:latin typeface="Arial"/>
+                          <a:ea typeface="Arial"/>
+                          <a:cs typeface="Arial"/>
+                        </a:rPr>
+                        <a:t>Blanket Purchase Agreement (BPA)</a:t>
+                      </a:r>
+                    </a:p>
+                  </a:txBody>
+                  <a:tcPr marL="45720" marR="45720" marT="45720" marB="45720" anchor="ctr">
+                    <a:lnL>
+                      <a:noFill/>
+                    </a:lnL>
+                    <a:lnR>
+                      <a:noFill/>
+                    </a:lnR>
+                    <a:lnT>
+                      <a:noFill/>
+                    </a:lnT>
+                    <a:lnB w="12700" cap="flat" cmpd="sng" algn="ctr">
+                      <a:solidFill>
+                        <a:srgbClr val="000000"/>
+                      </a:solidFill>
+                      <a:prstDash val="solid"/>
+                    </a:lnB>
+                    <a:noFill/>
+                  </a:tcPr>
+                </a:tc>
+                <a:tc>
+                  <a:txBody>
+                    <a:bodyPr anchor="ctr"/>
+                    <a:lstStyle/>
+                    <a:p>
+                      <a:pPr algn="l">
+                        <a:lnSpc>
+                          <a:spcPct val="115000"/>
+                        </a:lnSpc>
+                      </a:pPr>
+                      <a:r>
+                        <a:rPr lang="en-US" sz="750" b="0" dirty="0">
+                          <a:solidFill>
+                            <a:srgbClr val="000000"/>
+                          </a:solidFill>
+                          <a:latin typeface="Arial"/>
+                          <a:ea typeface="Arial"/>
+                          <a:cs typeface="Arial"/>
+                        </a:rPr>
+                        <a:t>Agreement or call-period logic</a:t>
+                      </a:r>
+                    </a:p>
+                  </a:txBody>
+                  <a:tcPr marL="45720" marR="45720" marT="45720" marB="45720" anchor="ctr">
+                    <a:lnL>
+                      <a:noFill/>
+                    </a:lnL>
+                    <a:lnR>
+                      <a:noFill/>
+                    </a:lnR>
+                    <a:lnT>
+                      <a:noFill/>
+                    </a:lnT>
+                    <a:lnB w="12700" cap="flat" cmpd="sng" algn="ctr">
+                      <a:solidFill>
+                        <a:srgbClr val="000000"/>
+                      </a:solidFill>
+                      <a:prstDash val="solid"/>
+                    </a:lnB>
+                    <a:noFill/>
+                  </a:tcPr>
+                </a:tc>
+                <a:tc>
+                  <a:txBody>
+                    <a:bodyPr anchor="ctr"/>
+                    <a:lstStyle/>
+                    <a:p>
+                      <a:pPr algn="ctr">
+                        <a:lnSpc>
+                          <a:spcPct val="115000"/>
+                        </a:lnSpc>
+                      </a:pPr>
+                      <a:r>
+                        <a:rPr lang="en-US" sz="750" b="0" dirty="0">
+                          <a:solidFill>
+                            <a:srgbClr val="000000"/>
+                          </a:solidFill>
+                          <a:latin typeface="Arial"/>
+                          <a:ea typeface="Arial"/>
+                          <a:cs typeface="Arial"/>
+                        </a:rPr>
+                        <a:t>Medium</a:t>
+                      </a:r>
+                    </a:p>
+                  </a:txBody>
+                  <a:tcPr marL="45720" marR="45720" marT="45720" marB="45720" anchor="ctr">
+                    <a:lnL>
+                      <a:noFill/>
+                    </a:lnL>
+                    <a:lnR>
+                      <a:noFill/>
+                    </a:lnR>
+                    <a:lnT>
+                      <a:noFill/>
+                    </a:lnT>
+                    <a:lnB w="12700" cap="flat" cmpd="sng" algn="ctr">
+                      <a:solidFill>
+                        <a:srgbClr val="000000"/>
+                      </a:solidFill>
+                      <a:prstDash val="solid"/>
+                    </a:lnB>
+                    <a:solidFill>
+                      <a:srgbClr val="B6C8D8"/>
+                    </a:solidFill>
+                  </a:tcPr>
+                </a:tc>
+                <a:tc>
+                  <a:txBody>
+                    <a:bodyPr anchor="ctr"/>
+                    <a:lstStyle/>
+                    <a:p>
+                      <a:pPr algn="l">
+                        <a:lnSpc>
+                          <a:spcPct val="115000"/>
+                        </a:lnSpc>
+                      </a:pPr>
+                      <a:r>
+                        <a:rPr lang="en-US" sz="750" b="0" dirty="0">
+                          <a:solidFill>
+                            <a:srgbClr val="000000"/>
+                          </a:solidFill>
+                          <a:latin typeface="Arial"/>
+                          <a:ea typeface="Arial"/>
+                          <a:cs typeface="Arial"/>
+                        </a:rPr>
+                        <a:t>Inspect parent and call rules.</a:t>
+                      </a:r>
+                    </a:p>
+                  </a:txBody>
+                  <a:tcPr marL="45720" marR="45720" marT="45720" marB="45720" anchor="ctr">
+                    <a:lnL>
+                      <a:noFill/>
+                    </a:lnL>
+                    <a:lnR>
+                      <a:noFill/>
+                    </a:lnR>
+                    <a:lnT>
+                      <a:noFill/>
+                    </a:lnT>
+                    <a:lnB w="12700" cap="flat" cmpd="sng" algn="ctr">
+                      <a:solidFill>
+                        <a:srgbClr val="000000"/>
+                      </a:solidFill>
+                      <a:prstDash val="solid"/>
+                    </a:lnB>
+                    <a:noFill/>
+                  </a:tcPr>
+                </a:tc>
+              </a:tr>
+              <a:tr h="320040">
+                <a:tc>
+                  <a:txBody>
+                    <a:bodyPr anchor="ctr"/>
+                    <a:lstStyle/>
+                    <a:p>
+                      <a:pPr algn="l">
+                        <a:lnSpc>
+                          <a:spcPct val="115000"/>
+                        </a:lnSpc>
+                      </a:pPr>
+                      <a:r>
+                        <a:rPr lang="en-US" sz="750" b="1" dirty="0">
+                          <a:solidFill>
+                            <a:srgbClr val="000000"/>
+                          </a:solidFill>
+                          <a:latin typeface="Arial"/>
+                          <a:ea typeface="Arial"/>
+                          <a:cs typeface="Arial"/>
+                        </a:rPr>
+                        <a:t>Basic Ordering Agreement (BOA)</a:t>
+                      </a:r>
+                    </a:p>
+                  </a:txBody>
+                  <a:tcPr marL="45720" marR="45720" marT="45720" marB="45720" anchor="ctr">
+                    <a:lnL>
+                      <a:noFill/>
+                    </a:lnL>
+                    <a:lnR>
+                      <a:noFill/>
+                    </a:lnR>
+                    <a:lnT>
+                      <a:noFill/>
+                    </a:lnT>
+                    <a:lnB w="12700" cap="flat" cmpd="sng" algn="ctr">
+                      <a:solidFill>
+                        <a:srgbClr val="000000"/>
+                      </a:solidFill>
+                      <a:prstDash val="solid"/>
+                    </a:lnB>
+                    <a:noFill/>
+                  </a:tcPr>
+                </a:tc>
+                <a:tc>
+                  <a:txBody>
+                    <a:bodyPr anchor="ctr"/>
+                    <a:lstStyle/>
+                    <a:p>
+                      <a:pPr algn="l">
+                        <a:lnSpc>
+                          <a:spcPct val="115000"/>
+                        </a:lnSpc>
+                      </a:pPr>
+                      <a:r>
+                        <a:rPr lang="en-US" sz="750" b="0" dirty="0">
+                          <a:solidFill>
+                            <a:srgbClr val="000000"/>
+                          </a:solidFill>
+                          <a:latin typeface="Arial"/>
+                          <a:ea typeface="Arial"/>
+                          <a:cs typeface="Arial"/>
+                        </a:rPr>
+                        <a:t>Nominal agreement end</a:t>
+                      </a:r>
+                    </a:p>
+                  </a:txBody>
+                  <a:tcPr marL="45720" marR="45720" marT="45720" marB="45720" anchor="ctr">
+                    <a:lnL>
+                      <a:noFill/>
+                    </a:lnL>
+                    <a:lnR>
+                      <a:noFill/>
+                    </a:lnR>
+                    <a:lnT>
+                      <a:noFill/>
+                    </a:lnT>
+                    <a:lnB w="12700" cap="flat" cmpd="sng" algn="ctr">
+                      <a:solidFill>
+                        <a:srgbClr val="000000"/>
+                      </a:solidFill>
+                      <a:prstDash val="solid"/>
+                    </a:lnB>
+                    <a:noFill/>
+                  </a:tcPr>
+                </a:tc>
+                <a:tc>
+                  <a:txBody>
+                    <a:bodyPr anchor="ctr"/>
+                    <a:lstStyle/>
+                    <a:p>
+                      <a:pPr algn="ctr">
+                        <a:lnSpc>
+                          <a:spcPct val="115000"/>
+                        </a:lnSpc>
+                      </a:pPr>
+                      <a:r>
+                        <a:rPr lang="en-US" sz="750" b="0" dirty="0">
+                          <a:solidFill>
+                            <a:srgbClr val="000000"/>
+                          </a:solidFill>
+                          <a:latin typeface="Arial"/>
+                          <a:ea typeface="Arial"/>
+                          <a:cs typeface="Arial"/>
+                        </a:rPr>
+                        <a:t>Low</a:t>
+                      </a:r>
+                    </a:p>
+                  </a:txBody>
+                  <a:tcPr marL="45720" marR="45720" marT="45720" marB="45720" anchor="ctr">
+                    <a:lnL>
+                      <a:noFill/>
+                    </a:lnL>
+                    <a:lnR>
+                      <a:noFill/>
+                    </a:lnR>
+                    <a:lnT>
+                      <a:noFill/>
+                    </a:lnT>
+                    <a:lnB w="12700" cap="flat" cmpd="sng" algn="ctr">
+                      <a:solidFill>
+                        <a:srgbClr val="000000"/>
+                      </a:solidFill>
+                      <a:prstDash val="solid"/>
+                    </a:lnB>
+                    <a:solidFill>
+                      <a:srgbClr val="E2E9EF"/>
+                    </a:solidFill>
+                  </a:tcPr>
+                </a:tc>
+                <a:tc>
+                  <a:txBody>
+                    <a:bodyPr anchor="ctr"/>
+                    <a:lstStyle/>
+                    <a:p>
+                      <a:pPr algn="l">
+                        <a:lnSpc>
+                          <a:spcPct val="115000"/>
+                        </a:lnSpc>
+                      </a:pPr>
+                      <a:r>
+                        <a:rPr lang="en-US" sz="750" b="0" dirty="0">
+                          <a:solidFill>
+                            <a:srgbClr val="000000"/>
+                          </a:solidFill>
+                          <a:latin typeface="Arial"/>
+                          <a:ea typeface="Arial"/>
+                          <a:cs typeface="Arial"/>
+                        </a:rPr>
+                        <a:t>Not a contract; not a guaranteed recompete.</a:t>
+                      </a:r>
+                    </a:p>
+                  </a:txBody>
+                  <a:tcPr marL="45720" marR="45720" marT="45720" marB="45720" anchor="ctr">
+                    <a:lnL>
+                      <a:noFill/>
+                    </a:lnL>
+                    <a:lnR>
+                      <a:noFill/>
+                    </a:lnR>
+                    <a:lnT>
+                      <a:noFill/>
+                    </a:lnT>
+                    <a:lnB w="12700" cap="flat" cmpd="sng" algn="ctr">
+                      <a:solidFill>
+                        <a:srgbClr val="000000"/>
+                      </a:solidFill>
+                      <a:prstDash val="solid"/>
+                    </a:lnB>
+                    <a:noFill/>
+                  </a:tcPr>
+                </a:tc>
+              </a:tr>
+              <a:tr h="434340">
+                <a:tc>
+                  <a:txBody>
+                    <a:bodyPr anchor="ctr"/>
+                    <a:lstStyle/>
+                    <a:p>
+                      <a:pPr algn="l">
+                        <a:lnSpc>
+                          <a:spcPct val="115000"/>
+                        </a:lnSpc>
+                      </a:pPr>
+                      <a:r>
+                        <a:rPr lang="en-US" sz="750" b="1" dirty="0">
+                          <a:solidFill>
+                            <a:srgbClr val="000000"/>
+                          </a:solidFill>
+                          <a:latin typeface="Arial"/>
+                          <a:ea typeface="Arial"/>
+                          <a:cs typeface="Arial"/>
+                        </a:rPr>
+                        <a:t>Other Transaction (OT) agreement or order</a:t>
+                      </a:r>
+                    </a:p>
+                  </a:txBody>
+                  <a:tcPr marL="45720" marR="45720" marT="45720" marB="45720" anchor="ctr">
+                    <a:lnL>
+                      <a:noFill/>
+                    </a:lnL>
+                    <a:lnR>
+                      <a:noFill/>
+                    </a:lnR>
+                    <a:lnT>
+                      <a:noFill/>
+                    </a:lnT>
+                    <a:lnB>
+                      <a:noFill/>
+                    </a:lnB>
+                    <a:noFill/>
+                  </a:tcPr>
+                </a:tc>
+                <a:tc>
+                  <a:txBody>
+                    <a:bodyPr anchor="ctr"/>
+                    <a:lstStyle/>
+                    <a:p>
+                      <a:pPr algn="l">
+                        <a:lnSpc>
+                          <a:spcPct val="115000"/>
+                        </a:lnSpc>
+                      </a:pPr>
+                      <a:r>
+                        <a:rPr lang="en-US" sz="750" b="0" dirty="0">
+                          <a:solidFill>
+                            <a:srgbClr val="000000"/>
+                          </a:solidFill>
+                          <a:latin typeface="Arial"/>
+                          <a:ea typeface="Arial"/>
+                          <a:cs typeface="Arial"/>
+                        </a:rPr>
+                        <a:t>Agreement-specific terms</a:t>
+                      </a:r>
+                    </a:p>
+                  </a:txBody>
+                  <a:tcPr marL="45720" marR="45720" marT="45720" marB="45720" anchor="ctr">
+                    <a:lnL>
+                      <a:noFill/>
+                    </a:lnL>
+                    <a:lnR>
+                      <a:noFill/>
+                    </a:lnR>
+                    <a:lnT>
+                      <a:noFill/>
+                    </a:lnT>
+                    <a:lnB>
+                      <a:noFill/>
+                    </a:lnB>
+                    <a:noFill/>
+                  </a:tcPr>
+                </a:tc>
+                <a:tc>
+                  <a:txBody>
+                    <a:bodyPr anchor="ctr"/>
+                    <a:lstStyle/>
+                    <a:p>
+                      <a:pPr algn="ctr">
+                        <a:lnSpc>
+                          <a:spcPct val="115000"/>
+                        </a:lnSpc>
+                      </a:pPr>
+                      <a:r>
+                        <a:rPr lang="en-US" sz="750" b="0" dirty="0">
+                          <a:solidFill>
+                            <a:srgbClr val="000000"/>
+                          </a:solidFill>
+                          <a:latin typeface="Arial"/>
+                          <a:ea typeface="Arial"/>
+                          <a:cs typeface="Arial"/>
+                        </a:rPr>
+                        <a:t>Variable</a:t>
+                      </a:r>
+                    </a:p>
+                  </a:txBody>
+                  <a:tcPr marL="45720" marR="45720" marT="45720" marB="45720" anchor="ctr">
+                    <a:lnL>
+                      <a:noFill/>
+                    </a:lnL>
+                    <a:lnR>
+                      <a:noFill/>
+                    </a:lnR>
+                    <a:lnT>
+                      <a:noFill/>
+                    </a:lnT>
+                    <a:lnB>
+                      <a:noFill/>
+                    </a:lnB>
+                    <a:solidFill>
+                      <a:srgbClr val="F2F2F2"/>
+                    </a:solidFill>
+                  </a:tcPr>
+                </a:tc>
+                <a:tc>
+                  <a:txBody>
+                    <a:bodyPr anchor="ctr"/>
+                    <a:lstStyle/>
+                    <a:p>
+                      <a:pPr algn="l">
+                        <a:lnSpc>
+                          <a:spcPct val="115000"/>
+                        </a:lnSpc>
+                      </a:pPr>
+                      <a:r>
+                        <a:rPr lang="en-US" sz="750" b="0" dirty="0">
+                          <a:solidFill>
+                            <a:srgbClr val="000000"/>
+                          </a:solidFill>
+                          <a:latin typeface="Arial"/>
+                          <a:ea typeface="Arial"/>
+                          <a:cs typeface="Arial"/>
+                        </a:rPr>
+                        <a:t>Read governing agreement; validate externally.</a:t>
+                      </a:r>
+                    </a:p>
+                  </a:txBody>
+                  <a:tcPr marL="45720" marR="45720" marT="45720" marB="45720" anchor="ctr">
+                    <a:lnL>
+                      <a:noFill/>
+                    </a:lnL>
+                    <a:lnR>
+                      <a:noFill/>
+                    </a:lnR>
+                    <a:lnT>
+                      <a:noFill/>
+                    </a:lnT>
+                    <a:lnB>
+                      <a:noFill/>
+                    </a:lnB>
+                    <a:noFill/>
+                  </a:tcPr>
+                </a:tc>
+              </a:tr>
+            </a:tbl>
+          </a:graphicData>
+        </a:graphic>
+      </p:graphicFrame>
+      <p:cxnSp>
+        <p:nvCxnSpPr>
+          <p:cNvPr id="55" name="GateToStateClassification"/>
+          <p:cNvCxnSpPr/>
+          <p:nvPr/>
+        </p:nvCxnSpPr>
+        <p:spPr>
+          <a:xfrm>
+            <a:off x="7676839" y="4754880"/>
+            <a:ext cx="128016" cy="1"/>
+          </a:xfrm>
+          <a:prstGeom prst="line">
+            <a:avLst/>
+          </a:prstGeom>
+          <a:ln w="9525">
+            <a:solidFill>
+              <a:srgbClr val="000000"/>
+            </a:solidFill>
+            <a:tailEnd type="triangle" w="med" len="med"/>
+          </a:ln>
+        </p:spPr>
+      </p:cxnSp>
+      <p:sp>
+        <p:nvSpPr>
+          <p:cNvPr id="56" name="StateHeader"/>
+          <p:cNvSpPr txBox="1"/>
+          <p:nvPr/>
+        </p:nvSpPr>
+        <p:spPr>
+          <a:xfrm>
+            <a:off x="7804855" y="4654296"/>
+            <a:ext cx="3930586" cy="201168"/>
+          </a:xfrm>
+          <a:prstGeom prst="rect">
+            <a:avLst/>
+          </a:prstGeom>
+          <a:solidFill>
+            <a:srgbClr val="F2F2F2"/>
+          </a:solidFill>
+          <a:ln w="12700">
+            <a:solidFill>
+              <a:srgbClr val="000000"/>
+            </a:solidFill>
+          </a:ln>
+        </p:spPr>
+        <p:txBody>
+          <a:bodyPr wrap="square" anchor="ctr" lIns="0" tIns="0" rIns="0" bIns="0"/>
+          <a:lstStyle/>
+          <a:p>
+            <a:pPr algn="ctr">
+              <a:lnSpc>
+                <a:spcPct val="100000"/>
+              </a:lnSpc>
+              <a:buNone/>
+            </a:pPr>
+            <a:r>
+              <a:rPr lang="en-US" sz="850" b="1" dirty="0">
+                <a:solidFill>
+                  <a:srgbClr val="000000"/>
+                </a:solidFill>
+                <a:latin typeface="Arial"/>
+                <a:ea typeface="Arial"/>
+                <a:cs typeface="Arial"/>
+              </a:rPr>
+              <a:t>OPPORTUNITY STATE, AFTER BOTH GATES</a:t>
+            </a:r>
+          </a:p>
+        </p:txBody>
+      </p:sp>
+      <p:sp>
+        <p:nvSpPr>
+          <p:cNvPr id="57" name="StateChip1"/>
+          <p:cNvSpPr txBox="1"/>
+          <p:nvPr/>
+        </p:nvSpPr>
+        <p:spPr>
+          <a:xfrm>
+            <a:off x="7804855" y="4910328"/>
+            <a:ext cx="1273619" cy="201168"/>
+          </a:xfrm>
+          <a:prstGeom prst="rect">
+            <a:avLst/>
+          </a:prstGeom>
+          <a:solidFill>
+            <a:srgbClr val="F2F2F2"/>
+          </a:solidFill>
+          <a:ln w="12700">
+            <a:solidFill>
+              <a:srgbClr val="000000"/>
+            </a:solidFill>
+          </a:ln>
+        </p:spPr>
+        <p:txBody>
+          <a:bodyPr wrap="square" anchor="ctr" lIns="45720" tIns="9144" rIns="45720" bIns="9144"/>
+          <a:lstStyle/>
+          <a:p>
+            <a:pPr algn="ctr">
+              <a:lnSpc>
+                <a:spcPct val="100000"/>
+              </a:lnSpc>
+              <a:buNone/>
+            </a:pPr>
+            <a:r>
+              <a:rPr lang="en-US" sz="850" dirty="0">
+                <a:solidFill>
+                  <a:srgbClr val="000000"/>
+                </a:solidFill>
+                <a:latin typeface="Arial"/>
+                <a:ea typeface="Arial"/>
+                <a:cs typeface="Arial"/>
+              </a:rPr>
+              <a:t>Open now</a:t>
+            </a:r>
+          </a:p>
+        </p:txBody>
+      </p:sp>
+      <p:sp>
+        <p:nvSpPr>
+          <p:cNvPr id="58" name="StateChip2"/>
+          <p:cNvSpPr txBox="1"/>
+          <p:nvPr/>
+        </p:nvSpPr>
+        <p:spPr>
+          <a:xfrm>
+            <a:off x="9133338" y="4910328"/>
+            <a:ext cx="1273619" cy="201168"/>
+          </a:xfrm>
+          <a:prstGeom prst="rect">
+            <a:avLst/>
+          </a:prstGeom>
+          <a:solidFill>
+            <a:srgbClr val="F2F2F2"/>
+          </a:solidFill>
+          <a:ln w="12700">
+            <a:solidFill>
+              <a:srgbClr val="000000"/>
+            </a:solidFill>
+          </a:ln>
+        </p:spPr>
+        <p:txBody>
+          <a:bodyPr wrap="square" anchor="ctr" lIns="45720" tIns="9144" rIns="45720" bIns="9144"/>
+          <a:lstStyle/>
+          <a:p>
+            <a:pPr algn="ctr">
+              <a:lnSpc>
+                <a:spcPct val="100000"/>
+              </a:lnSpc>
+              <a:buNone/>
+            </a:pPr>
+            <a:r>
+              <a:rPr lang="en-US" sz="850" dirty="0">
+                <a:solidFill>
+                  <a:srgbClr val="000000"/>
+                </a:solidFill>
+                <a:latin typeface="Arial"/>
+                <a:ea typeface="Arial"/>
+                <a:cs typeface="Arial"/>
+              </a:rPr>
+              <a:t>Option decision</a:t>
+            </a:r>
+          </a:p>
+        </p:txBody>
+      </p:sp>
+      <p:sp>
+        <p:nvSpPr>
+          <p:cNvPr id="59" name="StateChip3"/>
+          <p:cNvSpPr txBox="1"/>
+          <p:nvPr/>
+        </p:nvSpPr>
+        <p:spPr>
+          <a:xfrm>
+            <a:off x="10461821" y="4910328"/>
+            <a:ext cx="1273619" cy="201168"/>
+          </a:xfrm>
+          <a:prstGeom prst="rect">
+            <a:avLst/>
+          </a:prstGeom>
+          <a:solidFill>
+            <a:srgbClr val="F2F2F2"/>
+          </a:solidFill>
+          <a:ln w="12700">
+            <a:solidFill>
+              <a:srgbClr val="000000"/>
+            </a:solidFill>
+          </a:ln>
+        </p:spPr>
+        <p:txBody>
+          <a:bodyPr wrap="square" anchor="ctr" lIns="45720" tIns="9144" rIns="45720" bIns="9144"/>
+          <a:lstStyle/>
+          <a:p>
+            <a:pPr algn="ctr">
+              <a:lnSpc>
+                <a:spcPct val="100000"/>
+              </a:lnSpc>
+              <a:buNone/>
+            </a:pPr>
+            <a:r>
+              <a:rPr lang="en-US" sz="850" dirty="0">
+                <a:solidFill>
+                  <a:srgbClr val="000000"/>
+                </a:solidFill>
+                <a:latin typeface="Arial"/>
+                <a:ea typeface="Arial"/>
+                <a:cs typeface="Arial"/>
+              </a:rPr>
+              <a:t>Likely upcoming</a:t>
+            </a:r>
+          </a:p>
+        </p:txBody>
+      </p:sp>
+      <p:sp>
+        <p:nvSpPr>
+          <p:cNvPr id="60" name="StateChip4"/>
+          <p:cNvSpPr txBox="1"/>
+          <p:nvPr/>
+        </p:nvSpPr>
+        <p:spPr>
+          <a:xfrm>
+            <a:off x="7804855" y="5138928"/>
+            <a:ext cx="1273619" cy="201168"/>
+          </a:xfrm>
+          <a:prstGeom prst="rect">
+            <a:avLst/>
+          </a:prstGeom>
+          <a:solidFill>
+            <a:srgbClr val="F2F2F2"/>
+          </a:solidFill>
+          <a:ln w="12700">
+            <a:solidFill>
+              <a:srgbClr val="000000"/>
+            </a:solidFill>
+          </a:ln>
+        </p:spPr>
+        <p:txBody>
+          <a:bodyPr wrap="square" anchor="ctr" lIns="45720" tIns="9144" rIns="45720" bIns="9144"/>
+          <a:lstStyle/>
+          <a:p>
+            <a:pPr algn="ctr">
+              <a:lnSpc>
+                <a:spcPct val="100000"/>
+              </a:lnSpc>
+              <a:buNone/>
+            </a:pPr>
+            <a:r>
+              <a:rPr lang="en-US" sz="850" dirty="0">
+                <a:solidFill>
+                  <a:srgbClr val="000000"/>
+                </a:solidFill>
+                <a:latin typeface="Arial"/>
+                <a:ea typeface="Arial"/>
+                <a:cs typeface="Arial"/>
+              </a:rPr>
+              <a:t>Holders-only</a:t>
+            </a:r>
+          </a:p>
+        </p:txBody>
+      </p:sp>
+      <p:sp>
+        <p:nvSpPr>
+          <p:cNvPr id="61" name="StateChip5"/>
+          <p:cNvSpPr txBox="1"/>
+          <p:nvPr/>
+        </p:nvSpPr>
+        <p:spPr>
+          <a:xfrm>
+            <a:off x="9133338" y="5138928"/>
+            <a:ext cx="1273619" cy="201168"/>
+          </a:xfrm>
+          <a:prstGeom prst="rect">
+            <a:avLst/>
+          </a:prstGeom>
+          <a:solidFill>
+            <a:srgbClr val="F2F2F2"/>
+          </a:solidFill>
+          <a:ln w="12700">
+            <a:solidFill>
+              <a:srgbClr val="000000"/>
+            </a:solidFill>
+          </a:ln>
+        </p:spPr>
+        <p:txBody>
+          <a:bodyPr wrap="square" anchor="ctr" lIns="45720" tIns="9144" rIns="45720" bIns="9144"/>
+          <a:lstStyle/>
+          <a:p>
+            <a:pPr algn="ctr">
+              <a:lnSpc>
+                <a:spcPct val="100000"/>
+              </a:lnSpc>
+              <a:buNone/>
+            </a:pPr>
+            <a:r>
+              <a:rPr lang="en-US" sz="850" dirty="0">
+                <a:solidFill>
+                  <a:srgbClr val="000000"/>
+                </a:solidFill>
+                <a:latin typeface="Arial"/>
+                <a:ea typeface="Arial"/>
+                <a:cs typeface="Arial"/>
+              </a:rPr>
+              <a:t>Superseded</a:t>
+            </a:r>
+          </a:p>
+        </p:txBody>
+      </p:sp>
+      <p:sp>
+        <p:nvSpPr>
+          <p:cNvPr id="62" name="StateChip6"/>
+          <p:cNvSpPr txBox="1"/>
+          <p:nvPr/>
+        </p:nvSpPr>
+        <p:spPr>
+          <a:xfrm>
+            <a:off x="10461821" y="5138928"/>
+            <a:ext cx="1273619" cy="201168"/>
+          </a:xfrm>
+          <a:prstGeom prst="rect">
+            <a:avLst/>
+          </a:prstGeom>
+          <a:solidFill>
+            <a:srgbClr val="F2F2F2"/>
+          </a:solidFill>
+          <a:ln w="12700">
+            <a:solidFill>
+              <a:srgbClr val="000000"/>
+            </a:solidFill>
+          </a:ln>
+        </p:spPr>
+        <p:txBody>
+          <a:bodyPr wrap="square" anchor="ctr" lIns="45720" tIns="9144" rIns="45720" bIns="9144"/>
+          <a:lstStyle/>
+          <a:p>
+            <a:pPr algn="ctr">
+              <a:lnSpc>
+                <a:spcPct val="100000"/>
+              </a:lnSpc>
+              <a:buNone/>
+            </a:pPr>
+            <a:r>
+              <a:rPr lang="en-US" sz="850" dirty="0">
+                <a:solidFill>
+                  <a:srgbClr val="000000"/>
+                </a:solidFill>
+                <a:latin typeface="Arial"/>
+                <a:ea typeface="Arial"/>
+                <a:cs typeface="Arial"/>
+              </a:rPr>
+              <a:t>Research required</a:t>
+            </a:r>
+          </a:p>
+        </p:txBody>
+      </p:sp>
+      <p:cxnSp>
+        <p:nvCxnSpPr>
+          <p:cNvPr id="63" name="CaveatRailRule"/>
+          <p:cNvCxnSpPr/>
+          <p:nvPr/>
+        </p:nvCxnSpPr>
+        <p:spPr>
+          <a:xfrm>
+            <a:off x="453079" y="5394960"/>
+            <a:ext cx="11282362" cy="1"/>
+          </a:xfrm>
+          <a:prstGeom prst="line">
+            <a:avLst/>
+          </a:prstGeom>
+          <a:ln w="9525">
+            <a:solidFill>
+              <a:srgbClr val="000000"/>
+            </a:solidFill>
+          </a:ln>
+        </p:spPr>
+      </p:cxnSp>
+      <p:sp>
+        <p:nvSpPr>
+          <p:cNvPr id="64" name="CaveatRail"/>
+          <p:cNvSpPr txBox="1"/>
+          <p:nvPr/>
+        </p:nvSpPr>
+        <p:spPr>
+          <a:xfrm>
+            <a:off x="453079" y="5422392"/>
+            <a:ext cx="11282362" cy="438912"/>
+          </a:xfrm>
+          <a:prstGeom prst="rect">
+            <a:avLst/>
+          </a:prstGeom>
+          <a:noFill/>
+          <a:ln>
+            <a:noFill/>
+          </a:ln>
+        </p:spPr>
+        <p:txBody>
+          <a:bodyPr wrap="square" anchor="t" lIns="0" tIns="0" rIns="0" bIns="0"/>
+          <a:lstStyle/>
+          <a:p>
+            <a:pPr>
+              <a:lnSpc>
+                <a:spcPct val="100000"/>
+              </a:lnSpc>
+              <a:buNone/>
+            </a:pPr>
+            <a:r>
+              <a:rPr lang="en-US" sz="1000" b="1" dirty="0">
+                <a:solidFill>
+                  <a:srgbClr val="000000"/>
+                </a:solidFill>
+                <a:latin typeface="Arial"/>
+                <a:ea typeface="Arial"/>
+                <a:cs typeface="Arial"/>
+              </a:rPr>
+              <a:t>Timing is one of four reads; </a:t>
+            </a:r>
+            <a:r>
+              <a:rPr lang="en-US" sz="1000" dirty="0">
+                <a:solidFill>
+                  <a:srgbClr val="000000"/>
+                </a:solidFill>
+                <a:latin typeface="Arial"/>
+                <a:ea typeface="Arial"/>
+                <a:cs typeface="Arial"/>
+              </a:rPr>
+              <a:t>recurrence, authority, competition route, and bidder eligibility remain separate.</a:t>
+            </a:r>
+          </a:p>
+          <a:p>
+            <a:pPr>
+              <a:lnSpc>
+                <a:spcPct val="100000"/>
+              </a:lnSpc>
+              <a:buNone/>
+            </a:pPr>
+            <a:r>
+              <a:rPr lang="en-US" sz="750" dirty="0">
+                <a:solidFill>
+                  <a:srgbClr val="7F7F7F"/>
+                </a:solidFill>
+                <a:latin typeface="Arial"/>
+                <a:ea typeface="Arial"/>
+                <a:cs typeface="Arial"/>
+              </a:rPr>
+              <a:t>Timing confidence varies by vehicle type | A Basic Ordering Agreement (BOA) nominal end is not a guaranteed recompete | A later Procurement Instrument Identifier (PIID) may already be the successor | Option value is capacity, not guaranteed revenue</a:t>
+            </a:r>
+          </a:p>
+        </p:txBody>
+      </p:sp>
+      <p:sp>
+        <p:nvSpPr>
+          <p:cNvPr id="9999" name="Sources"/>
+          <p:cNvSpPr txBox="1"/>
+          <p:nvPr/>
+        </p:nvSpPr>
+        <p:spPr>
+          <a:xfrm>
+            <a:off x="453079" y="5930000"/>
+            <a:ext cx="11282362" cy="540000"/>
+          </a:xfrm>
+          <a:prstGeom prst="rect">
+            <a:avLst/>
+          </a:prstGeom>
+          <a:noFill/>
+          <a:ln>
+            <a:noFill/>
+          </a:ln>
+        </p:spPr>
+        <p:txBody>
+          <a:bodyPr wrap="square" anchor="t" lIns="91440" tIns="45720" rIns="91440" bIns="45720"/>
+          <a:lstStyle/>
+          <a:p>
+            <a:r>
+              <a:rPr lang="en-US" sz="800" kern="1200" dirty="0">
+                <a:solidFill>
+                  <a:srgbClr val="162029"/>
+                </a:solidFill>
+                <a:latin typeface="Arial"/>
+                <a:ea typeface="Arial"/>
+                <a:cs typeface="Arial"/>
+              </a:rPr>
+              <a:t>Sources: SAM.gov Contract Awards API; FAR 16.505, 16.703, 17.207; FPDS and internal Army Market Mapping workbook. Figures illustrative of method; as of 2026-06-22</a:t>
+            </a:r>
+          </a:p>
+        </p:txBody>
+      </p:sp>
+    </p:spTree>
+  </p:cSld>
+  <p:clrMapOvr>
+    <a:masterClrMapping/>
+  </p:clrMapOvr>
+</p:sld>
+</file>
+
+<file path=ppt/slides/slide3.xml><?xml version="1.0" encoding="utf-8"?>
+<p:sld xmlns:a="http://schemas.openxmlformats.org/drawingml/2006/main" xmlns:r="http://schemas.openxmlformats.org/officeDocument/2006/relationships" xmlns:p="http://schemas.openxmlformats.org/presentationml/2006/main">
+  <p:cSld>
+    <p:spTree>
+      <p:nvGrpSpPr>
+        <p:cNvPr id="1" name=""/>
+        <p:cNvGrpSpPr/>
+        <p:nvPr/>
+      </p:nvGrpSpPr>
+      <p:grpSpPr>
+        <a:xfrm>
+          <a:off x="0" y="0"/>
+          <a:ext cx="0" cy="0"/>
+          <a:chOff x="0" y="0"/>
+          <a:chExt cx="0" cy="0"/>
+        </a:xfrm>
+      </p:grpSpPr>
+      <p:sp>
+        <p:nvSpPr>
+          <p:cNvPr id="2" name="Breadcrumb"/>
+          <p:cNvSpPr>
+            <a:spLocks noGrp="1"/>
+          </p:cNvSpPr>
+          <p:nvPr>
+            <p:ph type="body" sz="quarter" idx="10"/>
+          </p:nvPr>
+        </p:nvSpPr>
+        <p:spPr>
+          <a:xfrm>
+            <a:off x="453079" y="263452"/>
+            <a:ext cx="11282362" cy="153888"/>
+          </a:xfrm>
+        </p:spPr>
+        <p:txBody>
+          <a:bodyPr/>
+          <a:lstStyle/>
+          <a:p>
+            <a:r>
+              <a:rPr lang="en-US" sz="1000" b="1" kern="1200" dirty="0">
+                <a:solidFill>
+                  <a:srgbClr val="44505C"/>
+                </a:solidFill>
+                <a:latin typeface="Arial"/>
+                <a:ea typeface="Arial"/>
+                <a:cs typeface="Arial"/>
+              </a:rPr>
+              <a:t>Market Sizing</a:t>
+            </a:r>
+            <a:r>
+              <a:rPr lang="en-US" sz="1000" kern="1200" dirty="0">
+                <a:solidFill>
+                  <a:srgbClr val="44505C"/>
+                </a:solidFill>
+                <a:latin typeface="Arial"/>
+                <a:ea typeface="Arial"/>
+                <a:cs typeface="Arial"/>
+              </a:rPr>
               <a:t> / Obligated and Unobligated Value</a:t>
             </a:r>
           </a:p>
@@ -9268,7 +12844,7 @@
 </p:sld>
 </file>
 
-<file path=ppt/slides/slide3.xml><?xml version="1.0" encoding="utf-8"?>
+<file path=ppt/slides/slide4.xml><?xml version="1.0" encoding="utf-8"?>
 <p:sld xmlns:a="http://schemas.openxmlformats.org/drawingml/2006/main" xmlns:r="http://schemas.openxmlformats.org/officeDocument/2006/relationships" xmlns:p="http://schemas.openxmlformats.org/presentationml/2006/main">
   <p:cSld>
     <p:spTree>
@@ -9753,7 +13329,7 @@
         </p:nvSpPr>
         <p:spPr>
           <a:xfrm>
-            <a:off x="2995111" y="1485900"/>
+            <a:off x="3086551" y="1527048"/>
             <a:ext cx="164592" cy="164592"/>
           </a:xfrm>
           <a:prstGeom prst="ellipse">
@@ -9800,8 +13376,8 @@
         </p:nvSpPr>
         <p:spPr>
           <a:xfrm>
-            <a:off x="3191707" y="1485900"/>
-            <a:ext cx="530352" cy="164592"/>
+            <a:off x="3283147" y="1527048"/>
+            <a:ext cx="749808" cy="164592"/>
           </a:xfrm>
           <a:prstGeom prst="rect">
             <a:avLst/>
@@ -9815,9 +13391,9 @@
           <a:bodyPr wrap="none" anchor="ctr" lIns="0" tIns="0" rIns="0" bIns="0"/>
           <a:lstStyle/>
           <a:p>
-            <a:pPr>
+            <a:pPr algn="l">
               <a:lnSpc>
-                <a:spcPct val="115000"/>
+                <a:spcPct val="100000"/>
               </a:lnSpc>
               <a:buNone/>
             </a:pPr>
@@ -9843,7 +13419,7 @@
         </p:nvSpPr>
         <p:spPr>
           <a:xfrm>
-            <a:off x="4110679" y="1485900"/>
+            <a:off x="4202119" y="1527048"/>
             <a:ext cx="164592" cy="164592"/>
           </a:xfrm>
           <a:prstGeom prst="ellipse">
@@ -9890,8 +13466,8 @@
         </p:nvSpPr>
         <p:spPr>
           <a:xfrm>
-            <a:off x="4307275" y="1485900"/>
-            <a:ext cx="530352" cy="164592"/>
+            <a:off x="4398715" y="1527048"/>
+            <a:ext cx="749808" cy="164592"/>
           </a:xfrm>
           <a:prstGeom prst="rect">
             <a:avLst/>
@@ -9905,9 +13481,9 @@
           <a:bodyPr wrap="none" anchor="ctr" lIns="0" tIns="0" rIns="0" bIns="0"/>
           <a:lstStyle/>
           <a:p>
-            <a:pPr>
+            <a:pPr algn="l">
               <a:lnSpc>
-                <a:spcPct val="115000"/>
+                <a:spcPct val="100000"/>
               </a:lnSpc>
               <a:buNone/>
             </a:pPr>
@@ -9933,7 +13509,7 @@
         </p:nvSpPr>
         <p:spPr>
           <a:xfrm>
-            <a:off x="5226247" y="1485900"/>
+            <a:off x="5317687" y="1527048"/>
             <a:ext cx="164592" cy="164592"/>
           </a:xfrm>
           <a:prstGeom prst="ellipse">
@@ -9980,8 +13556,8 @@
         </p:nvSpPr>
         <p:spPr>
           <a:xfrm>
-            <a:off x="5422843" y="1485900"/>
-            <a:ext cx="530352" cy="164592"/>
+            <a:off x="5514283" y="1527048"/>
+            <a:ext cx="749808" cy="164592"/>
           </a:xfrm>
           <a:prstGeom prst="rect">
             <a:avLst/>
@@ -9995,9 +13571,9 @@
           <a:bodyPr wrap="none" anchor="ctr" lIns="0" tIns="0" rIns="0" bIns="0"/>
           <a:lstStyle/>
           <a:p>
-            <a:pPr>
+            <a:pPr algn="l">
               <a:lnSpc>
-                <a:spcPct val="115000"/>
+                <a:spcPct val="100000"/>
               </a:lnSpc>
               <a:buNone/>
             </a:pPr>
@@ -10023,7 +13599,7 @@
         </p:nvSpPr>
         <p:spPr>
           <a:xfrm>
-            <a:off x="6341815" y="1485900"/>
+            <a:off x="6433255" y="1527048"/>
             <a:ext cx="164592" cy="164592"/>
           </a:xfrm>
           <a:prstGeom prst="ellipse">
@@ -10070,8 +13646,8 @@
         </p:nvSpPr>
         <p:spPr>
           <a:xfrm>
-            <a:off x="6538411" y="1485900"/>
-            <a:ext cx="530352" cy="164592"/>
+            <a:off x="6629851" y="1527048"/>
+            <a:ext cx="749808" cy="164592"/>
           </a:xfrm>
           <a:prstGeom prst="rect">
             <a:avLst/>
@@ -10085,9 +13661,9 @@
           <a:bodyPr wrap="none" anchor="ctr" lIns="0" tIns="0" rIns="0" bIns="0"/>
           <a:lstStyle/>
           <a:p>
-            <a:pPr>
+            <a:pPr algn="l">
               <a:lnSpc>
-                <a:spcPct val="115000"/>
+                <a:spcPct val="100000"/>
               </a:lnSpc>
               <a:buNone/>
             </a:pPr>
@@ -10113,8 +13689,8 @@
         </p:nvSpPr>
         <p:spPr>
           <a:xfrm>
-            <a:off x="2995111" y="1687068"/>
-            <a:ext cx="1024128" cy="315468"/>
+            <a:off x="2995111" y="1741932"/>
+            <a:ext cx="1024128" cy="306324"/>
           </a:xfrm>
           <a:prstGeom prst="rect">
             <a:avLst/>
@@ -10139,7 +13715,7 @@
               <a:buNone/>
             </a:pPr>
             <a:r>
-              <a:rPr lang="en-US" sz="900" b="1" dirty="0">
+              <a:rPr lang="en-US" sz="750" b="1" dirty="0">
                 <a:solidFill>
                   <a:srgbClr val="000000"/>
                 </a:solidFill>
@@ -10158,7 +13734,7 @@
               <a:buNone/>
             </a:pPr>
             <a:r>
-              <a:rPr lang="en-US" sz="725" dirty="0">
+              <a:rPr lang="en-US" sz="650" dirty="0">
                 <a:solidFill>
                   <a:srgbClr val="000000"/>
                 </a:solidFill>
@@ -10179,8 +13755,8 @@
         </p:nvSpPr>
         <p:spPr>
           <a:xfrm>
-            <a:off x="4110679" y="1687068"/>
-            <a:ext cx="1024128" cy="315468"/>
+            <a:off x="4110679" y="1741932"/>
+            <a:ext cx="1024128" cy="306324"/>
           </a:xfrm>
           <a:prstGeom prst="rect">
             <a:avLst/>
@@ -10205,7 +13781,7 @@
               <a:buNone/>
             </a:pPr>
             <a:r>
-              <a:rPr lang="en-US" sz="900" b="1" dirty="0">
+              <a:rPr lang="en-US" sz="750" b="1" dirty="0">
                 <a:solidFill>
                   <a:srgbClr val="000000"/>
                 </a:solidFill>
@@ -10224,7 +13800,7 @@
               <a:buNone/>
             </a:pPr>
             <a:r>
-              <a:rPr lang="en-US" sz="725" dirty="0">
+              <a:rPr lang="en-US" sz="650" dirty="0">
                 <a:solidFill>
                   <a:srgbClr val="000000"/>
                 </a:solidFill>
@@ -10245,8 +13821,8 @@
         </p:nvSpPr>
         <p:spPr>
           <a:xfrm>
-            <a:off x="5226247" y="1687068"/>
-            <a:ext cx="1024128" cy="315468"/>
+            <a:off x="5226247" y="1741932"/>
+            <a:ext cx="1024128" cy="306324"/>
           </a:xfrm>
           <a:prstGeom prst="rect">
             <a:avLst/>
@@ -10271,7 +13847,7 @@
               <a:buNone/>
             </a:pPr>
             <a:r>
-              <a:rPr lang="en-US" sz="900" b="1" dirty="0">
+              <a:rPr lang="en-US" sz="750" b="1" dirty="0">
                 <a:solidFill>
                   <a:srgbClr val="000000"/>
                 </a:solidFill>
@@ -10290,7 +13866,7 @@
               <a:buNone/>
             </a:pPr>
             <a:r>
-              <a:rPr lang="en-US" sz="725" dirty="0">
+              <a:rPr lang="en-US" sz="650" dirty="0">
                 <a:solidFill>
                   <a:srgbClr val="000000"/>
                 </a:solidFill>
@@ -10311,8 +13887,8 @@
         </p:nvSpPr>
         <p:spPr>
           <a:xfrm>
-            <a:off x="6341815" y="1687068"/>
-            <a:ext cx="1024128" cy="315468"/>
+            <a:off x="6341815" y="1741932"/>
+            <a:ext cx="1024128" cy="306324"/>
           </a:xfrm>
           <a:prstGeom prst="rect">
             <a:avLst/>
@@ -10337,7 +13913,7 @@
               <a:buNone/>
             </a:pPr>
             <a:r>
-              <a:rPr lang="en-US" sz="900" b="1" dirty="0">
+              <a:rPr lang="en-US" sz="750" b="1" dirty="0">
                 <a:solidFill>
                   <a:srgbClr val="000000"/>
                 </a:solidFill>
@@ -10356,7 +13932,7 @@
               <a:buNone/>
             </a:pPr>
             <a:r>
-              <a:rPr lang="en-US" sz="725" dirty="0">
+              <a:rPr lang="en-US" sz="650" dirty="0">
                 <a:solidFill>
                   <a:srgbClr val="000000"/>
                 </a:solidFill>
@@ -10377,8 +13953,8 @@
         </p:nvSpPr>
         <p:spPr>
           <a:xfrm>
-            <a:off x="2995111" y="2039112"/>
-            <a:ext cx="1417320" cy="374904"/>
+            <a:off x="2995111" y="2089404"/>
+            <a:ext cx="1417320" cy="361188"/>
           </a:xfrm>
           <a:prstGeom prst="rect">
             <a:avLst/>
@@ -10443,8 +14019,8 @@
         </p:nvSpPr>
         <p:spPr>
           <a:xfrm>
-            <a:off x="5226247" y="2039112"/>
-            <a:ext cx="1417320" cy="374904"/>
+            <a:off x="5226247" y="2089404"/>
+            <a:ext cx="1417320" cy="361188"/>
           </a:xfrm>
           <a:prstGeom prst="rect">
             <a:avLst/>
@@ -10509,8 +14085,8 @@
         </p:nvCxnSpPr>
         <p:spPr>
           <a:xfrm>
-            <a:off x="3507175" y="2002536"/>
-            <a:ext cx="0" cy="36576"/>
+            <a:off x="3507175" y="2048256"/>
+            <a:ext cx="0" cy="41148"/>
           </a:xfrm>
           <a:prstGeom prst="line">
             <a:avLst/>
@@ -10530,8 +14106,8 @@
         </p:nvCxnSpPr>
         <p:spPr>
           <a:xfrm>
-            <a:off x="3507175" y="2414016"/>
-            <a:ext cx="0" cy="36576"/>
+            <a:off x="3507175" y="2450592"/>
+            <a:ext cx="0" cy="18288"/>
           </a:xfrm>
           <a:prstGeom prst="line">
             <a:avLst/>
@@ -10552,8 +14128,8 @@
         </p:nvCxnSpPr>
         <p:spPr>
           <a:xfrm>
-            <a:off x="4622743" y="2002536"/>
-            <a:ext cx="0" cy="448056"/>
+            <a:off x="4622743" y="2048256"/>
+            <a:ext cx="0" cy="420624"/>
           </a:xfrm>
           <a:prstGeom prst="line">
             <a:avLst/>
@@ -10574,8 +14150,8 @@
         </p:nvCxnSpPr>
         <p:spPr>
           <a:xfrm>
-            <a:off x="5738311" y="2002536"/>
-            <a:ext cx="0" cy="36576"/>
+            <a:off x="5738311" y="2048256"/>
+            <a:ext cx="0" cy="41148"/>
           </a:xfrm>
           <a:prstGeom prst="line">
             <a:avLst/>
@@ -10595,8 +14171,8 @@
         </p:nvCxnSpPr>
         <p:spPr>
           <a:xfrm>
-            <a:off x="5738311" y="2414016"/>
-            <a:ext cx="0" cy="36576"/>
+            <a:off x="5738311" y="2450592"/>
+            <a:ext cx="0" cy="18288"/>
           </a:xfrm>
           <a:prstGeom prst="line">
             <a:avLst/>
@@ -10617,8 +14193,8 @@
         </p:nvCxnSpPr>
         <p:spPr>
           <a:xfrm>
-            <a:off x="6853879" y="2002536"/>
-            <a:ext cx="0" cy="448056"/>
+            <a:off x="6853879" y="2048256"/>
+            <a:ext cx="0" cy="420624"/>
           </a:xfrm>
           <a:prstGeom prst="line">
             <a:avLst/>
@@ -10639,8 +14215,8 @@
         </p:nvSpPr>
         <p:spPr>
           <a:xfrm>
-            <a:off x="544519" y="2450592"/>
-            <a:ext cx="1078992" cy="329184"/>
+            <a:off x="544519" y="2468880"/>
+            <a:ext cx="1078992" cy="310896"/>
           </a:xfrm>
           <a:prstGeom prst="rect">
             <a:avLst/>
@@ -10705,8 +14281,8 @@
         </p:nvSpPr>
         <p:spPr>
           <a:xfrm>
-            <a:off x="1842967" y="2450592"/>
-            <a:ext cx="5285232" cy="329184"/>
+            <a:off x="1842967" y="2468880"/>
+            <a:ext cx="5285232" cy="310896"/>
           </a:xfrm>
           <a:prstGeom prst="rect">
             <a:avLst/>
@@ -10771,7 +14347,7 @@
         </p:nvSpPr>
         <p:spPr>
           <a:xfrm>
-            <a:off x="562807" y="2249424"/>
+            <a:off x="635959" y="2253996"/>
             <a:ext cx="164592" cy="164592"/>
           </a:xfrm>
           <a:prstGeom prst="ellipse">
@@ -10818,8 +14394,8 @@
         </p:nvSpPr>
         <p:spPr>
           <a:xfrm>
-            <a:off x="759403" y="2249424"/>
-            <a:ext cx="530352" cy="164592"/>
+            <a:off x="832555" y="2253996"/>
+            <a:ext cx="749808" cy="164592"/>
           </a:xfrm>
           <a:prstGeom prst="rect">
             <a:avLst/>
@@ -10833,9 +14409,9 @@
           <a:bodyPr wrap="none" anchor="ctr" lIns="0" tIns="0" rIns="0" bIns="0"/>
           <a:lstStyle/>
           <a:p>
-            <a:pPr>
+            <a:pPr algn="l">
               <a:lnSpc>
-                <a:spcPct val="115000"/>
+                <a:spcPct val="100000"/>
               </a:lnSpc>
               <a:buNone/>
             </a:pPr>
@@ -10861,7 +14437,7 @@
         </p:nvSpPr>
         <p:spPr>
           <a:xfrm>
-            <a:off x="1861255" y="2249424"/>
+            <a:off x="1934407" y="2253996"/>
             <a:ext cx="164592" cy="164592"/>
           </a:xfrm>
           <a:prstGeom prst="ellipse">
@@ -10908,8 +14484,8 @@
         </p:nvSpPr>
         <p:spPr>
           <a:xfrm>
-            <a:off x="2057851" y="2249424"/>
-            <a:ext cx="530352" cy="164592"/>
+            <a:off x="2131003" y="2253996"/>
+            <a:ext cx="749808" cy="164592"/>
           </a:xfrm>
           <a:prstGeom prst="rect">
             <a:avLst/>
@@ -10923,9 +14499,9 @@
           <a:bodyPr wrap="none" anchor="ctr" lIns="0" tIns="0" rIns="0" bIns="0"/>
           <a:lstStyle/>
           <a:p>
-            <a:pPr>
+            <a:pPr algn="l">
               <a:lnSpc>
-                <a:spcPct val="115000"/>
+                <a:spcPct val="100000"/>
               </a:lnSpc>
               <a:buNone/>
             </a:pPr>
@@ -10951,7 +14527,7 @@
         </p:nvCxnSpPr>
         <p:spPr>
           <a:xfrm>
-            <a:off x="1623511" y="2615184"/>
+            <a:off x="1623511" y="2624328"/>
             <a:ext cx="219456" cy="0"/>
           </a:xfrm>
           <a:prstGeom prst="line">
@@ -10973,7 +14549,7 @@
         </p:nvSpPr>
         <p:spPr>
           <a:xfrm>
-            <a:off x="7512247" y="2048256"/>
+            <a:off x="7512247" y="2066544"/>
             <a:ext cx="1353312" cy="877824"/>
           </a:xfrm>
           <a:prstGeom prst="rect">
@@ -10999,7 +14575,7 @@
               <a:buNone/>
             </a:pPr>
             <a:r>
-              <a:rPr lang="en-US" sz="1400" b="1" dirty="0">
+              <a:rPr lang="en-US" sz="1325" b="1" dirty="0">
                 <a:solidFill>
                   <a:srgbClr val="FFFFFF"/>
                 </a:solidFill>
@@ -11018,7 +14594,7 @@
               <a:buNone/>
             </a:pPr>
             <a:r>
-              <a:rPr lang="en-US" sz="1600" b="1" dirty="0">
+              <a:rPr lang="en-US" sz="1500" b="1" dirty="0">
                 <a:solidFill>
                   <a:srgbClr val="FFFFFF"/>
                 </a:solidFill>
@@ -11037,7 +14613,7 @@
               <a:buNone/>
             </a:pPr>
             <a:r>
-              <a:rPr lang="en-US" sz="625" dirty="0">
+              <a:rPr lang="en-US" sz="560" dirty="0">
                 <a:solidFill>
                   <a:srgbClr val="FFFFFF"/>
                 </a:solidFill>
@@ -11058,7 +14634,7 @@
         </p:nvSpPr>
         <p:spPr>
           <a:xfrm>
-            <a:off x="7640263" y="1847088"/>
+            <a:off x="7621975" y="1851660"/>
             <a:ext cx="164592" cy="164592"/>
           </a:xfrm>
           <a:prstGeom prst="ellipse">
@@ -11105,8 +14681,8 @@
         </p:nvSpPr>
         <p:spPr>
           <a:xfrm>
-            <a:off x="7836859" y="1847088"/>
-            <a:ext cx="530352" cy="164592"/>
+            <a:off x="7818571" y="1851660"/>
+            <a:ext cx="749808" cy="164592"/>
           </a:xfrm>
           <a:prstGeom prst="rect">
             <a:avLst/>
@@ -11120,9 +14696,9 @@
           <a:bodyPr wrap="none" anchor="ctr" lIns="0" tIns="0" rIns="0" bIns="0"/>
           <a:lstStyle/>
           <a:p>
-            <a:pPr>
+            <a:pPr algn="l">
               <a:lnSpc>
-                <a:spcPct val="115000"/>
+                <a:spcPct val="100000"/>
               </a:lnSpc>
               <a:buNone/>
             </a:pPr>
@@ -11148,7 +14724,7 @@
         </p:nvCxnSpPr>
         <p:spPr>
           <a:xfrm>
-            <a:off x="7128199" y="2615184"/>
+            <a:off x="7128199" y="2624328"/>
             <a:ext cx="384048" cy="0"/>
           </a:xfrm>
           <a:prstGeom prst="line">
@@ -11170,8 +14746,8 @@
         </p:nvSpPr>
         <p:spPr>
           <a:xfrm>
-            <a:off x="4769047" y="2779776"/>
-            <a:ext cx="2468880" cy="219456"/>
+            <a:off x="4769047" y="2788920"/>
+            <a:ext cx="2468880" cy="201168"/>
           </a:xfrm>
           <a:prstGeom prst="rect">
             <a:avLst/>
@@ -11240,7 +14816,7 @@
         <p:spPr>
           <a:xfrm>
             <a:off x="9249607" y="1527048"/>
-            <a:ext cx="2412682" cy="402336"/>
+            <a:ext cx="2412682" cy="429768"/>
           </a:xfrm>
           <a:prstGeom prst="rect">
             <a:avLst/>
@@ -11254,7 +14830,7 @@
           </a:ln>
         </p:spPr>
         <p:txBody>
-          <a:bodyPr wrap="square" anchor="t" lIns="60000" tIns="35000" rIns="60000" bIns="35000"/>
+          <a:bodyPr wrap="square" anchor="t" lIns="40000" tIns="18000" rIns="40000" bIns="18000"/>
           <a:lstStyle/>
           <a:p>
             <a:pPr algn="l">
@@ -11264,7 +14840,7 @@
               <a:buNone/>
             </a:pPr>
             <a:r>
-              <a:rPr lang="en-US" sz="775" b="1" dirty="0">
+              <a:rPr lang="en-US" sz="750" b="1" dirty="0">
                 <a:solidFill>
                   <a:srgbClr val="7F7F7F"/>
                 </a:solidFill>
@@ -11304,7 +14880,7 @@
         </p:nvCxnSpPr>
         <p:spPr>
           <a:xfrm flipH="1">
-            <a:off x="8188903" y="1728216"/>
+            <a:off x="8188903" y="1741932"/>
             <a:ext cx="1060704" cy="0"/>
           </a:xfrm>
           <a:prstGeom prst="line">
@@ -11326,8 +14902,8 @@
         </p:nvCxnSpPr>
         <p:spPr>
           <a:xfrm>
-            <a:off x="8188903" y="1728216"/>
-            <a:ext cx="0" cy="320040"/>
+            <a:off x="8188903" y="1741932"/>
+            <a:ext cx="0" cy="324612"/>
           </a:xfrm>
           <a:prstGeom prst="line">
             <a:avLst/>
@@ -11349,7 +14925,7 @@
         </p:nvCxnSpPr>
         <p:spPr>
           <a:xfrm>
-            <a:off x="8865559" y="2487168"/>
+            <a:off x="8865559" y="2505456"/>
             <a:ext cx="164592" cy="0"/>
           </a:xfrm>
           <a:prstGeom prst="line">
@@ -11370,8 +14946,8 @@
         </p:nvCxnSpPr>
         <p:spPr>
           <a:xfrm>
-            <a:off x="9030151" y="2093976"/>
-            <a:ext cx="0" cy="621792"/>
+            <a:off x="9030151" y="2139696"/>
+            <a:ext cx="0" cy="612648"/>
           </a:xfrm>
           <a:prstGeom prst="line">
             <a:avLst/>
@@ -11391,7 +14967,7 @@
         </p:nvSpPr>
         <p:spPr>
           <a:xfrm>
-            <a:off x="9249607" y="1956816"/>
+            <a:off x="9249607" y="2002536"/>
             <a:ext cx="2412682" cy="274320"/>
           </a:xfrm>
           <a:prstGeom prst="rect">
@@ -11417,7 +14993,7 @@
               <a:buNone/>
             </a:pPr>
             <a:r>
-              <a:rPr lang="en-US" sz="800" b="1" dirty="0">
+              <a:rPr lang="en-US" sz="750" b="1" dirty="0">
                 <a:solidFill>
                   <a:srgbClr val="000000"/>
                 </a:solidFill>
@@ -11436,7 +15012,7 @@
               <a:buNone/>
             </a:pPr>
             <a:r>
-              <a:rPr lang="en-US" sz="675" dirty="0">
+              <a:rPr lang="en-US" sz="650" dirty="0">
                 <a:solidFill>
                   <a:srgbClr val="000000"/>
                 </a:solidFill>
@@ -11457,7 +15033,7 @@
         </p:nvSpPr>
         <p:spPr>
           <a:xfrm>
-            <a:off x="9249607" y="2267712"/>
+            <a:off x="9249607" y="2313432"/>
             <a:ext cx="2412682" cy="274320"/>
           </a:xfrm>
           <a:prstGeom prst="rect">
@@ -11483,7 +15059,7 @@
               <a:buNone/>
             </a:pPr>
             <a:r>
-              <a:rPr lang="en-US" sz="800" b="1" dirty="0">
+              <a:rPr lang="en-US" sz="750" b="1" dirty="0">
                 <a:solidFill>
                   <a:srgbClr val="000000"/>
                 </a:solidFill>
@@ -11523,7 +15099,7 @@
         </p:nvSpPr>
         <p:spPr>
           <a:xfrm>
-            <a:off x="9249607" y="2578608"/>
+            <a:off x="9249607" y="2615184"/>
             <a:ext cx="2412682" cy="274320"/>
           </a:xfrm>
           <a:prstGeom prst="rect">
@@ -11549,7 +15125,7 @@
               <a:buNone/>
             </a:pPr>
             <a:r>
-              <a:rPr lang="en-US" sz="800" b="1" dirty="0">
+              <a:rPr lang="en-US" sz="750" b="1" dirty="0">
                 <a:solidFill>
                   <a:srgbClr val="000000"/>
                 </a:solidFill>
@@ -11568,7 +15144,7 @@
               <a:buNone/>
             </a:pPr>
             <a:r>
-              <a:rPr lang="en-US" sz="675" dirty="0">
+              <a:rPr lang="en-US" sz="650" dirty="0">
                 <a:solidFill>
                   <a:srgbClr val="000000"/>
                 </a:solidFill>
@@ -11589,7 +15165,7 @@
         </p:nvCxnSpPr>
         <p:spPr>
           <a:xfrm>
-            <a:off x="9030151" y="2093976"/>
+            <a:off x="9030151" y="2139696"/>
             <a:ext cx="219456" cy="0"/>
           </a:xfrm>
           <a:prstGeom prst="line">
@@ -11611,7 +15187,7 @@
         </p:nvCxnSpPr>
         <p:spPr>
           <a:xfrm>
-            <a:off x="9030151" y="2404872"/>
+            <a:off x="9030151" y="2450592"/>
             <a:ext cx="219456" cy="0"/>
           </a:xfrm>
           <a:prstGeom prst="line">
@@ -11633,7 +15209,7 @@
         </p:nvCxnSpPr>
         <p:spPr>
           <a:xfrm>
-            <a:off x="9030151" y="2715768"/>
+            <a:off x="9030151" y="2752344"/>
             <a:ext cx="219456" cy="0"/>
           </a:xfrm>
           <a:prstGeom prst="line">

</xml_diff>

<commit_message>
Awards methodology deck: rework recompete-timing slide; drop the copy slide
- contracts_recompete_timing: reworked from the swim-lane schematic to a native
  stacked-bar chart timeline with overlays.
- Remove the verbatim copy slide (contracts_recompete_timing_copy); the slide
  registry in __init__.py renumbers 01-04 -> 01-03 accordingly.
- Regenerate deck outputs (.pptx, .pdf, QA slide PNGs).

Co-Authored-By: Claude Opus 4.8 (1M context) <noreply@anthropic.com>
</commit_message>
<xml_diff>
--- a/projects/other/awards_methodology/20260622_Awards Methodology_vS.pptx
+++ b/projects/other/awards_methodology/20260622_Awards Methodology_vS.pptx
@@ -5,13 +5,12 @@
     <p:sldMasterId id="2147483648" r:id="rId1"/>
   </p:sldMasterIdLst>
   <p:handoutMasterIdLst>
-    <p:handoutMasterId r:id="rId6"/>
+    <p:handoutMasterId r:id="rId5"/>
   </p:handoutMasterIdLst>
   <p:sldIdLst>
     <p:sldId id="256" r:id="rId2"/>
     <p:sldId id="257" r:id="rId3"/>
     <p:sldId id="258" r:id="rId4"/>
-    <p:sldId id="259" r:id="rId5"/>
   </p:sldIdLst>
   <p:sldSz cx="12192000" cy="6858000"/>
   <p:notesSz cx="6934200" cy="9220200"/>
@@ -211,9 +210,9 @@
         <c:delete val="0"/>
         <c:axPos val="l"/>
         <c:numFmt formatCode="General" sourceLinked="1"/>
-        <c:majorTickMark val="out"/>
+        <c:majorTickMark val="none"/>
         <c:minorTickMark val="none"/>
-        <c:tickLblPos val="nextTo"/>
+        <c:tickLblPos val="none"/>
         <c:spPr>
           <a:ln w="9525" cap="flat">
             <a:solidFill>
@@ -2888,3732 +2887,6 @@
           </a:p>
         </p:txBody>
       </p:sp>
-      <p:sp>
-        <p:nvSpPr>
-          <p:cNvPr id="10" name="ClockReframe"/>
-          <p:cNvSpPr txBox="1"/>
-          <p:nvPr/>
-        </p:nvSpPr>
-        <p:spPr>
-          <a:xfrm>
-            <a:off x="453079" y="1371600"/>
-            <a:ext cx="7406640" cy="630936"/>
-          </a:xfrm>
-          <a:prstGeom prst="rect">
-            <a:avLst/>
-          </a:prstGeom>
-          <a:noFill/>
-          <a:ln>
-            <a:noFill/>
-          </a:ln>
-        </p:spPr>
-        <p:txBody>
-          <a:bodyPr wrap="square" anchor="t" lIns="0" tIns="0" rIns="0" bIns="0"/>
-          <a:lstStyle/>
-          <a:p>
-            <a:pPr>
-              <a:lnSpc>
-                <a:spcPct val="108000"/>
-              </a:lnSpc>
-              <a:buNone/>
-            </a:pPr>
-            <a:r>
-              <a:rPr lang="en-US" sz="1100" b="1" dirty="0">
-                <a:solidFill>
-                  <a:srgbClr val="000000"/>
-                </a:solidFill>
-                <a:latin typeface="Arial"/>
-                <a:ea typeface="Arial"/>
-                <a:cs typeface="Arial"/>
-              </a:rPr>
-              <a:t>Recompete is when authority to place new orders ends, not when the latest task order ends.</a:t>
-            </a:r>
-          </a:p>
-          <a:p>
-            <a:pPr>
-              <a:lnSpc>
-                <a:spcPct val="108000"/>
-              </a:lnSpc>
-              <a:buNone/>
-            </a:pPr>
-            <a:r>
-              <a:rPr lang="en-US" sz="900" dirty="0">
-                <a:solidFill>
-                  <a:srgbClr val="000000"/>
-                </a:solidFill>
-                <a:latin typeface="Arial"/>
-                <a:ea typeface="Arial"/>
-                <a:cs typeface="Arial"/>
-              </a:rPr>
-              <a:t>For an Indefinite Delivery Vehicle (IDV), the parent's last date to order controls; orders placed during the ordering period can keep performing after it. Reading the latest child-order end as the recompete date is the common false signal.</a:t>
-            </a:r>
-          </a:p>
-        </p:txBody>
-      </p:sp>
-      <p:cxnSp>
-        <p:nvCxnSpPr>
-          <p:cNvPr id="11" name="SectionDivider"/>
-          <p:cNvCxnSpPr/>
-          <p:nvPr/>
-        </p:nvCxnSpPr>
-        <p:spPr>
-          <a:xfrm>
-            <a:off x="7942015" y="1371600"/>
-            <a:ext cx="1" cy="3858768"/>
-          </a:xfrm>
-          <a:prstGeom prst="line">
-            <a:avLst/>
-          </a:prstGeom>
-          <a:ln w="6350">
-            <a:solidFill>
-              <a:srgbClr val="BFBFBF"/>
-            </a:solidFill>
-          </a:ln>
-        </p:spPr>
-      </p:cxnSp>
-      <p:cxnSp>
-        <p:nvCxnSpPr>
-          <p:cNvPr id="12" name="TriggerLegendTick"/>
-          <p:cNvCxnSpPr/>
-          <p:nvPr/>
-        </p:nvCxnSpPr>
-        <p:spPr>
-          <a:xfrm>
-            <a:off x="3580327" y="2093976"/>
-            <a:ext cx="1" cy="164592"/>
-          </a:xfrm>
-          <a:prstGeom prst="line">
-            <a:avLst/>
-          </a:prstGeom>
-          <a:ln w="25400">
-            <a:solidFill>
-              <a:srgbClr val="6E91B1"/>
-            </a:solidFill>
-          </a:ln>
-        </p:spPr>
-      </p:cxnSp>
-      <p:sp>
-        <p:nvSpPr>
-          <p:cNvPr id="13" name="TriggerLegend"/>
-          <p:cNvSpPr txBox="1"/>
-          <p:nvPr/>
-        </p:nvSpPr>
-        <p:spPr>
-          <a:xfrm>
-            <a:off x="3671767" y="2048256"/>
-            <a:ext cx="1069848" cy="256032"/>
-          </a:xfrm>
-          <a:prstGeom prst="rect">
-            <a:avLst/>
-          </a:prstGeom>
-          <a:noFill/>
-          <a:ln>
-            <a:noFill/>
-          </a:ln>
-        </p:spPr>
-        <p:txBody>
-          <a:bodyPr wrap="square" anchor="ctr" lIns="0" tIns="0" rIns="0" bIns="0"/>
-          <a:lstStyle/>
-          <a:p>
-            <a:pPr algn="l">
-              <a:lnSpc>
-                <a:spcPct val="105000"/>
-              </a:lnSpc>
-              <a:buNone/>
-            </a:pPr>
-            <a:r>
-              <a:rPr lang="en-US" sz="800" b="0" i="1" dirty="0">
-                <a:solidFill>
-                  <a:srgbClr val="000000"/>
-                </a:solidFill>
-                <a:latin typeface="Arial"/>
-                <a:ea typeface="Arial"/>
-                <a:cs typeface="Arial"/>
-              </a:rPr>
-              <a:t>last date to order
-(recompete trigger)</a:t>
-            </a:r>
-          </a:p>
-        </p:txBody>
-      </p:sp>
-      <p:sp>
-        <p:nvSpPr>
-          <p:cNvPr id="14" name="TailLegend"/>
-          <p:cNvSpPr txBox="1"/>
-          <p:nvPr/>
-        </p:nvSpPr>
-        <p:spPr>
-          <a:xfrm>
-            <a:off x="4750759" y="2048256"/>
-            <a:ext cx="1444752" cy="329184"/>
-          </a:xfrm>
-          <a:prstGeom prst="rect">
-            <a:avLst/>
-          </a:prstGeom>
-          <a:noFill/>
-          <a:ln>
-            <a:noFill/>
-          </a:ln>
-        </p:spPr>
-        <p:txBody>
-          <a:bodyPr wrap="square" anchor="ctr" lIns="0" tIns="0" rIns="0" bIns="0"/>
-          <a:lstStyle/>
-          <a:p>
-            <a:pPr algn="l">
-              <a:lnSpc>
-                <a:spcPct val="105000"/>
-              </a:lnSpc>
-              <a:buNone/>
-            </a:pPr>
-            <a:r>
-              <a:rPr lang="en-US" sz="750" b="0" i="1" dirty="0">
-                <a:solidFill>
-                  <a:srgbClr val="7F7F7F"/>
-                </a:solidFill>
-                <a:latin typeface="Arial"/>
-                <a:ea typeface="Arial"/>
-                <a:cs typeface="Arial"/>
-              </a:rPr>
-              <a:t>child-order performance tail
-(continues past the trigger)</a:t>
-            </a:r>
-          </a:p>
-        </p:txBody>
-      </p:sp>
-      <p:cxnSp>
-        <p:nvCxnSpPr>
-          <p:cNvPr id="15" name="TimeAxis"/>
-          <p:cNvCxnSpPr/>
-          <p:nvPr/>
-        </p:nvCxnSpPr>
-        <p:spPr>
-          <a:xfrm>
-            <a:off x="2227015" y="2395728"/>
-            <a:ext cx="3877056" cy="1"/>
-          </a:xfrm>
-          <a:prstGeom prst="line">
-            <a:avLst/>
-          </a:prstGeom>
-          <a:ln w="9525">
-            <a:solidFill>
-              <a:srgbClr val="000000"/>
-            </a:solidFill>
-            <a:tailEnd type="triangle" w="med" len="med"/>
-          </a:ln>
-        </p:spPr>
-      </p:cxnSp>
-      <p:cxnSp>
-        <p:nvCxnSpPr>
-          <p:cNvPr id="16" name="TodayLine"/>
-          <p:cNvCxnSpPr/>
-          <p:nvPr/>
-        </p:nvCxnSpPr>
-        <p:spPr>
-          <a:xfrm>
-            <a:off x="2227015" y="2368296"/>
-            <a:ext cx="1" cy="2962656"/>
-          </a:xfrm>
-          <a:prstGeom prst="line">
-            <a:avLst/>
-          </a:prstGeom>
-          <a:ln w="6350">
-            <a:solidFill>
-              <a:srgbClr val="BFBFBF"/>
-            </a:solidFill>
-            <a:prstDash val="dash"/>
-          </a:ln>
-        </p:spPr>
-      </p:cxnSp>
-      <p:cxnSp>
-        <p:nvCxnSpPr>
-          <p:cNvPr id="17" name="DecisionHorizonLine"/>
-          <p:cNvCxnSpPr/>
-          <p:nvPr/>
-        </p:nvCxnSpPr>
-        <p:spPr>
-          <a:xfrm>
-            <a:off x="5537143" y="2368296"/>
-            <a:ext cx="1" cy="2962656"/>
-          </a:xfrm>
-          <a:prstGeom prst="line">
-            <a:avLst/>
-          </a:prstGeom>
-          <a:ln w="6350">
-            <a:solidFill>
-              <a:srgbClr val="BFBFBF"/>
-            </a:solidFill>
-            <a:prstDash val="dash"/>
-          </a:ln>
-        </p:spPr>
-      </p:cxnSp>
-      <p:sp>
-        <p:nvSpPr>
-          <p:cNvPr id="18" name="TodayLabel"/>
-          <p:cNvSpPr txBox="1"/>
-          <p:nvPr/>
-        </p:nvSpPr>
-        <p:spPr>
-          <a:xfrm>
-            <a:off x="1989271" y="2176272"/>
-            <a:ext cx="530352" cy="164592"/>
-          </a:xfrm>
-          <a:prstGeom prst="rect">
-            <a:avLst/>
-          </a:prstGeom>
-          <a:noFill/>
-          <a:ln>
-            <a:noFill/>
-          </a:ln>
-        </p:spPr>
-        <p:txBody>
-          <a:bodyPr wrap="square" anchor="ctr" lIns="0" tIns="0" rIns="0" bIns="0"/>
-          <a:lstStyle/>
-          <a:p>
-            <a:pPr algn="ctr">
-              <a:lnSpc>
-                <a:spcPct val="105000"/>
-              </a:lnSpc>
-              <a:buNone/>
-            </a:pPr>
-            <a:r>
-              <a:rPr lang="en-US" sz="800" b="1" i="0" dirty="0">
-                <a:solidFill>
-                  <a:srgbClr val="000000"/>
-                </a:solidFill>
-                <a:latin typeface="Arial"/>
-                <a:ea typeface="Arial"/>
-                <a:cs typeface="Arial"/>
-              </a:rPr>
-              <a:t>TODAY</a:t>
-            </a:r>
-          </a:p>
-        </p:txBody>
-      </p:sp>
-      <p:sp>
-        <p:nvSpPr>
-          <p:cNvPr id="19" name="DecisionHorizonLabel"/>
-          <p:cNvSpPr txBox="1"/>
-          <p:nvPr/>
-        </p:nvSpPr>
-        <p:spPr>
-          <a:xfrm>
-            <a:off x="5116519" y="2414016"/>
-            <a:ext cx="841248" cy="128016"/>
-          </a:xfrm>
-          <a:prstGeom prst="rect">
-            <a:avLst/>
-          </a:prstGeom>
-          <a:noFill/>
-          <a:ln>
-            <a:noFill/>
-          </a:ln>
-        </p:spPr>
-        <p:txBody>
-          <a:bodyPr wrap="square" anchor="ctr" lIns="0" tIns="0" rIns="0" bIns="0"/>
-          <a:lstStyle/>
-          <a:p>
-            <a:pPr algn="ctr">
-              <a:lnSpc>
-                <a:spcPct val="105000"/>
-              </a:lnSpc>
-              <a:buNone/>
-            </a:pPr>
-            <a:r>
-              <a:rPr lang="en-US" sz="750" b="0" i="1" dirty="0">
-                <a:solidFill>
-                  <a:srgbClr val="7F7F7F"/>
-                </a:solidFill>
-                <a:latin typeface="Arial"/>
-                <a:ea typeface="Arial"/>
-                <a:cs typeface="Arial"/>
-              </a:rPr>
-              <a:t>decision horizon</a:t>
-            </a:r>
-          </a:p>
-        </p:txBody>
-      </p:sp>
-      <p:cxnSp>
-        <p:nvCxnSpPr>
-          <p:cNvPr id="20" name="LaneSeparator"/>
-          <p:cNvCxnSpPr/>
-          <p:nvPr/>
-        </p:nvCxnSpPr>
-        <p:spPr>
-          <a:xfrm>
-            <a:off x="453079" y="2980944"/>
-            <a:ext cx="5779008" cy="1"/>
-          </a:xfrm>
-          <a:prstGeom prst="line">
-            <a:avLst/>
-          </a:prstGeom>
-          <a:ln w="3175">
-            <a:solidFill>
-              <a:srgbClr val="D9D9D9"/>
-            </a:solidFill>
-          </a:ln>
-        </p:spPr>
-      </p:cxnSp>
-      <p:cxnSp>
-        <p:nvCxnSpPr>
-          <p:cNvPr id="21" name="LaneSeparator"/>
-          <p:cNvCxnSpPr/>
-          <p:nvPr/>
-        </p:nvCxnSpPr>
-        <p:spPr>
-          <a:xfrm>
-            <a:off x="453079" y="3502152"/>
-            <a:ext cx="5779008" cy="1"/>
-          </a:xfrm>
-          <a:prstGeom prst="line">
-            <a:avLst/>
-          </a:prstGeom>
-          <a:ln w="3175">
-            <a:solidFill>
-              <a:srgbClr val="D9D9D9"/>
-            </a:solidFill>
-          </a:ln>
-        </p:spPr>
-      </p:cxnSp>
-      <p:cxnSp>
-        <p:nvCxnSpPr>
-          <p:cNvPr id="22" name="LaneSeparator"/>
-          <p:cNvCxnSpPr/>
-          <p:nvPr/>
-        </p:nvCxnSpPr>
-        <p:spPr>
-          <a:xfrm>
-            <a:off x="453079" y="4023360"/>
-            <a:ext cx="5779008" cy="1"/>
-          </a:xfrm>
-          <a:prstGeom prst="line">
-            <a:avLst/>
-          </a:prstGeom>
-          <a:ln w="3175">
-            <a:solidFill>
-              <a:srgbClr val="D9D9D9"/>
-            </a:solidFill>
-          </a:ln>
-        </p:spPr>
-      </p:cxnSp>
-      <p:cxnSp>
-        <p:nvCxnSpPr>
-          <p:cNvPr id="23" name="LaneSeparator"/>
-          <p:cNvCxnSpPr/>
-          <p:nvPr/>
-        </p:nvCxnSpPr>
-        <p:spPr>
-          <a:xfrm>
-            <a:off x="453079" y="4544568"/>
-            <a:ext cx="5779008" cy="1"/>
-          </a:xfrm>
-          <a:prstGeom prst="line">
-            <a:avLst/>
-          </a:prstGeom>
-          <a:ln w="3175">
-            <a:solidFill>
-              <a:srgbClr val="D9D9D9"/>
-            </a:solidFill>
-          </a:ln>
-        </p:spPr>
-      </p:cxnSp>
-      <p:cxnSp>
-        <p:nvCxnSpPr>
-          <p:cNvPr id="24" name="LaneSeparator"/>
-          <p:cNvCxnSpPr/>
-          <p:nvPr/>
-        </p:nvCxnSpPr>
-        <p:spPr>
-          <a:xfrm>
-            <a:off x="453079" y="5065776"/>
-            <a:ext cx="5779008" cy="1"/>
-          </a:xfrm>
-          <a:prstGeom prst="line">
-            <a:avLst/>
-          </a:prstGeom>
-          <a:ln w="3175">
-            <a:solidFill>
-              <a:srgbClr val="D9D9D9"/>
-            </a:solidFill>
-          </a:ln>
-        </p:spPr>
-      </p:cxnSp>
-      <p:sp>
-        <p:nvSpPr>
-          <p:cNvPr id="25" name="LaneLabel"/>
-          <p:cNvSpPr txBox="1"/>
-          <p:nvPr/>
-        </p:nvSpPr>
-        <p:spPr>
-          <a:xfrm>
-            <a:off x="453079" y="2523744"/>
-            <a:ext cx="1627632" cy="457200"/>
-          </a:xfrm>
-          <a:prstGeom prst="rect">
-            <a:avLst/>
-          </a:prstGeom>
-          <a:noFill/>
-          <a:ln>
-            <a:noFill/>
-          </a:ln>
-        </p:spPr>
-        <p:txBody>
-          <a:bodyPr wrap="square" anchor="ctr" lIns="0" tIns="0" rIns="0" bIns="0"/>
-          <a:lstStyle/>
-          <a:p>
-            <a:pPr algn="l">
-              <a:lnSpc>
-                <a:spcPct val="105000"/>
-              </a:lnSpc>
-              <a:buNone/>
-            </a:pPr>
-            <a:r>
-              <a:rPr lang="en-US" sz="850" b="1" i="0" dirty="0">
-                <a:solidFill>
-                  <a:srgbClr val="000000"/>
-                </a:solidFill>
-                <a:latin typeface="Arial"/>
-                <a:ea typeface="Arial"/>
-                <a:cs typeface="Arial"/>
-              </a:rPr>
-              <a:t>Standalone definitive
-contract</a:t>
-            </a:r>
-          </a:p>
-        </p:txBody>
-      </p:sp>
-      <p:sp>
-        <p:nvSpPr>
-          <p:cNvPr id="26" name="StandaloneBase"/>
-          <p:cNvSpPr txBox="1"/>
-          <p:nvPr/>
-        </p:nvSpPr>
-        <p:spPr>
-          <a:xfrm>
-            <a:off x="2227015" y="2615184"/>
-            <a:ext cx="1975104" cy="137160"/>
-          </a:xfrm>
-          <a:prstGeom prst="rect">
-            <a:avLst/>
-          </a:prstGeom>
-          <a:noFill/>
-          <a:ln w="12700">
-            <a:solidFill>
-              <a:srgbClr val="000000"/>
-            </a:solidFill>
-          </a:ln>
-        </p:spPr>
-        <p:txBody>
-          <a:bodyPr wrap="square" anchor="ctr" lIns="0" tIns="0" rIns="0" bIns="0"/>
-          <a:lstStyle/>
-          <a:p>
-            <a:pPr algn="ctr">
-              <a:lnSpc>
-                <a:spcPct val="100000"/>
-              </a:lnSpc>
-              <a:buNone/>
-            </a:pPr>
-            <a:r>
-              <a:rPr lang="en-US" sz="750" dirty="0">
-                <a:solidFill>
-                  <a:srgbClr val="000000"/>
-                </a:solidFill>
-                <a:latin typeface="Arial"/>
-                <a:ea typeface="Arial"/>
-                <a:cs typeface="Arial"/>
-              </a:rPr>
-              <a:t>base term</a:t>
-            </a:r>
-          </a:p>
-        </p:txBody>
-      </p:sp>
-      <p:sp>
-        <p:nvSpPr>
-          <p:cNvPr id="27" name="StandaloneOptions"/>
-          <p:cNvSpPr txBox="1"/>
-          <p:nvPr/>
-        </p:nvSpPr>
-        <p:spPr>
-          <a:xfrm>
-            <a:off x="4202119" y="2615184"/>
-            <a:ext cx="1188720" cy="137160"/>
-          </a:xfrm>
-          <a:prstGeom prst="rect">
-            <a:avLst/>
-          </a:prstGeom>
-          <a:noFill/>
-          <a:ln w="12700">
-            <a:solidFill>
-              <a:srgbClr val="000000"/>
-            </a:solidFill>
-            <a:prstDash val="dash"/>
-          </a:ln>
-        </p:spPr>
-        <p:txBody>
-          <a:bodyPr wrap="square" anchor="ctr" lIns="0" tIns="0" rIns="0" bIns="0"/>
-          <a:lstStyle/>
-          <a:p>
-            <a:pPr algn="ctr">
-              <a:lnSpc>
-                <a:spcPct val="100000"/>
-              </a:lnSpc>
-              <a:buNone/>
-            </a:pPr>
-            <a:r>
-              <a:rPr lang="en-US" sz="750" dirty="0">
-                <a:solidFill>
-                  <a:srgbClr val="000000"/>
-                </a:solidFill>
-                <a:latin typeface="Arial"/>
-                <a:ea typeface="Arial"/>
-                <a:cs typeface="Arial"/>
-              </a:rPr>
-              <a:t>option capacity</a:t>
-            </a:r>
-          </a:p>
-        </p:txBody>
-      </p:sp>
-      <p:cxnSp>
-        <p:nvCxnSpPr>
-          <p:cNvPr id="28" name="RecompeteTrigger"/>
-          <p:cNvCxnSpPr/>
-          <p:nvPr/>
-        </p:nvCxnSpPr>
-        <p:spPr>
-          <a:xfrm>
-            <a:off x="4202119" y="2551176"/>
-            <a:ext cx="1" cy="393192"/>
-          </a:xfrm>
-          <a:prstGeom prst="line">
-            <a:avLst/>
-          </a:prstGeom>
-          <a:ln w="25400">
-            <a:solidFill>
-              <a:srgbClr val="6E91B1"/>
-            </a:solidFill>
-          </a:ln>
-        </p:spPr>
-      </p:cxnSp>
-      <p:sp>
-        <p:nvSpPr>
-          <p:cNvPr id="29" name="StandaloneDecisionLabel"/>
-          <p:cNvSpPr txBox="1"/>
-          <p:nvPr/>
-        </p:nvSpPr>
-        <p:spPr>
-          <a:xfrm>
-            <a:off x="3854647" y="2770632"/>
-            <a:ext cx="749808" cy="128016"/>
-          </a:xfrm>
-          <a:prstGeom prst="rect">
-            <a:avLst/>
-          </a:prstGeom>
-          <a:noFill/>
-          <a:ln>
-            <a:noFill/>
-          </a:ln>
-        </p:spPr>
-        <p:txBody>
-          <a:bodyPr wrap="square" anchor="ctr" lIns="0" tIns="0" rIns="0" bIns="0"/>
-          <a:lstStyle/>
-          <a:p>
-            <a:pPr algn="ctr">
-              <a:lnSpc>
-                <a:spcPct val="105000"/>
-              </a:lnSpc>
-              <a:buNone/>
-            </a:pPr>
-            <a:r>
-              <a:rPr lang="en-US" sz="700" b="0" i="1" dirty="0">
-                <a:solidFill>
-                  <a:srgbClr val="7F7F7F"/>
-                </a:solidFill>
-                <a:latin typeface="Arial"/>
-                <a:ea typeface="Arial"/>
-                <a:cs typeface="Arial"/>
-              </a:rPr>
-              <a:t>option decision</a:t>
-            </a:r>
-          </a:p>
-        </p:txBody>
-      </p:sp>
-      <p:sp>
-        <p:nvSpPr>
-          <p:cNvPr id="30" name="StandaloneUltimateLabel"/>
-          <p:cNvSpPr txBox="1"/>
-          <p:nvPr/>
-        </p:nvSpPr>
-        <p:spPr>
-          <a:xfrm>
-            <a:off x="4641031" y="2770632"/>
-            <a:ext cx="841248" cy="128016"/>
-          </a:xfrm>
-          <a:prstGeom prst="rect">
-            <a:avLst/>
-          </a:prstGeom>
-          <a:noFill/>
-          <a:ln>
-            <a:noFill/>
-          </a:ln>
-        </p:spPr>
-        <p:txBody>
-          <a:bodyPr wrap="square" anchor="ctr" lIns="0" tIns="0" rIns="0" bIns="0"/>
-          <a:lstStyle/>
-          <a:p>
-            <a:pPr algn="ctr">
-              <a:lnSpc>
-                <a:spcPct val="105000"/>
-              </a:lnSpc>
-              <a:buNone/>
-            </a:pPr>
-            <a:r>
-              <a:rPr lang="en-US" sz="700" b="0" i="1" dirty="0">
-                <a:solidFill>
-                  <a:srgbClr val="7F7F7F"/>
-                </a:solidFill>
-                <a:latin typeface="Arial"/>
-                <a:ea typeface="Arial"/>
-                <a:cs typeface="Arial"/>
-              </a:rPr>
-              <a:t>ultimate end</a:t>
-            </a:r>
-          </a:p>
-        </p:txBody>
-      </p:sp>
-      <p:cxnSp>
-        <p:nvCxnSpPr>
-          <p:cNvPr id="31" name="StandaloneDrop"/>
-          <p:cNvCxnSpPr/>
-          <p:nvPr/>
-        </p:nvCxnSpPr>
-        <p:spPr>
-          <a:xfrm>
-            <a:off x="4202119" y="2752344"/>
-            <a:ext cx="1" cy="192024"/>
-          </a:xfrm>
-          <a:prstGeom prst="line">
-            <a:avLst/>
-          </a:prstGeom>
-          <a:ln w="9525">
-            <a:solidFill>
-              <a:srgbClr val="000000"/>
-            </a:solidFill>
-          </a:ln>
-        </p:spPr>
-      </p:cxnSp>
-      <p:cxnSp>
-        <p:nvCxnSpPr>
-          <p:cNvPr id="32" name="RouteToAddressableGate"/>
-          <p:cNvCxnSpPr/>
-          <p:nvPr/>
-        </p:nvCxnSpPr>
-        <p:spPr>
-          <a:xfrm>
-            <a:off x="4202119" y="2944368"/>
-            <a:ext cx="2029968" cy="1"/>
-          </a:xfrm>
-          <a:prstGeom prst="line">
-            <a:avLst/>
-          </a:prstGeom>
-          <a:ln w="9525">
-            <a:solidFill>
-              <a:srgbClr val="000000"/>
-            </a:solidFill>
-            <a:tailEnd type="triangle" w="med" len="med"/>
-          </a:ln>
-        </p:spPr>
-      </p:cxnSp>
-      <p:sp>
-        <p:nvSpPr>
-          <p:cNvPr id="33" name="LaneLabel"/>
-          <p:cNvSpPr txBox="1"/>
-          <p:nvPr/>
-        </p:nvSpPr>
-        <p:spPr>
-          <a:xfrm>
-            <a:off x="453079" y="3044952"/>
-            <a:ext cx="1627632" cy="457200"/>
-          </a:xfrm>
-          <a:prstGeom prst="rect">
-            <a:avLst/>
-          </a:prstGeom>
-          <a:noFill/>
-          <a:ln>
-            <a:noFill/>
-          </a:ln>
-        </p:spPr>
-        <p:txBody>
-          <a:bodyPr wrap="square" anchor="ctr" lIns="0" tIns="0" rIns="0" bIns="0"/>
-          <a:lstStyle/>
-          <a:p>
-            <a:pPr algn="l">
-              <a:lnSpc>
-                <a:spcPct val="105000"/>
-              </a:lnSpc>
-              <a:buNone/>
-            </a:pPr>
-            <a:r>
-              <a:rPr lang="en-US" sz="850" b="1" i="0" dirty="0">
-                <a:solidFill>
-                  <a:srgbClr val="000000"/>
-                </a:solidFill>
-                <a:latin typeface="Arial"/>
-                <a:ea typeface="Arial"/>
-                <a:cs typeface="Arial"/>
-              </a:rPr>
-              <a:t>Single-award
-Indefinite-Delivery/
-Indefinite-Quantity (IDIQ)</a:t>
-            </a:r>
-          </a:p>
-        </p:txBody>
-      </p:sp>
-      <p:sp>
-        <p:nvSpPr>
-          <p:cNvPr id="34" name="SAIDIQBase"/>
-          <p:cNvSpPr txBox="1"/>
-          <p:nvPr/>
-        </p:nvSpPr>
-        <p:spPr>
-          <a:xfrm>
-            <a:off x="2227015" y="3118104"/>
-            <a:ext cx="1837944" cy="128016"/>
-          </a:xfrm>
-          <a:prstGeom prst="rect">
-            <a:avLst/>
-          </a:prstGeom>
-          <a:noFill/>
-          <a:ln w="12700">
-            <a:solidFill>
-              <a:srgbClr val="000000"/>
-            </a:solidFill>
-          </a:ln>
-        </p:spPr>
-        <p:txBody>
-          <a:bodyPr wrap="square" anchor="ctr" lIns="0" tIns="0" rIns="0" bIns="0"/>
-          <a:lstStyle/>
-          <a:p>
-            <a:pPr algn="ctr">
-              <a:lnSpc>
-                <a:spcPct val="100000"/>
-              </a:lnSpc>
-              <a:buNone/>
-            </a:pPr>
-            <a:r>
-              <a:rPr lang="en-US" sz="750" dirty="0">
-                <a:solidFill>
-                  <a:srgbClr val="000000"/>
-                </a:solidFill>
-                <a:latin typeface="Arial"/>
-                <a:ea typeface="Arial"/>
-                <a:cs typeface="Arial"/>
-              </a:rPr>
-              <a:t>parent ordering period</a:t>
-            </a:r>
-          </a:p>
-        </p:txBody>
-      </p:sp>
-      <p:sp>
-        <p:nvSpPr>
-          <p:cNvPr id="35" name="SAIDIQOptions"/>
-          <p:cNvSpPr/>
-          <p:nvPr/>
-        </p:nvSpPr>
-        <p:spPr>
-          <a:xfrm>
-            <a:off x="4064959" y="3118104"/>
-            <a:ext cx="1005840" cy="128016"/>
-          </a:xfrm>
-          <a:prstGeom prst="rect">
-            <a:avLst/>
-          </a:prstGeom>
-          <a:noFill/>
-          <a:ln w="12700">
-            <a:solidFill>
-              <a:srgbClr val="000000"/>
-            </a:solidFill>
-            <a:prstDash val="dash"/>
-          </a:ln>
-        </p:spPr>
-      </p:sp>
-      <p:sp>
-        <p:nvSpPr>
-          <p:cNvPr id="36" name="SAIDIQChildLabel"/>
-          <p:cNvSpPr txBox="1"/>
-          <p:nvPr/>
-        </p:nvSpPr>
-        <p:spPr>
-          <a:xfrm>
-            <a:off x="2227015" y="3300984"/>
-            <a:ext cx="438912" cy="118872"/>
-          </a:xfrm>
-          <a:prstGeom prst="rect">
-            <a:avLst/>
-          </a:prstGeom>
-          <a:noFill/>
-          <a:ln>
-            <a:noFill/>
-          </a:ln>
-        </p:spPr>
-        <p:txBody>
-          <a:bodyPr wrap="square" anchor="ctr" lIns="0" tIns="0" rIns="0" bIns="0"/>
-          <a:lstStyle/>
-          <a:p>
-            <a:pPr algn="l">
-              <a:lnSpc>
-                <a:spcPct val="105000"/>
-              </a:lnSpc>
-              <a:buNone/>
-            </a:pPr>
-            <a:r>
-              <a:rPr lang="en-US" sz="750" b="0" i="1" dirty="0">
-                <a:solidFill>
-                  <a:srgbClr val="7F7F7F"/>
-                </a:solidFill>
-                <a:latin typeface="Arial"/>
-                <a:ea typeface="Arial"/>
-                <a:cs typeface="Arial"/>
-              </a:rPr>
-              <a:t>orders</a:t>
-            </a:r>
-          </a:p>
-        </p:txBody>
-      </p:sp>
-      <p:sp>
-        <p:nvSpPr>
-          <p:cNvPr id="37" name="SAIDIQChild1"/>
-          <p:cNvSpPr/>
-          <p:nvPr/>
-        </p:nvSpPr>
-        <p:spPr>
-          <a:xfrm>
-            <a:off x="2702503" y="3291840"/>
-            <a:ext cx="2816352" cy="64008"/>
-          </a:xfrm>
-          <a:prstGeom prst="rect">
-            <a:avLst/>
-          </a:prstGeom>
-          <a:noFill/>
-          <a:ln w="9525">
-            <a:solidFill>
-              <a:srgbClr val="7F7F7F"/>
-            </a:solidFill>
-          </a:ln>
-        </p:spPr>
-      </p:sp>
-      <p:sp>
-        <p:nvSpPr>
-          <p:cNvPr id="38" name="SAIDIQChild2"/>
-          <p:cNvSpPr/>
-          <p:nvPr/>
-        </p:nvSpPr>
-        <p:spPr>
-          <a:xfrm>
-            <a:off x="3799783" y="3392424"/>
-            <a:ext cx="2130552" cy="64008"/>
-          </a:xfrm>
-          <a:prstGeom prst="rect">
-            <a:avLst/>
-          </a:prstGeom>
-          <a:noFill/>
-          <a:ln w="9525">
-            <a:solidFill>
-              <a:srgbClr val="7F7F7F"/>
-            </a:solidFill>
-          </a:ln>
-        </p:spPr>
-      </p:sp>
-      <p:cxnSp>
-        <p:nvCxnSpPr>
-          <p:cNvPr id="39" name="RecompeteTrigger"/>
-          <p:cNvCxnSpPr/>
-          <p:nvPr/>
-        </p:nvCxnSpPr>
-        <p:spPr>
-          <a:xfrm>
-            <a:off x="5070799" y="3063240"/>
-            <a:ext cx="1" cy="393192"/>
-          </a:xfrm>
-          <a:prstGeom prst="line">
-            <a:avLst/>
-          </a:prstGeom>
-          <a:ln w="25400">
-            <a:solidFill>
-              <a:srgbClr val="6E91B1"/>
-            </a:solidFill>
-          </a:ln>
-        </p:spPr>
-      </p:cxnSp>
-      <p:cxnSp>
-        <p:nvCxnSpPr>
-          <p:cNvPr id="40" name="RouteToAddressableGate"/>
-          <p:cNvCxnSpPr/>
-          <p:nvPr/>
-        </p:nvCxnSpPr>
-        <p:spPr>
-          <a:xfrm>
-            <a:off x="5070799" y="3182112"/>
-            <a:ext cx="1161288" cy="1"/>
-          </a:xfrm>
-          <a:prstGeom prst="line">
-            <a:avLst/>
-          </a:prstGeom>
-          <a:ln w="9525">
-            <a:solidFill>
-              <a:srgbClr val="000000"/>
-            </a:solidFill>
-            <a:tailEnd type="triangle" w="med" len="med"/>
-          </a:ln>
-        </p:spPr>
-      </p:cxnSp>
-      <p:sp>
-        <p:nvSpPr>
-          <p:cNvPr id="41" name="LaneLabel"/>
-          <p:cNvSpPr txBox="1"/>
-          <p:nvPr/>
-        </p:nvSpPr>
-        <p:spPr>
-          <a:xfrm>
-            <a:off x="453079" y="3566160"/>
-            <a:ext cx="1627632" cy="457200"/>
-          </a:xfrm>
-          <a:prstGeom prst="rect">
-            <a:avLst/>
-          </a:prstGeom>
-          <a:noFill/>
-          <a:ln>
-            <a:noFill/>
-          </a:ln>
-        </p:spPr>
-        <p:txBody>
-          <a:bodyPr wrap="square" anchor="ctr" lIns="0" tIns="0" rIns="0" bIns="0"/>
-          <a:lstStyle/>
-          <a:p>
-            <a:pPr algn="l">
-              <a:lnSpc>
-                <a:spcPct val="105000"/>
-              </a:lnSpc>
-              <a:buNone/>
-            </a:pPr>
-            <a:r>
-              <a:rPr lang="en-US" sz="850" b="1" i="0" dirty="0">
-                <a:solidFill>
-                  <a:srgbClr val="000000"/>
-                </a:solidFill>
-                <a:latin typeface="Arial"/>
-                <a:ea typeface="Arial"/>
-                <a:cs typeface="Arial"/>
-              </a:rPr>
-              <a:t>Multiple-award
-Indefinite-Delivery/
-Indefinite-Quantity (IDIQ)</a:t>
-            </a:r>
-          </a:p>
-        </p:txBody>
-      </p:sp>
-      <p:sp>
-        <p:nvSpPr>
-          <p:cNvPr id="42" name="MAIDIQBase"/>
-          <p:cNvSpPr txBox="1"/>
-          <p:nvPr/>
-        </p:nvSpPr>
-        <p:spPr>
-          <a:xfrm>
-            <a:off x="2227015" y="3621024"/>
-            <a:ext cx="1563624" cy="128016"/>
-          </a:xfrm>
-          <a:prstGeom prst="rect">
-            <a:avLst/>
-          </a:prstGeom>
-          <a:noFill/>
-          <a:ln w="12700">
-            <a:solidFill>
-              <a:srgbClr val="000000"/>
-            </a:solidFill>
-          </a:ln>
-        </p:spPr>
-        <p:txBody>
-          <a:bodyPr wrap="square" anchor="ctr" lIns="0" tIns="0" rIns="0" bIns="0"/>
-          <a:lstStyle/>
-          <a:p>
-            <a:pPr algn="ctr">
-              <a:lnSpc>
-                <a:spcPct val="100000"/>
-              </a:lnSpc>
-              <a:buNone/>
-            </a:pPr>
-            <a:r>
-              <a:rPr lang="en-US" sz="750" dirty="0">
-                <a:solidFill>
-                  <a:srgbClr val="000000"/>
-                </a:solidFill>
-                <a:latin typeface="Arial"/>
-                <a:ea typeface="Arial"/>
-                <a:cs typeface="Arial"/>
-              </a:rPr>
-              <a:t>parent vehicle</a:t>
-            </a:r>
-          </a:p>
-        </p:txBody>
-      </p:sp>
-      <p:sp>
-        <p:nvSpPr>
-          <p:cNvPr id="43" name="MAIDIQOptions"/>
-          <p:cNvSpPr/>
-          <p:nvPr/>
-        </p:nvSpPr>
-        <p:spPr>
-          <a:xfrm>
-            <a:off x="3790639" y="3621024"/>
-            <a:ext cx="923544" cy="128016"/>
-          </a:xfrm>
-          <a:prstGeom prst="rect">
-            <a:avLst/>
-          </a:prstGeom>
-          <a:noFill/>
-          <a:ln w="12700">
-            <a:solidFill>
-              <a:srgbClr val="000000"/>
-            </a:solidFill>
-            <a:prstDash val="dash"/>
-          </a:ln>
-        </p:spPr>
-      </p:sp>
-      <p:sp>
-        <p:nvSpPr>
-          <p:cNvPr id="44" name="MAIDIQChildLabel"/>
-          <p:cNvSpPr txBox="1"/>
-          <p:nvPr/>
-        </p:nvSpPr>
-        <p:spPr>
-          <a:xfrm>
-            <a:off x="2227015" y="3794760"/>
-            <a:ext cx="438912" cy="118872"/>
-          </a:xfrm>
-          <a:prstGeom prst="rect">
-            <a:avLst/>
-          </a:prstGeom>
-          <a:noFill/>
-          <a:ln>
-            <a:noFill/>
-          </a:ln>
-        </p:spPr>
-        <p:txBody>
-          <a:bodyPr wrap="square" anchor="ctr" lIns="0" tIns="0" rIns="0" bIns="0"/>
-          <a:lstStyle/>
-          <a:p>
-            <a:pPr algn="l">
-              <a:lnSpc>
-                <a:spcPct val="105000"/>
-              </a:lnSpc>
-              <a:buNone/>
-            </a:pPr>
-            <a:r>
-              <a:rPr lang="en-US" sz="750" b="0" i="1" dirty="0">
-                <a:solidFill>
-                  <a:srgbClr val="7F7F7F"/>
-                </a:solidFill>
-                <a:latin typeface="Arial"/>
-                <a:ea typeface="Arial"/>
-                <a:cs typeface="Arial"/>
-              </a:rPr>
-              <a:t>orders</a:t>
-            </a:r>
-          </a:p>
-        </p:txBody>
-      </p:sp>
-      <p:sp>
-        <p:nvSpPr>
-          <p:cNvPr id="45" name="MAIDIQChild1"/>
-          <p:cNvSpPr/>
-          <p:nvPr/>
-        </p:nvSpPr>
-        <p:spPr>
-          <a:xfrm>
-            <a:off x="2638495" y="3785616"/>
-            <a:ext cx="2606040" cy="54864"/>
-          </a:xfrm>
-          <a:prstGeom prst="rect">
-            <a:avLst/>
-          </a:prstGeom>
-          <a:noFill/>
-          <a:ln w="9525">
-            <a:solidFill>
-              <a:srgbClr val="7F7F7F"/>
-            </a:solidFill>
-          </a:ln>
-        </p:spPr>
-      </p:sp>
-      <p:sp>
-        <p:nvSpPr>
-          <p:cNvPr id="46" name="MAIDIQChild2"/>
-          <p:cNvSpPr/>
-          <p:nvPr/>
-        </p:nvSpPr>
-        <p:spPr>
-          <a:xfrm>
-            <a:off x="3507175" y="3867912"/>
-            <a:ext cx="2478024" cy="54864"/>
-          </a:xfrm>
-          <a:prstGeom prst="rect">
-            <a:avLst/>
-          </a:prstGeom>
-          <a:noFill/>
-          <a:ln w="9525">
-            <a:solidFill>
-              <a:srgbClr val="7F7F7F"/>
-            </a:solidFill>
-          </a:ln>
-        </p:spPr>
-      </p:sp>
-      <p:sp>
-        <p:nvSpPr>
-          <p:cNvPr id="47" name="MAIDIQChild3"/>
-          <p:cNvSpPr/>
-          <p:nvPr/>
-        </p:nvSpPr>
-        <p:spPr>
-          <a:xfrm>
-            <a:off x="4174687" y="3950208"/>
-            <a:ext cx="1828800" cy="54864"/>
-          </a:xfrm>
-          <a:prstGeom prst="rect">
-            <a:avLst/>
-          </a:prstGeom>
-          <a:noFill/>
-          <a:ln w="9525">
-            <a:solidFill>
-              <a:srgbClr val="7F7F7F"/>
-            </a:solidFill>
-          </a:ln>
-        </p:spPr>
-      </p:sp>
-      <p:cxnSp>
-        <p:nvCxnSpPr>
-          <p:cNvPr id="48" name="RecompeteTrigger"/>
-          <p:cNvCxnSpPr/>
-          <p:nvPr/>
-        </p:nvCxnSpPr>
-        <p:spPr>
-          <a:xfrm>
-            <a:off x="4714183" y="3575304"/>
-            <a:ext cx="1" cy="393192"/>
-          </a:xfrm>
-          <a:prstGeom prst="line">
-            <a:avLst/>
-          </a:prstGeom>
-          <a:ln w="25400">
-            <a:solidFill>
-              <a:srgbClr val="6E91B1"/>
-            </a:solidFill>
-          </a:ln>
-        </p:spPr>
-      </p:cxnSp>
-      <p:cxnSp>
-        <p:nvCxnSpPr>
-          <p:cNvPr id="49" name="RouteToAddressableGate"/>
-          <p:cNvCxnSpPr/>
-          <p:nvPr/>
-        </p:nvCxnSpPr>
-        <p:spPr>
-          <a:xfrm>
-            <a:off x="4714183" y="3685032"/>
-            <a:ext cx="1517904" cy="1"/>
-          </a:xfrm>
-          <a:prstGeom prst="line">
-            <a:avLst/>
-          </a:prstGeom>
-          <a:ln w="9525">
-            <a:solidFill>
-              <a:srgbClr val="000000"/>
-            </a:solidFill>
-            <a:tailEnd type="triangle" w="med" len="med"/>
-          </a:ln>
-        </p:spPr>
-      </p:cxnSp>
-      <p:sp>
-        <p:nvSpPr>
-          <p:cNvPr id="50" name="LaneLabel"/>
-          <p:cNvSpPr txBox="1"/>
-          <p:nvPr/>
-        </p:nvSpPr>
-        <p:spPr>
-          <a:xfrm>
-            <a:off x="453079" y="4087368"/>
-            <a:ext cx="1627632" cy="457200"/>
-          </a:xfrm>
-          <a:prstGeom prst="rect">
-            <a:avLst/>
-          </a:prstGeom>
-          <a:noFill/>
-          <a:ln>
-            <a:noFill/>
-          </a:ln>
-        </p:spPr>
-        <p:txBody>
-          <a:bodyPr wrap="square" anchor="ctr" lIns="0" tIns="0" rIns="0" bIns="0"/>
-          <a:lstStyle/>
-          <a:p>
-            <a:pPr algn="l">
-              <a:lnSpc>
-                <a:spcPct val="105000"/>
-              </a:lnSpc>
-              <a:buNone/>
-            </a:pPr>
-            <a:r>
-              <a:rPr lang="en-US" sz="850" b="1" i="0" dirty="0">
-                <a:solidFill>
-                  <a:srgbClr val="000000"/>
-                </a:solidFill>
-                <a:latin typeface="Arial"/>
-                <a:ea typeface="Arial"/>
-                <a:cs typeface="Arial"/>
-              </a:rPr>
-              <a:t>Blanket Purchase Agreement
-(BPA)</a:t>
-            </a:r>
-          </a:p>
-        </p:txBody>
-      </p:sp>
-      <p:sp>
-        <p:nvSpPr>
-          <p:cNvPr id="51" name="BPABase"/>
-          <p:cNvSpPr txBox="1"/>
-          <p:nvPr/>
-        </p:nvSpPr>
-        <p:spPr>
-          <a:xfrm>
-            <a:off x="2227015" y="4160520"/>
-            <a:ext cx="1408176" cy="128016"/>
-          </a:xfrm>
-          <a:prstGeom prst="rect">
-            <a:avLst/>
-          </a:prstGeom>
-          <a:noFill/>
-          <a:ln w="12700">
-            <a:solidFill>
-              <a:srgbClr val="000000"/>
-            </a:solidFill>
-          </a:ln>
-        </p:spPr>
-        <p:txBody>
-          <a:bodyPr wrap="square" anchor="ctr" lIns="0" tIns="0" rIns="0" bIns="0"/>
-          <a:lstStyle/>
-          <a:p>
-            <a:pPr algn="ctr">
-              <a:lnSpc>
-                <a:spcPct val="100000"/>
-              </a:lnSpc>
-              <a:buNone/>
-            </a:pPr>
-            <a:r>
-              <a:rPr lang="en-US" sz="750" dirty="0">
-                <a:solidFill>
-                  <a:srgbClr val="000000"/>
-                </a:solidFill>
-                <a:latin typeface="Arial"/>
-                <a:ea typeface="Arial"/>
-                <a:cs typeface="Arial"/>
-              </a:rPr>
-              <a:t>agreement / call period</a:t>
-            </a:r>
-          </a:p>
-        </p:txBody>
-      </p:sp>
-      <p:sp>
-        <p:nvSpPr>
-          <p:cNvPr id="52" name="BPAOptions"/>
-          <p:cNvSpPr/>
-          <p:nvPr/>
-        </p:nvSpPr>
-        <p:spPr>
-          <a:xfrm>
-            <a:off x="3635191" y="4160520"/>
-            <a:ext cx="859536" cy="128016"/>
-          </a:xfrm>
-          <a:prstGeom prst="rect">
-            <a:avLst/>
-          </a:prstGeom>
-          <a:noFill/>
-          <a:ln w="12700">
-            <a:solidFill>
-              <a:srgbClr val="000000"/>
-            </a:solidFill>
-            <a:prstDash val="dash"/>
-          </a:ln>
-        </p:spPr>
-      </p:sp>
-      <p:sp>
-        <p:nvSpPr>
-          <p:cNvPr id="53" name="BPAChildLabel"/>
-          <p:cNvSpPr txBox="1"/>
-          <p:nvPr/>
-        </p:nvSpPr>
-        <p:spPr>
-          <a:xfrm>
-            <a:off x="2227015" y="4343400"/>
-            <a:ext cx="438912" cy="118872"/>
-          </a:xfrm>
-          <a:prstGeom prst="rect">
-            <a:avLst/>
-          </a:prstGeom>
-          <a:noFill/>
-          <a:ln>
-            <a:noFill/>
-          </a:ln>
-        </p:spPr>
-        <p:txBody>
-          <a:bodyPr wrap="square" anchor="ctr" lIns="0" tIns="0" rIns="0" bIns="0"/>
-          <a:lstStyle/>
-          <a:p>
-            <a:pPr algn="l">
-              <a:lnSpc>
-                <a:spcPct val="105000"/>
-              </a:lnSpc>
-              <a:buNone/>
-            </a:pPr>
-            <a:r>
-              <a:rPr lang="en-US" sz="750" b="0" i="1" dirty="0">
-                <a:solidFill>
-                  <a:srgbClr val="7F7F7F"/>
-                </a:solidFill>
-                <a:latin typeface="Arial"/>
-                <a:ea typeface="Arial"/>
-                <a:cs typeface="Arial"/>
-              </a:rPr>
-              <a:t>calls</a:t>
-            </a:r>
-          </a:p>
-        </p:txBody>
-      </p:sp>
-      <p:sp>
-        <p:nvSpPr>
-          <p:cNvPr id="54" name="BPAChild1"/>
-          <p:cNvSpPr/>
-          <p:nvPr/>
-        </p:nvSpPr>
-        <p:spPr>
-          <a:xfrm>
-            <a:off x="2793943" y="4334256"/>
-            <a:ext cx="2523744" cy="64008"/>
-          </a:xfrm>
-          <a:prstGeom prst="rect">
-            <a:avLst/>
-          </a:prstGeom>
-          <a:noFill/>
-          <a:ln w="9525">
-            <a:solidFill>
-              <a:srgbClr val="7F7F7F"/>
-            </a:solidFill>
-          </a:ln>
-        </p:spPr>
-      </p:sp>
-      <p:sp>
-        <p:nvSpPr>
-          <p:cNvPr id="55" name="BPAChild2"/>
-          <p:cNvSpPr/>
-          <p:nvPr/>
-        </p:nvSpPr>
-        <p:spPr>
-          <a:xfrm>
-            <a:off x="3690055" y="4434840"/>
-            <a:ext cx="2221992" cy="64008"/>
-          </a:xfrm>
-          <a:prstGeom prst="rect">
-            <a:avLst/>
-          </a:prstGeom>
-          <a:noFill/>
-          <a:ln w="9525">
-            <a:solidFill>
-              <a:srgbClr val="7F7F7F"/>
-            </a:solidFill>
-          </a:ln>
-        </p:spPr>
-      </p:sp>
-      <p:cxnSp>
-        <p:nvCxnSpPr>
-          <p:cNvPr id="56" name="RecompeteTrigger"/>
-          <p:cNvCxnSpPr/>
-          <p:nvPr/>
-        </p:nvCxnSpPr>
-        <p:spPr>
-          <a:xfrm>
-            <a:off x="4494727" y="4105656"/>
-            <a:ext cx="1" cy="393192"/>
-          </a:xfrm>
-          <a:prstGeom prst="line">
-            <a:avLst/>
-          </a:prstGeom>
-          <a:ln w="25400">
-            <a:solidFill>
-              <a:srgbClr val="6E91B1"/>
-            </a:solidFill>
-          </a:ln>
-        </p:spPr>
-      </p:cxnSp>
-      <p:cxnSp>
-        <p:nvCxnSpPr>
-          <p:cNvPr id="57" name="RouteToAddressableGate"/>
-          <p:cNvCxnSpPr/>
-          <p:nvPr/>
-        </p:nvCxnSpPr>
-        <p:spPr>
-          <a:xfrm>
-            <a:off x="4494727" y="4224528"/>
-            <a:ext cx="1737360" cy="1"/>
-          </a:xfrm>
-          <a:prstGeom prst="line">
-            <a:avLst/>
-          </a:prstGeom>
-          <a:ln w="9525">
-            <a:solidFill>
-              <a:srgbClr val="000000"/>
-            </a:solidFill>
-            <a:tailEnd type="triangle" w="med" len="med"/>
-          </a:ln>
-        </p:spPr>
-      </p:cxnSp>
-      <p:sp>
-        <p:nvSpPr>
-          <p:cNvPr id="58" name="LaneLabel"/>
-          <p:cNvSpPr txBox="1"/>
-          <p:nvPr/>
-        </p:nvSpPr>
-        <p:spPr>
-          <a:xfrm>
-            <a:off x="453079" y="4608576"/>
-            <a:ext cx="1627632" cy="457200"/>
-          </a:xfrm>
-          <a:prstGeom prst="rect">
-            <a:avLst/>
-          </a:prstGeom>
-          <a:noFill/>
-          <a:ln>
-            <a:noFill/>
-          </a:ln>
-        </p:spPr>
-        <p:txBody>
-          <a:bodyPr wrap="square" anchor="ctr" lIns="0" tIns="0" rIns="0" bIns="0"/>
-          <a:lstStyle/>
-          <a:p>
-            <a:pPr algn="l">
-              <a:lnSpc>
-                <a:spcPct val="105000"/>
-              </a:lnSpc>
-              <a:buNone/>
-            </a:pPr>
-            <a:r>
-              <a:rPr lang="en-US" sz="850" b="1" i="0" dirty="0">
-                <a:solidFill>
-                  <a:srgbClr val="000000"/>
-                </a:solidFill>
-                <a:latin typeface="Arial"/>
-                <a:ea typeface="Arial"/>
-                <a:cs typeface="Arial"/>
-              </a:rPr>
-              <a:t>Other Transaction (OT)
-agreement</a:t>
-            </a:r>
-          </a:p>
-        </p:txBody>
-      </p:sp>
-      <p:sp>
-        <p:nvSpPr>
-          <p:cNvPr id="59" name="OTBase"/>
-          <p:cNvSpPr txBox="1"/>
-          <p:nvPr/>
-        </p:nvSpPr>
-        <p:spPr>
-          <a:xfrm>
-            <a:off x="2227015" y="4681728"/>
-            <a:ext cx="1929384" cy="128016"/>
-          </a:xfrm>
-          <a:prstGeom prst="rect">
-            <a:avLst/>
-          </a:prstGeom>
-          <a:noFill/>
-          <a:ln w="12700">
-            <a:solidFill>
-              <a:srgbClr val="000000"/>
-            </a:solidFill>
-          </a:ln>
-        </p:spPr>
-        <p:txBody>
-          <a:bodyPr wrap="square" anchor="ctr" lIns="0" tIns="0" rIns="0" bIns="0"/>
-          <a:lstStyle/>
-          <a:p>
-            <a:pPr algn="ctr">
-              <a:lnSpc>
-                <a:spcPct val="100000"/>
-              </a:lnSpc>
-              <a:buNone/>
-            </a:pPr>
-            <a:r>
-              <a:rPr lang="en-US" sz="750" dirty="0">
-                <a:solidFill>
-                  <a:srgbClr val="000000"/>
-                </a:solidFill>
-                <a:latin typeface="Arial"/>
-                <a:ea typeface="Arial"/>
-                <a:cs typeface="Arial"/>
-              </a:rPr>
-              <a:t>agreement-specific term</a:t>
-            </a:r>
-          </a:p>
-        </p:txBody>
-      </p:sp>
-      <p:sp>
-        <p:nvSpPr>
-          <p:cNvPr id="60" name="OTOptions"/>
-          <p:cNvSpPr/>
-          <p:nvPr/>
-        </p:nvSpPr>
-        <p:spPr>
-          <a:xfrm>
-            <a:off x="4156399" y="4681728"/>
-            <a:ext cx="1115568" cy="128016"/>
-          </a:xfrm>
-          <a:prstGeom prst="rect">
-            <a:avLst/>
-          </a:prstGeom>
-          <a:noFill/>
-          <a:ln w="12700">
-            <a:solidFill>
-              <a:srgbClr val="000000"/>
-            </a:solidFill>
-            <a:prstDash val="dash"/>
-          </a:ln>
-        </p:spPr>
-      </p:sp>
-      <p:sp>
-        <p:nvSpPr>
-          <p:cNvPr id="61" name="OTChildLabel"/>
-          <p:cNvSpPr txBox="1"/>
-          <p:nvPr/>
-        </p:nvSpPr>
-        <p:spPr>
-          <a:xfrm>
-            <a:off x="2227015" y="4882896"/>
-            <a:ext cx="438912" cy="118872"/>
-          </a:xfrm>
-          <a:prstGeom prst="rect">
-            <a:avLst/>
-          </a:prstGeom>
-          <a:noFill/>
-          <a:ln>
-            <a:noFill/>
-          </a:ln>
-        </p:spPr>
-        <p:txBody>
-          <a:bodyPr wrap="square" anchor="ctr" lIns="0" tIns="0" rIns="0" bIns="0"/>
-          <a:lstStyle/>
-          <a:p>
-            <a:pPr algn="l">
-              <a:lnSpc>
-                <a:spcPct val="105000"/>
-              </a:lnSpc>
-              <a:buNone/>
-            </a:pPr>
-            <a:r>
-              <a:rPr lang="en-US" sz="750" b="0" i="1" dirty="0">
-                <a:solidFill>
-                  <a:srgbClr val="7F7F7F"/>
-                </a:solidFill>
-                <a:latin typeface="Arial"/>
-                <a:ea typeface="Arial"/>
-                <a:cs typeface="Arial"/>
-              </a:rPr>
-              <a:t>orders</a:t>
-            </a:r>
-          </a:p>
-        </p:txBody>
-      </p:sp>
-      <p:sp>
-        <p:nvSpPr>
-          <p:cNvPr id="62" name="OTChild1"/>
-          <p:cNvSpPr/>
-          <p:nvPr/>
-        </p:nvSpPr>
-        <p:spPr>
-          <a:xfrm>
-            <a:off x="3187135" y="4873752"/>
-            <a:ext cx="2926080" cy="64008"/>
-          </a:xfrm>
-          <a:prstGeom prst="rect">
-            <a:avLst/>
-          </a:prstGeom>
-          <a:noFill/>
-          <a:ln w="9525">
-            <a:solidFill>
-              <a:srgbClr val="7F7F7F"/>
-            </a:solidFill>
-          </a:ln>
-        </p:spPr>
-      </p:sp>
-      <p:cxnSp>
-        <p:nvCxnSpPr>
-          <p:cNvPr id="63" name="RecompeteTrigger"/>
-          <p:cNvCxnSpPr/>
-          <p:nvPr/>
-        </p:nvCxnSpPr>
-        <p:spPr>
-          <a:xfrm>
-            <a:off x="5271967" y="4626864"/>
-            <a:ext cx="1" cy="393192"/>
-          </a:xfrm>
-          <a:prstGeom prst="line">
-            <a:avLst/>
-          </a:prstGeom>
-          <a:ln w="25400">
-            <a:solidFill>
-              <a:srgbClr val="6E91B1"/>
-            </a:solidFill>
-          </a:ln>
-        </p:spPr>
-      </p:cxnSp>
-      <p:cxnSp>
-        <p:nvCxnSpPr>
-          <p:cNvPr id="64" name="RouteToAddressableGate"/>
-          <p:cNvCxnSpPr/>
-          <p:nvPr/>
-        </p:nvCxnSpPr>
-        <p:spPr>
-          <a:xfrm>
-            <a:off x="5271967" y="4745736"/>
-            <a:ext cx="960120" cy="1"/>
-          </a:xfrm>
-          <a:prstGeom prst="line">
-            <a:avLst/>
-          </a:prstGeom>
-          <a:ln w="9525">
-            <a:solidFill>
-              <a:srgbClr val="000000"/>
-            </a:solidFill>
-            <a:tailEnd type="triangle" w="med" len="med"/>
-          </a:ln>
-        </p:spPr>
-      </p:cxnSp>
-      <p:sp>
-        <p:nvSpPr>
-          <p:cNvPr id="65" name="AddressableBadge"/>
-          <p:cNvSpPr txBox="1"/>
-          <p:nvPr/>
-        </p:nvSpPr>
-        <p:spPr>
-          <a:xfrm>
-            <a:off x="6232087" y="2359152"/>
-            <a:ext cx="1627632" cy="365760"/>
-          </a:xfrm>
-          <a:prstGeom prst="rect">
-            <a:avLst/>
-          </a:prstGeom>
-          <a:solidFill>
-            <a:srgbClr val="3D5972"/>
-          </a:solidFill>
-          <a:ln w="19050">
-            <a:solidFill>
-              <a:srgbClr val="000000"/>
-            </a:solidFill>
-          </a:ln>
-        </p:spPr>
-        <p:txBody>
-          <a:bodyPr wrap="none" anchor="ctr" lIns="0" tIns="0" rIns="0" bIns="0"/>
-          <a:lstStyle/>
-          <a:p>
-            <a:pPr algn="ctr">
-              <a:lnSpc>
-                <a:spcPct val="100000"/>
-              </a:lnSpc>
-              <a:buNone/>
-            </a:pPr>
-            <a:r>
-              <a:rPr lang="en-US" sz="1600" b="1" dirty="0">
-                <a:solidFill>
-                  <a:srgbClr val="FFFFFF"/>
-                </a:solidFill>
-                <a:latin typeface="Arial"/>
-                <a:ea typeface="Arial"/>
-                <a:cs typeface="Arial"/>
-              </a:rPr>
-              <a:t>ADDRESSABLE?</a:t>
-            </a:r>
-          </a:p>
-        </p:txBody>
-      </p:sp>
-      <p:sp>
-        <p:nvSpPr>
-          <p:cNvPr id="66" name="AddressableGuardrail"/>
-          <p:cNvSpPr txBox="1"/>
-          <p:nvPr/>
-        </p:nvSpPr>
-        <p:spPr>
-          <a:xfrm>
-            <a:off x="6232087" y="2724912"/>
-            <a:ext cx="1627632" cy="2414016"/>
-          </a:xfrm>
-          <a:prstGeom prst="rect">
-            <a:avLst/>
-          </a:prstGeom>
-          <a:solidFill>
-            <a:srgbClr val="B6C8D8"/>
-          </a:solidFill>
-          <a:ln w="12700">
-            <a:solidFill>
-              <a:srgbClr val="000000"/>
-            </a:solidFill>
-          </a:ln>
-        </p:spPr>
-        <p:txBody>
-          <a:bodyPr wrap="square" anchor="t" lIns="114300" tIns="76200" rIns="114300" bIns="76200"/>
-          <a:lstStyle/>
-          <a:p>
-            <a:pPr>
-              <a:lnSpc>
-                <a:spcPct val="105000"/>
-              </a:lnSpc>
-              <a:spcAft>
-                <a:spcPts val="400"/>
-              </a:spcAft>
-              <a:buNone/>
-            </a:pPr>
-            <a:r>
-              <a:rPr lang="en-US" sz="900" b="1" dirty="0">
-                <a:solidFill>
-                  <a:srgbClr val="000000"/>
-                </a:solidFill>
-                <a:latin typeface="Arial"/>
-                <a:ea typeface="Arial"/>
-                <a:cs typeface="Arial"/>
-              </a:rPr>
-              <a:t>An expiring vehicle is not automatically an opportunity.</a:t>
-            </a:r>
-          </a:p>
-          <a:p>
-            <a:pPr>
-              <a:lnSpc>
-                <a:spcPct val="105000"/>
-              </a:lnSpc>
-              <a:buNone/>
-            </a:pPr>
-            <a:r>
-              <a:rPr lang="en-US" sz="850" b="1" dirty="0">
-                <a:solidFill>
-                  <a:srgbClr val="000000"/>
-                </a:solidFill>
-                <a:latin typeface="Arial"/>
-                <a:ea typeface="Arial"/>
-                <a:cs typeface="Arial"/>
-              </a:rPr>
-              <a:t>1  SUCCESSOR CHECK</a:t>
-            </a:r>
-          </a:p>
-          <a:p>
-            <a:pPr>
-              <a:lnSpc>
-                <a:spcPct val="105000"/>
-              </a:lnSpc>
-              <a:spcAft>
-                <a:spcPts val="300"/>
-              </a:spcAft>
-              <a:buNone/>
-            </a:pPr>
-            <a:r>
-              <a:rPr lang="en-US" sz="850" dirty="0">
-                <a:solidFill>
-                  <a:srgbClr val="000000"/>
-                </a:solidFill>
-                <a:latin typeface="Arial"/>
-                <a:ea typeface="Arial"/>
-                <a:cs typeface="Arial"/>
-              </a:rPr>
-              <a:t>Has a follow-on already been awarded? If yes, classify it as superseded, not overdue.</a:t>
-            </a:r>
-          </a:p>
-          <a:p>
-            <a:pPr>
-              <a:lnSpc>
-                <a:spcPct val="105000"/>
-              </a:lnSpc>
-              <a:buNone/>
-            </a:pPr>
-            <a:r>
-              <a:rPr lang="en-US" sz="850" b="1" dirty="0">
-                <a:solidFill>
-                  <a:srgbClr val="000000"/>
-                </a:solidFill>
-                <a:latin typeface="Arial"/>
-                <a:ea typeface="Arial"/>
-                <a:cs typeface="Arial"/>
-              </a:rPr>
-              <a:t>2  ACCESS CHECK</a:t>
-            </a:r>
-          </a:p>
-          <a:p>
-            <a:pPr>
-              <a:lnSpc>
-                <a:spcPct val="105000"/>
-              </a:lnSpc>
-              <a:buNone/>
-            </a:pPr>
-            <a:r>
-              <a:rPr lang="en-US" sz="850" dirty="0">
-                <a:solidFill>
-                  <a:srgbClr val="000000"/>
-                </a:solidFill>
-                <a:latin typeface="Arial"/>
-                <a:ea typeface="Arial"/>
-                <a:cs typeface="Arial"/>
-              </a:rPr>
-              <a:t>Can the company compete? FAR 16.505 may limit the next order to existing vehicle holders.</a:t>
-            </a:r>
-          </a:p>
-        </p:txBody>
-      </p:sp>
-      <p:graphicFrame>
-        <p:nvGraphicFramePr>
-          <p:cNvPr id="67" name="VehicleClockRules"/>
-          <p:cNvGraphicFramePr>
-            <a:graphicFrameLocks noGrp="1"/>
-          </p:cNvGraphicFramePr>
-          <p:nvPr/>
-        </p:nvGraphicFramePr>
-        <p:xfrm>
-          <a:off x="8024311" y="1371600"/>
-          <a:ext cx="3711130" cy="3139440"/>
-        </p:xfrm>
-        <a:graphic>
-          <a:graphicData uri="http://schemas.openxmlformats.org/drawingml/2006/table">
-            <a:tbl>
-              <a:tblPr firstRow="1" firstCol="1" bandRow="0">
-                <a:tableStyleId>{2D5ABB26-0587-4C30-8999-92F81FD0307C}</a:tableStyleId>
-              </a:tblPr>
-              <a:tblGrid>
-                <a:gridCol w="822960"/>
-                <a:gridCol w="941832"/>
-                <a:gridCol w="713232"/>
-                <a:gridCol w="1233106"/>
-              </a:tblGrid>
-              <a:tr h="274320">
-                <a:tc>
-                  <a:txBody>
-                    <a:bodyPr anchor="ctr"/>
-                    <a:lstStyle/>
-                    <a:p>
-                      <a:pPr algn="l">
-                        <a:lnSpc>
-                          <a:spcPct val="115000"/>
-                        </a:lnSpc>
-                      </a:pPr>
-                      <a:r>
-                        <a:rPr lang="en-US" sz="800" b="1" dirty="0">
-                          <a:solidFill>
-                            <a:srgbClr val="000000"/>
-                          </a:solidFill>
-                          <a:latin typeface="Arial"/>
-                          <a:ea typeface="Arial"/>
-                          <a:cs typeface="Arial"/>
-                        </a:rPr>
-                        <a:t>Vehicle type</a:t>
-                      </a:r>
-                    </a:p>
-                  </a:txBody>
-                  <a:tcPr marL="45720" marR="45720" marT="45720" marB="45720" anchor="ctr">
-                    <a:lnL>
-                      <a:noFill/>
-                    </a:lnL>
-                    <a:lnR>
-                      <a:noFill/>
-                    </a:lnR>
-                    <a:lnT>
-                      <a:noFill/>
-                    </a:lnT>
-                    <a:lnB w="19050" cap="flat" cmpd="sng" algn="ctr">
-                      <a:solidFill>
-                        <a:srgbClr val="000000"/>
-                      </a:solidFill>
-                      <a:prstDash val="solid"/>
-                    </a:lnB>
-                    <a:noFill/>
-                  </a:tcPr>
-                </a:tc>
-                <a:tc>
-                  <a:txBody>
-                    <a:bodyPr anchor="ctr"/>
-                    <a:lstStyle/>
-                    <a:p>
-                      <a:pPr algn="l">
-                        <a:lnSpc>
-                          <a:spcPct val="115000"/>
-                        </a:lnSpc>
-                      </a:pPr>
-                      <a:r>
-                        <a:rPr lang="en-US" sz="800" b="1" dirty="0">
-                          <a:solidFill>
-                            <a:srgbClr val="000000"/>
-                          </a:solidFill>
-                          <a:latin typeface="Arial"/>
-                          <a:ea typeface="Arial"/>
-                          <a:cs typeface="Arial"/>
-                        </a:rPr>
-                        <a:t>Recompete clock</a:t>
-                      </a:r>
-                    </a:p>
-                  </a:txBody>
-                  <a:tcPr marL="45720" marR="45720" marT="45720" marB="45720" anchor="ctr">
-                    <a:lnL>
-                      <a:noFill/>
-                    </a:lnL>
-                    <a:lnR>
-                      <a:noFill/>
-                    </a:lnR>
-                    <a:lnT>
-                      <a:noFill/>
-                    </a:lnT>
-                    <a:lnB w="19050" cap="flat" cmpd="sng" algn="ctr">
-                      <a:solidFill>
-                        <a:srgbClr val="000000"/>
-                      </a:solidFill>
-                      <a:prstDash val="solid"/>
-                    </a:lnB>
-                    <a:noFill/>
-                  </a:tcPr>
-                </a:tc>
-                <a:tc>
-                  <a:txBody>
-                    <a:bodyPr anchor="ctr"/>
-                    <a:lstStyle/>
-                    <a:p>
-                      <a:pPr algn="ctr">
-                        <a:lnSpc>
-                          <a:spcPct val="115000"/>
-                        </a:lnSpc>
-                      </a:pPr>
-                      <a:r>
-                        <a:rPr lang="en-US" sz="800" b="1" dirty="0">
-                          <a:solidFill>
-                            <a:srgbClr val="000000"/>
-                          </a:solidFill>
-                          <a:latin typeface="Arial"/>
-                          <a:ea typeface="Arial"/>
-                          <a:cs typeface="Arial"/>
-                        </a:rPr>
-                        <a:t>Confidence</a:t>
-                      </a:r>
-                    </a:p>
-                  </a:txBody>
-                  <a:tcPr marL="45720" marR="45720" marT="45720" marB="45720" anchor="ctr">
-                    <a:lnL>
-                      <a:noFill/>
-                    </a:lnL>
-                    <a:lnR>
-                      <a:noFill/>
-                    </a:lnR>
-                    <a:lnT>
-                      <a:noFill/>
-                    </a:lnT>
-                    <a:lnB w="19050" cap="flat" cmpd="sng" algn="ctr">
-                      <a:solidFill>
-                        <a:srgbClr val="000000"/>
-                      </a:solidFill>
-                      <a:prstDash val="solid"/>
-                    </a:lnB>
-                    <a:noFill/>
-                  </a:tcPr>
-                </a:tc>
-                <a:tc>
-                  <a:txBody>
-                    <a:bodyPr anchor="ctr"/>
-                    <a:lstStyle/>
-                    <a:p>
-                      <a:pPr algn="l">
-                        <a:lnSpc>
-                          <a:spcPct val="115000"/>
-                        </a:lnSpc>
-                      </a:pPr>
-                      <a:r>
-                        <a:rPr lang="en-US" sz="800" b="1" dirty="0">
-                          <a:solidFill>
-                            <a:srgbClr val="000000"/>
-                          </a:solidFill>
-                          <a:latin typeface="Arial"/>
-                          <a:ea typeface="Arial"/>
-                          <a:cs typeface="Arial"/>
-                        </a:rPr>
-                        <a:t>Note</a:t>
-                      </a:r>
-                    </a:p>
-                  </a:txBody>
-                  <a:tcPr marL="45720" marR="45720" marT="45720" marB="45720" anchor="ctr">
-                    <a:lnL>
-                      <a:noFill/>
-                    </a:lnL>
-                    <a:lnR>
-                      <a:noFill/>
-                    </a:lnR>
-                    <a:lnT>
-                      <a:noFill/>
-                    </a:lnT>
-                    <a:lnB w="19050" cap="flat" cmpd="sng" algn="ctr">
-                      <a:solidFill>
-                        <a:srgbClr val="000000"/>
-                      </a:solidFill>
-                      <a:prstDash val="solid"/>
-                    </a:lnB>
-                    <a:noFill/>
-                  </a:tcPr>
-                </a:tc>
-              </a:tr>
-              <a:tr h="579120">
-                <a:tc>
-                  <a:txBody>
-                    <a:bodyPr anchor="ctr"/>
-                    <a:lstStyle/>
-                    <a:p>
-                      <a:pPr algn="l">
-                        <a:lnSpc>
-                          <a:spcPct val="115000"/>
-                        </a:lnSpc>
-                      </a:pPr>
-                      <a:r>
-                        <a:rPr lang="en-US" sz="800" b="1" dirty="0">
-                          <a:solidFill>
-                            <a:srgbClr val="000000"/>
-                          </a:solidFill>
-                          <a:latin typeface="Arial"/>
-                          <a:ea typeface="Arial"/>
-                          <a:cs typeface="Arial"/>
-                        </a:rPr>
-                        <a:t>Standalone definitive contract</a:t>
-                      </a:r>
-                    </a:p>
-                  </a:txBody>
-                  <a:tcPr marL="45720" marR="45720" marT="45720" marB="45720" anchor="ctr">
-                    <a:lnL>
-                      <a:noFill/>
-                    </a:lnL>
-                    <a:lnR>
-                      <a:noFill/>
-                    </a:lnR>
-                    <a:lnT>
-                      <a:noFill/>
-                    </a:lnT>
-                    <a:lnB w="12700" cap="flat" cmpd="sng" algn="ctr">
-                      <a:solidFill>
-                        <a:srgbClr val="000000"/>
-                      </a:solidFill>
-                      <a:prstDash val="solid"/>
-                    </a:lnB>
-                    <a:noFill/>
-                  </a:tcPr>
-                </a:tc>
-                <a:tc>
-                  <a:txBody>
-                    <a:bodyPr anchor="ctr"/>
-                    <a:lstStyle/>
-                    <a:p>
-                      <a:pPr algn="l">
-                        <a:lnSpc>
-                          <a:spcPct val="115000"/>
-                        </a:lnSpc>
-                      </a:pPr>
-                      <a:r>
-                        <a:rPr lang="en-US" sz="800" b="0" dirty="0">
-                          <a:solidFill>
-                            <a:srgbClr val="000000"/>
-                          </a:solidFill>
-                          <a:latin typeface="Arial"/>
-                          <a:ea typeface="Arial"/>
-                          <a:cs typeface="Arial"/>
-                        </a:rPr>
-                        <a:t>Current and ultimate completion</a:t>
-                      </a:r>
-                    </a:p>
-                  </a:txBody>
-                  <a:tcPr marL="45720" marR="45720" marT="45720" marB="45720" anchor="ctr">
-                    <a:lnL>
-                      <a:noFill/>
-                    </a:lnL>
-                    <a:lnR>
-                      <a:noFill/>
-                    </a:lnR>
-                    <a:lnT>
-                      <a:noFill/>
-                    </a:lnT>
-                    <a:lnB w="12700" cap="flat" cmpd="sng" algn="ctr">
-                      <a:solidFill>
-                        <a:srgbClr val="000000"/>
-                      </a:solidFill>
-                      <a:prstDash val="solid"/>
-                    </a:lnB>
-                    <a:noFill/>
-                  </a:tcPr>
-                </a:tc>
-                <a:tc>
-                  <a:txBody>
-                    <a:bodyPr anchor="ctr"/>
-                    <a:lstStyle/>
-                    <a:p>
-                      <a:pPr algn="ctr">
-                        <a:lnSpc>
-                          <a:spcPct val="115000"/>
-                        </a:lnSpc>
-                      </a:pPr>
-                      <a:r>
-                        <a:rPr lang="en-US" sz="800" b="0" dirty="0">
-                          <a:solidFill>
-                            <a:srgbClr val="FFFFFF"/>
-                          </a:solidFill>
-                          <a:latin typeface="Arial"/>
-                          <a:ea typeface="Arial"/>
-                          <a:cs typeface="Arial"/>
-                        </a:rPr>
-                        <a:t>High</a:t>
-                      </a:r>
-                    </a:p>
-                  </a:txBody>
-                  <a:tcPr marL="45720" marR="45720" marT="45720" marB="45720" anchor="ctr">
-                    <a:lnL>
-                      <a:noFill/>
-                    </a:lnL>
-                    <a:lnR>
-                      <a:noFill/>
-                    </a:lnR>
-                    <a:lnT>
-                      <a:noFill/>
-                    </a:lnT>
-                    <a:lnB w="12700" cap="flat" cmpd="sng" algn="ctr">
-                      <a:solidFill>
-                        <a:srgbClr val="000000"/>
-                      </a:solidFill>
-                      <a:prstDash val="solid"/>
-                    </a:lnB>
-                    <a:solidFill>
-                      <a:srgbClr val="6E91B1"/>
-                    </a:solidFill>
-                  </a:tcPr>
-                </a:tc>
-                <a:tc>
-                  <a:txBody>
-                    <a:bodyPr anchor="ctr"/>
-                    <a:lstStyle/>
-                    <a:p>
-                      <a:pPr algn="l">
-                        <a:lnSpc>
-                          <a:spcPct val="115000"/>
-                        </a:lnSpc>
-                      </a:pPr>
-                      <a:r>
-                        <a:rPr lang="en-US" sz="800" b="0" dirty="0">
-                          <a:solidFill>
-                            <a:srgbClr val="000000"/>
-                          </a:solidFill>
-                          <a:latin typeface="Arial"/>
-                          <a:ea typeface="Arial"/>
-                          <a:cs typeface="Arial"/>
-                        </a:rPr>
-                        <a:t>Current may be an option decision; ultimate is the outer horizon.</a:t>
-                      </a:r>
-                    </a:p>
-                  </a:txBody>
-                  <a:tcPr marL="45720" marR="45720" marT="45720" marB="45720" anchor="ctr">
-                    <a:lnL>
-                      <a:noFill/>
-                    </a:lnL>
-                    <a:lnR>
-                      <a:noFill/>
-                    </a:lnR>
-                    <a:lnT>
-                      <a:noFill/>
-                    </a:lnT>
-                    <a:lnB w="12700" cap="flat" cmpd="sng" algn="ctr">
-                      <a:solidFill>
-                        <a:srgbClr val="000000"/>
-                      </a:solidFill>
-                      <a:prstDash val="solid"/>
-                    </a:lnB>
-                    <a:noFill/>
-                  </a:tcPr>
-                </a:tc>
-              </a:tr>
-              <a:tr h="701040">
-                <a:tc>
-                  <a:txBody>
-                    <a:bodyPr anchor="ctr"/>
-                    <a:lstStyle/>
-                    <a:p>
-                      <a:pPr algn="l">
-                        <a:lnSpc>
-                          <a:spcPct val="115000"/>
-                        </a:lnSpc>
-                      </a:pPr>
-                      <a:r>
-                        <a:rPr lang="en-US" sz="800" b="1" dirty="0">
-                          <a:solidFill>
-                            <a:srgbClr val="000000"/>
-                          </a:solidFill>
-                          <a:latin typeface="Arial"/>
-                          <a:ea typeface="Arial"/>
-                          <a:cs typeface="Arial"/>
-                        </a:rPr>
-                        <a:t>IDIQ, single or multiple award</a:t>
-                      </a:r>
-                    </a:p>
-                  </a:txBody>
-                  <a:tcPr marL="45720" marR="45720" marT="45720" marB="45720" anchor="ctr">
-                    <a:lnL>
-                      <a:noFill/>
-                    </a:lnL>
-                    <a:lnR>
-                      <a:noFill/>
-                    </a:lnR>
-                    <a:lnT>
-                      <a:noFill/>
-                    </a:lnT>
-                    <a:lnB w="12700" cap="flat" cmpd="sng" algn="ctr">
-                      <a:solidFill>
-                        <a:srgbClr val="000000"/>
-                      </a:solidFill>
-                      <a:prstDash val="solid"/>
-                    </a:lnB>
-                    <a:noFill/>
-                  </a:tcPr>
-                </a:tc>
-                <a:tc>
-                  <a:txBody>
-                    <a:bodyPr anchor="ctr"/>
-                    <a:lstStyle/>
-                    <a:p>
-                      <a:pPr algn="l">
-                        <a:lnSpc>
-                          <a:spcPct val="115000"/>
-                        </a:lnSpc>
-                      </a:pPr>
-                      <a:r>
-                        <a:rPr lang="en-US" sz="800" b="0" dirty="0">
-                          <a:solidFill>
-                            <a:srgbClr val="000000"/>
-                          </a:solidFill>
-                          <a:latin typeface="Arial"/>
-                          <a:ea typeface="Arial"/>
-                          <a:cs typeface="Arial"/>
-                        </a:rPr>
-                        <a:t>Parent last date to order; child end for holders-only work</a:t>
-                      </a:r>
-                    </a:p>
-                  </a:txBody>
-                  <a:tcPr marL="45720" marR="45720" marT="45720" marB="45720" anchor="ctr">
-                    <a:lnL>
-                      <a:noFill/>
-                    </a:lnL>
-                    <a:lnR>
-                      <a:noFill/>
-                    </a:lnR>
-                    <a:lnT>
-                      <a:noFill/>
-                    </a:lnT>
-                    <a:lnB w="12700" cap="flat" cmpd="sng" algn="ctr">
-                      <a:solidFill>
-                        <a:srgbClr val="000000"/>
-                      </a:solidFill>
-                      <a:prstDash val="solid"/>
-                    </a:lnB>
-                    <a:noFill/>
-                  </a:tcPr>
-                </a:tc>
-                <a:tc>
-                  <a:txBody>
-                    <a:bodyPr anchor="ctr"/>
-                    <a:lstStyle/>
-                    <a:p>
-                      <a:pPr algn="ctr">
-                        <a:lnSpc>
-                          <a:spcPct val="115000"/>
-                        </a:lnSpc>
-                      </a:pPr>
-                      <a:r>
-                        <a:rPr lang="en-US" sz="800" b="0" dirty="0">
-                          <a:solidFill>
-                            <a:srgbClr val="FFFFFF"/>
-                          </a:solidFill>
-                          <a:latin typeface="Arial"/>
-                          <a:ea typeface="Arial"/>
-                          <a:cs typeface="Arial"/>
-                        </a:rPr>
-                        <a:t>High (parent)</a:t>
-                      </a:r>
-                    </a:p>
-                  </a:txBody>
-                  <a:tcPr marL="45720" marR="45720" marT="45720" marB="45720" anchor="ctr">
-                    <a:lnL>
-                      <a:noFill/>
-                    </a:lnL>
-                    <a:lnR>
-                      <a:noFill/>
-                    </a:lnR>
-                    <a:lnT>
-                      <a:noFill/>
-                    </a:lnT>
-                    <a:lnB w="12700" cap="flat" cmpd="sng" algn="ctr">
-                      <a:solidFill>
-                        <a:srgbClr val="000000"/>
-                      </a:solidFill>
-                      <a:prstDash val="solid"/>
-                    </a:lnB>
-                    <a:solidFill>
-                      <a:srgbClr val="6E91B1"/>
-                    </a:solidFill>
-                  </a:tcPr>
-                </a:tc>
-                <a:tc>
-                  <a:txBody>
-                    <a:bodyPr anchor="ctr"/>
-                    <a:lstStyle/>
-                    <a:p>
-                      <a:pPr algn="l">
-                        <a:lnSpc>
-                          <a:spcPct val="115000"/>
-                        </a:lnSpc>
-                      </a:pPr>
-                      <a:r>
-                        <a:rPr lang="en-US" sz="800" b="0" dirty="0">
-                          <a:solidFill>
-                            <a:srgbClr val="000000"/>
-                          </a:solidFill>
-                          <a:latin typeface="Arial"/>
-                          <a:ea typeface="Arial"/>
-                          <a:cs typeface="Arial"/>
-                        </a:rPr>
-                        <a:t>Parent governs vehicle; child follow-on may be holders-only.</a:t>
-                      </a:r>
-                    </a:p>
-                  </a:txBody>
-                  <a:tcPr marL="45720" marR="45720" marT="45720" marB="45720" anchor="ctr">
-                    <a:lnL>
-                      <a:noFill/>
-                    </a:lnL>
-                    <a:lnR>
-                      <a:noFill/>
-                    </a:lnR>
-                    <a:lnT>
-                      <a:noFill/>
-                    </a:lnT>
-                    <a:lnB w="12700" cap="flat" cmpd="sng" algn="ctr">
-                      <a:solidFill>
-                        <a:srgbClr val="000000"/>
-                      </a:solidFill>
-                      <a:prstDash val="solid"/>
-                    </a:lnB>
-                    <a:noFill/>
-                  </a:tcPr>
-                </a:tc>
-              </a:tr>
-              <a:tr h="335280">
-                <a:tc>
-                  <a:txBody>
-                    <a:bodyPr anchor="ctr"/>
-                    <a:lstStyle/>
-                    <a:p>
-                      <a:pPr algn="l">
-                        <a:lnSpc>
-                          <a:spcPct val="115000"/>
-                        </a:lnSpc>
-                      </a:pPr>
-                      <a:r>
-                        <a:rPr lang="en-US" sz="800" b="1" dirty="0">
-                          <a:solidFill>
-                            <a:srgbClr val="000000"/>
-                          </a:solidFill>
-                          <a:latin typeface="Arial"/>
-                          <a:ea typeface="Arial"/>
-                          <a:cs typeface="Arial"/>
-                        </a:rPr>
-                        <a:t>Task or delivery order</a:t>
-                      </a:r>
-                    </a:p>
-                  </a:txBody>
-                  <a:tcPr marL="45720" marR="45720" marT="45720" marB="45720" anchor="ctr">
-                    <a:lnL>
-                      <a:noFill/>
-                    </a:lnL>
-                    <a:lnR>
-                      <a:noFill/>
-                    </a:lnR>
-                    <a:lnT>
-                      <a:noFill/>
-                    </a:lnT>
-                    <a:lnB w="12700" cap="flat" cmpd="sng" algn="ctr">
-                      <a:solidFill>
-                        <a:srgbClr val="000000"/>
-                      </a:solidFill>
-                      <a:prstDash val="solid"/>
-                    </a:lnB>
-                    <a:noFill/>
-                  </a:tcPr>
-                </a:tc>
-                <a:tc>
-                  <a:txBody>
-                    <a:bodyPr anchor="ctr"/>
-                    <a:lstStyle/>
-                    <a:p>
-                      <a:pPr algn="l">
-                        <a:lnSpc>
-                          <a:spcPct val="115000"/>
-                        </a:lnSpc>
-                      </a:pPr>
-                      <a:r>
-                        <a:rPr lang="en-US" sz="800" b="0" dirty="0">
-                          <a:solidFill>
-                            <a:srgbClr val="000000"/>
-                          </a:solidFill>
-                          <a:latin typeface="Arial"/>
-                          <a:ea typeface="Arial"/>
-                          <a:cs typeface="Arial"/>
-                        </a:rPr>
-                        <a:t>Child ultimate completion</a:t>
-                      </a:r>
-                    </a:p>
-                  </a:txBody>
-                  <a:tcPr marL="45720" marR="45720" marT="45720" marB="45720" anchor="ctr">
-                    <a:lnL>
-                      <a:noFill/>
-                    </a:lnL>
-                    <a:lnR>
-                      <a:noFill/>
-                    </a:lnR>
-                    <a:lnT>
-                      <a:noFill/>
-                    </a:lnT>
-                    <a:lnB w="12700" cap="flat" cmpd="sng" algn="ctr">
-                      <a:solidFill>
-                        <a:srgbClr val="000000"/>
-                      </a:solidFill>
-                      <a:prstDash val="solid"/>
-                    </a:lnB>
-                    <a:noFill/>
-                  </a:tcPr>
-                </a:tc>
-                <a:tc>
-                  <a:txBody>
-                    <a:bodyPr anchor="ctr"/>
-                    <a:lstStyle/>
-                    <a:p>
-                      <a:pPr algn="ctr">
-                        <a:lnSpc>
-                          <a:spcPct val="115000"/>
-                        </a:lnSpc>
-                      </a:pPr>
-                      <a:r>
-                        <a:rPr lang="en-US" sz="800" b="0" dirty="0">
-                          <a:solidFill>
-                            <a:srgbClr val="000000"/>
-                          </a:solidFill>
-                          <a:latin typeface="Arial"/>
-                          <a:ea typeface="Arial"/>
-                          <a:cs typeface="Arial"/>
-                        </a:rPr>
-                        <a:t>Medium</a:t>
-                      </a:r>
-                    </a:p>
-                  </a:txBody>
-                  <a:tcPr marL="45720" marR="45720" marT="45720" marB="45720" anchor="ctr">
-                    <a:lnL>
-                      <a:noFill/>
-                    </a:lnL>
-                    <a:lnR>
-                      <a:noFill/>
-                    </a:lnR>
-                    <a:lnT>
-                      <a:noFill/>
-                    </a:lnT>
-                    <a:lnB w="12700" cap="flat" cmpd="sng" algn="ctr">
-                      <a:solidFill>
-                        <a:srgbClr val="000000"/>
-                      </a:solidFill>
-                      <a:prstDash val="solid"/>
-                    </a:lnB>
-                    <a:solidFill>
-                      <a:srgbClr val="B6C8D8"/>
-                    </a:solidFill>
-                  </a:tcPr>
-                </a:tc>
-                <a:tc>
-                  <a:txBody>
-                    <a:bodyPr anchor="ctr"/>
-                    <a:lstStyle/>
-                    <a:p>
-                      <a:pPr algn="l">
-                        <a:lnSpc>
-                          <a:spcPct val="115000"/>
-                        </a:lnSpc>
-                      </a:pPr>
-                      <a:r>
-                        <a:rPr lang="en-US" sz="800" b="0" dirty="0">
-                          <a:solidFill>
-                            <a:srgbClr val="000000"/>
-                          </a:solidFill>
-                          <a:latin typeface="Arial"/>
-                          <a:ea typeface="Arial"/>
-                          <a:cs typeface="Arial"/>
-                        </a:rPr>
-                        <a:t>Follow-on may be holders-only.</a:t>
-                      </a:r>
-                    </a:p>
-                  </a:txBody>
-                  <a:tcPr marL="45720" marR="45720" marT="45720" marB="45720" anchor="ctr">
-                    <a:lnL>
-                      <a:noFill/>
-                    </a:lnL>
-                    <a:lnR>
-                      <a:noFill/>
-                    </a:lnR>
-                    <a:lnT>
-                      <a:noFill/>
-                    </a:lnT>
-                    <a:lnB w="12700" cap="flat" cmpd="sng" algn="ctr">
-                      <a:solidFill>
-                        <a:srgbClr val="000000"/>
-                      </a:solidFill>
-                      <a:prstDash val="solid"/>
-                    </a:lnB>
-                    <a:noFill/>
-                  </a:tcPr>
-                </a:tc>
-              </a:tr>
-              <a:tr h="457200">
-                <a:tc>
-                  <a:txBody>
-                    <a:bodyPr anchor="ctr"/>
-                    <a:lstStyle/>
-                    <a:p>
-                      <a:pPr algn="l">
-                        <a:lnSpc>
-                          <a:spcPct val="115000"/>
-                        </a:lnSpc>
-                      </a:pPr>
-                      <a:r>
-                        <a:rPr lang="en-US" sz="800" b="1" dirty="0">
-                          <a:solidFill>
-                            <a:srgbClr val="000000"/>
-                          </a:solidFill>
-                          <a:latin typeface="Arial"/>
-                          <a:ea typeface="Arial"/>
-                          <a:cs typeface="Arial"/>
-                        </a:rPr>
-                        <a:t>BPA</a:t>
-                      </a:r>
-                    </a:p>
-                  </a:txBody>
-                  <a:tcPr marL="45720" marR="45720" marT="45720" marB="45720" anchor="ctr">
-                    <a:lnL>
-                      <a:noFill/>
-                    </a:lnL>
-                    <a:lnR>
-                      <a:noFill/>
-                    </a:lnR>
-                    <a:lnT>
-                      <a:noFill/>
-                    </a:lnT>
-                    <a:lnB w="12700" cap="flat" cmpd="sng" algn="ctr">
-                      <a:solidFill>
-                        <a:srgbClr val="000000"/>
-                      </a:solidFill>
-                      <a:prstDash val="solid"/>
-                    </a:lnB>
-                    <a:noFill/>
-                  </a:tcPr>
-                </a:tc>
-                <a:tc>
-                  <a:txBody>
-                    <a:bodyPr anchor="ctr"/>
-                    <a:lstStyle/>
-                    <a:p>
-                      <a:pPr algn="l">
-                        <a:lnSpc>
-                          <a:spcPct val="115000"/>
-                        </a:lnSpc>
-                      </a:pPr>
-                      <a:r>
-                        <a:rPr lang="en-US" sz="800" b="0" dirty="0">
-                          <a:solidFill>
-                            <a:srgbClr val="000000"/>
-                          </a:solidFill>
-                          <a:latin typeface="Arial"/>
-                          <a:ea typeface="Arial"/>
-                          <a:cs typeface="Arial"/>
-                        </a:rPr>
-                        <a:t>Agreement or call-period logic</a:t>
-                      </a:r>
-                    </a:p>
-                  </a:txBody>
-                  <a:tcPr marL="45720" marR="45720" marT="45720" marB="45720" anchor="ctr">
-                    <a:lnL>
-                      <a:noFill/>
-                    </a:lnL>
-                    <a:lnR>
-                      <a:noFill/>
-                    </a:lnR>
-                    <a:lnT>
-                      <a:noFill/>
-                    </a:lnT>
-                    <a:lnB w="12700" cap="flat" cmpd="sng" algn="ctr">
-                      <a:solidFill>
-                        <a:srgbClr val="000000"/>
-                      </a:solidFill>
-                      <a:prstDash val="solid"/>
-                    </a:lnB>
-                    <a:noFill/>
-                  </a:tcPr>
-                </a:tc>
-                <a:tc>
-                  <a:txBody>
-                    <a:bodyPr anchor="ctr"/>
-                    <a:lstStyle/>
-                    <a:p>
-                      <a:pPr algn="ctr">
-                        <a:lnSpc>
-                          <a:spcPct val="115000"/>
-                        </a:lnSpc>
-                      </a:pPr>
-                      <a:r>
-                        <a:rPr lang="en-US" sz="800" b="0" dirty="0">
-                          <a:solidFill>
-                            <a:srgbClr val="000000"/>
-                          </a:solidFill>
-                          <a:latin typeface="Arial"/>
-                          <a:ea typeface="Arial"/>
-                          <a:cs typeface="Arial"/>
-                        </a:rPr>
-                        <a:t>Medium</a:t>
-                      </a:r>
-                    </a:p>
-                  </a:txBody>
-                  <a:tcPr marL="45720" marR="45720" marT="45720" marB="45720" anchor="ctr">
-                    <a:lnL>
-                      <a:noFill/>
-                    </a:lnL>
-                    <a:lnR>
-                      <a:noFill/>
-                    </a:lnR>
-                    <a:lnT>
-                      <a:noFill/>
-                    </a:lnT>
-                    <a:lnB w="12700" cap="flat" cmpd="sng" algn="ctr">
-                      <a:solidFill>
-                        <a:srgbClr val="000000"/>
-                      </a:solidFill>
-                      <a:prstDash val="solid"/>
-                    </a:lnB>
-                    <a:solidFill>
-                      <a:srgbClr val="B6C8D8"/>
-                    </a:solidFill>
-                  </a:tcPr>
-                </a:tc>
-                <a:tc>
-                  <a:txBody>
-                    <a:bodyPr anchor="ctr"/>
-                    <a:lstStyle/>
-                    <a:p>
-                      <a:pPr algn="l">
-                        <a:lnSpc>
-                          <a:spcPct val="115000"/>
-                        </a:lnSpc>
-                      </a:pPr>
-                      <a:r>
-                        <a:rPr lang="en-US" sz="800" b="0" dirty="0">
-                          <a:solidFill>
-                            <a:srgbClr val="000000"/>
-                          </a:solidFill>
-                          <a:latin typeface="Arial"/>
-                          <a:ea typeface="Arial"/>
-                          <a:cs typeface="Arial"/>
-                        </a:rPr>
-                        <a:t>Inspect parent and call rules.</a:t>
-                      </a:r>
-                    </a:p>
-                  </a:txBody>
-                  <a:tcPr marL="45720" marR="45720" marT="45720" marB="45720" anchor="ctr">
-                    <a:lnL>
-                      <a:noFill/>
-                    </a:lnL>
-                    <a:lnR>
-                      <a:noFill/>
-                    </a:lnR>
-                    <a:lnT>
-                      <a:noFill/>
-                    </a:lnT>
-                    <a:lnB w="12700" cap="flat" cmpd="sng" algn="ctr">
-                      <a:solidFill>
-                        <a:srgbClr val="000000"/>
-                      </a:solidFill>
-                      <a:prstDash val="solid"/>
-                    </a:lnB>
-                    <a:noFill/>
-                  </a:tcPr>
-                </a:tc>
-              </a:tr>
-              <a:tr h="335280">
-                <a:tc>
-                  <a:txBody>
-                    <a:bodyPr anchor="ctr"/>
-                    <a:lstStyle/>
-                    <a:p>
-                      <a:pPr algn="l">
-                        <a:lnSpc>
-                          <a:spcPct val="115000"/>
-                        </a:lnSpc>
-                      </a:pPr>
-                      <a:r>
-                        <a:rPr lang="en-US" sz="800" b="1" dirty="0">
-                          <a:solidFill>
-                            <a:srgbClr val="000000"/>
-                          </a:solidFill>
-                          <a:latin typeface="Arial"/>
-                          <a:ea typeface="Arial"/>
-                          <a:cs typeface="Arial"/>
-                        </a:rPr>
-                        <a:t>BOA</a:t>
-                      </a:r>
-                    </a:p>
-                  </a:txBody>
-                  <a:tcPr marL="45720" marR="45720" marT="45720" marB="45720" anchor="ctr">
-                    <a:lnL>
-                      <a:noFill/>
-                    </a:lnL>
-                    <a:lnR>
-                      <a:noFill/>
-                    </a:lnR>
-                    <a:lnT>
-                      <a:noFill/>
-                    </a:lnT>
-                    <a:lnB w="12700" cap="flat" cmpd="sng" algn="ctr">
-                      <a:solidFill>
-                        <a:srgbClr val="000000"/>
-                      </a:solidFill>
-                      <a:prstDash val="solid"/>
-                    </a:lnB>
-                    <a:noFill/>
-                  </a:tcPr>
-                </a:tc>
-                <a:tc>
-                  <a:txBody>
-                    <a:bodyPr anchor="ctr"/>
-                    <a:lstStyle/>
-                    <a:p>
-                      <a:pPr algn="l">
-                        <a:lnSpc>
-                          <a:spcPct val="115000"/>
-                        </a:lnSpc>
-                      </a:pPr>
-                      <a:r>
-                        <a:rPr lang="en-US" sz="800" b="0" dirty="0">
-                          <a:solidFill>
-                            <a:srgbClr val="000000"/>
-                          </a:solidFill>
-                          <a:latin typeface="Arial"/>
-                          <a:ea typeface="Arial"/>
-                          <a:cs typeface="Arial"/>
-                        </a:rPr>
-                        <a:t>Nominal agreement end</a:t>
-                      </a:r>
-                    </a:p>
-                  </a:txBody>
-                  <a:tcPr marL="45720" marR="45720" marT="45720" marB="45720" anchor="ctr">
-                    <a:lnL>
-                      <a:noFill/>
-                    </a:lnL>
-                    <a:lnR>
-                      <a:noFill/>
-                    </a:lnR>
-                    <a:lnT>
-                      <a:noFill/>
-                    </a:lnT>
-                    <a:lnB w="12700" cap="flat" cmpd="sng" algn="ctr">
-                      <a:solidFill>
-                        <a:srgbClr val="000000"/>
-                      </a:solidFill>
-                      <a:prstDash val="solid"/>
-                    </a:lnB>
-                    <a:noFill/>
-                  </a:tcPr>
-                </a:tc>
-                <a:tc>
-                  <a:txBody>
-                    <a:bodyPr anchor="ctr"/>
-                    <a:lstStyle/>
-                    <a:p>
-                      <a:pPr algn="ctr">
-                        <a:lnSpc>
-                          <a:spcPct val="115000"/>
-                        </a:lnSpc>
-                      </a:pPr>
-                      <a:r>
-                        <a:rPr lang="en-US" sz="800" b="0" dirty="0">
-                          <a:solidFill>
-                            <a:srgbClr val="000000"/>
-                          </a:solidFill>
-                          <a:latin typeface="Arial"/>
-                          <a:ea typeface="Arial"/>
-                          <a:cs typeface="Arial"/>
-                        </a:rPr>
-                        <a:t>Low</a:t>
-                      </a:r>
-                    </a:p>
-                  </a:txBody>
-                  <a:tcPr marL="45720" marR="45720" marT="45720" marB="45720" anchor="ctr">
-                    <a:lnL>
-                      <a:noFill/>
-                    </a:lnL>
-                    <a:lnR>
-                      <a:noFill/>
-                    </a:lnR>
-                    <a:lnT>
-                      <a:noFill/>
-                    </a:lnT>
-                    <a:lnB w="12700" cap="flat" cmpd="sng" algn="ctr">
-                      <a:solidFill>
-                        <a:srgbClr val="000000"/>
-                      </a:solidFill>
-                      <a:prstDash val="solid"/>
-                    </a:lnB>
-                    <a:solidFill>
-                      <a:srgbClr val="E2E9EF"/>
-                    </a:solidFill>
-                  </a:tcPr>
-                </a:tc>
-                <a:tc>
-                  <a:txBody>
-                    <a:bodyPr anchor="ctr"/>
-                    <a:lstStyle/>
-                    <a:p>
-                      <a:pPr algn="l">
-                        <a:lnSpc>
-                          <a:spcPct val="115000"/>
-                        </a:lnSpc>
-                      </a:pPr>
-                      <a:r>
-                        <a:rPr lang="en-US" sz="800" b="0" dirty="0">
-                          <a:solidFill>
-                            <a:srgbClr val="000000"/>
-                          </a:solidFill>
-                          <a:latin typeface="Arial"/>
-                          <a:ea typeface="Arial"/>
-                          <a:cs typeface="Arial"/>
-                        </a:rPr>
-                        <a:t>Not a contract; not a guaranteed recompete.</a:t>
-                      </a:r>
-                    </a:p>
-                  </a:txBody>
-                  <a:tcPr marL="45720" marR="45720" marT="45720" marB="45720" anchor="ctr">
-                    <a:lnL>
-                      <a:noFill/>
-                    </a:lnL>
-                    <a:lnR>
-                      <a:noFill/>
-                    </a:lnR>
-                    <a:lnT>
-                      <a:noFill/>
-                    </a:lnT>
-                    <a:lnB w="12700" cap="flat" cmpd="sng" algn="ctr">
-                      <a:solidFill>
-                        <a:srgbClr val="000000"/>
-                      </a:solidFill>
-                      <a:prstDash val="solid"/>
-                    </a:lnB>
-                    <a:noFill/>
-                  </a:tcPr>
-                </a:tc>
-              </a:tr>
-              <a:tr h="457200">
-                <a:tc>
-                  <a:txBody>
-                    <a:bodyPr anchor="ctr"/>
-                    <a:lstStyle/>
-                    <a:p>
-                      <a:pPr algn="l">
-                        <a:lnSpc>
-                          <a:spcPct val="115000"/>
-                        </a:lnSpc>
-                      </a:pPr>
-                      <a:r>
-                        <a:rPr lang="en-US" sz="800" b="1" dirty="0">
-                          <a:solidFill>
-                            <a:srgbClr val="000000"/>
-                          </a:solidFill>
-                          <a:latin typeface="Arial"/>
-                          <a:ea typeface="Arial"/>
-                          <a:cs typeface="Arial"/>
-                        </a:rPr>
-                        <a:t>OT agreement or order</a:t>
-                      </a:r>
-                    </a:p>
-                  </a:txBody>
-                  <a:tcPr marL="45720" marR="45720" marT="45720" marB="45720" anchor="ctr">
-                    <a:lnL>
-                      <a:noFill/>
-                    </a:lnL>
-                    <a:lnR>
-                      <a:noFill/>
-                    </a:lnR>
-                    <a:lnT>
-                      <a:noFill/>
-                    </a:lnT>
-                    <a:lnB>
-                      <a:noFill/>
-                    </a:lnB>
-                    <a:noFill/>
-                  </a:tcPr>
-                </a:tc>
-                <a:tc>
-                  <a:txBody>
-                    <a:bodyPr anchor="ctr"/>
-                    <a:lstStyle/>
-                    <a:p>
-                      <a:pPr algn="l">
-                        <a:lnSpc>
-                          <a:spcPct val="115000"/>
-                        </a:lnSpc>
-                      </a:pPr>
-                      <a:r>
-                        <a:rPr lang="en-US" sz="800" b="0" dirty="0">
-                          <a:solidFill>
-                            <a:srgbClr val="000000"/>
-                          </a:solidFill>
-                          <a:latin typeface="Arial"/>
-                          <a:ea typeface="Arial"/>
-                          <a:cs typeface="Arial"/>
-                        </a:rPr>
-                        <a:t>Agreement-specific terms</a:t>
-                      </a:r>
-                    </a:p>
-                  </a:txBody>
-                  <a:tcPr marL="45720" marR="45720" marT="45720" marB="45720" anchor="ctr">
-                    <a:lnL>
-                      <a:noFill/>
-                    </a:lnL>
-                    <a:lnR>
-                      <a:noFill/>
-                    </a:lnR>
-                    <a:lnT>
-                      <a:noFill/>
-                    </a:lnT>
-                    <a:lnB>
-                      <a:noFill/>
-                    </a:lnB>
-                    <a:noFill/>
-                  </a:tcPr>
-                </a:tc>
-                <a:tc>
-                  <a:txBody>
-                    <a:bodyPr anchor="ctr"/>
-                    <a:lstStyle/>
-                    <a:p>
-                      <a:pPr algn="ctr">
-                        <a:lnSpc>
-                          <a:spcPct val="115000"/>
-                        </a:lnSpc>
-                      </a:pPr>
-                      <a:r>
-                        <a:rPr lang="en-US" sz="800" b="0" dirty="0">
-                          <a:solidFill>
-                            <a:srgbClr val="000000"/>
-                          </a:solidFill>
-                          <a:latin typeface="Arial"/>
-                          <a:ea typeface="Arial"/>
-                          <a:cs typeface="Arial"/>
-                        </a:rPr>
-                        <a:t>Variable</a:t>
-                      </a:r>
-                    </a:p>
-                  </a:txBody>
-                  <a:tcPr marL="45720" marR="45720" marT="45720" marB="45720" anchor="ctr">
-                    <a:lnL>
-                      <a:noFill/>
-                    </a:lnL>
-                    <a:lnR>
-                      <a:noFill/>
-                    </a:lnR>
-                    <a:lnT>
-                      <a:noFill/>
-                    </a:lnT>
-                    <a:lnB>
-                      <a:noFill/>
-                    </a:lnB>
-                    <a:solidFill>
-                      <a:srgbClr val="F2F2F2"/>
-                    </a:solidFill>
-                  </a:tcPr>
-                </a:tc>
-                <a:tc>
-                  <a:txBody>
-                    <a:bodyPr anchor="ctr"/>
-                    <a:lstStyle/>
-                    <a:p>
-                      <a:pPr algn="l">
-                        <a:lnSpc>
-                          <a:spcPct val="115000"/>
-                        </a:lnSpc>
-                      </a:pPr>
-                      <a:r>
-                        <a:rPr lang="en-US" sz="800" b="0" dirty="0">
-                          <a:solidFill>
-                            <a:srgbClr val="000000"/>
-                          </a:solidFill>
-                          <a:latin typeface="Arial"/>
-                          <a:ea typeface="Arial"/>
-                          <a:cs typeface="Arial"/>
-                        </a:rPr>
-                        <a:t>Read governing agreement; validate externally.</a:t>
-                      </a:r>
-                    </a:p>
-                  </a:txBody>
-                  <a:tcPr marL="45720" marR="45720" marT="45720" marB="45720" anchor="ctr">
-                    <a:lnL>
-                      <a:noFill/>
-                    </a:lnL>
-                    <a:lnR>
-                      <a:noFill/>
-                    </a:lnR>
-                    <a:lnT>
-                      <a:noFill/>
-                    </a:lnT>
-                    <a:lnB>
-                      <a:noFill/>
-                    </a:lnB>
-                    <a:noFill/>
-                  </a:tcPr>
-                </a:tc>
-              </a:tr>
-            </a:tbl>
-          </a:graphicData>
-        </a:graphic>
-      </p:graphicFrame>
-      <p:cxnSp>
-        <p:nvCxnSpPr>
-          <p:cNvPr id="68" name="GateToStateClassification"/>
-          <p:cNvCxnSpPr/>
-          <p:nvPr/>
-        </p:nvCxnSpPr>
-        <p:spPr>
-          <a:xfrm>
-            <a:off x="7859719" y="4620768"/>
-            <a:ext cx="164592" cy="1"/>
-          </a:xfrm>
-          <a:prstGeom prst="line">
-            <a:avLst/>
-          </a:prstGeom>
-          <a:ln w="9525">
-            <a:solidFill>
-              <a:srgbClr val="000000"/>
-            </a:solidFill>
-            <a:tailEnd type="triangle" w="med" len="med"/>
-          </a:ln>
-        </p:spPr>
-      </p:cxnSp>
-      <p:sp>
-        <p:nvSpPr>
-          <p:cNvPr id="69" name="StateHeader"/>
-          <p:cNvSpPr txBox="1"/>
-          <p:nvPr/>
-        </p:nvSpPr>
-        <p:spPr>
-          <a:xfrm>
-            <a:off x="8024311" y="4538472"/>
-            <a:ext cx="3711130" cy="164592"/>
-          </a:xfrm>
-          <a:prstGeom prst="rect">
-            <a:avLst/>
-          </a:prstGeom>
-          <a:solidFill>
-            <a:srgbClr val="F2F2F2"/>
-          </a:solidFill>
-          <a:ln w="12700">
-            <a:solidFill>
-              <a:srgbClr val="000000"/>
-            </a:solidFill>
-          </a:ln>
-        </p:spPr>
-        <p:txBody>
-          <a:bodyPr wrap="square" anchor="ctr" lIns="0" tIns="0" rIns="0" bIns="0"/>
-          <a:lstStyle/>
-          <a:p>
-            <a:pPr algn="ctr">
-              <a:lnSpc>
-                <a:spcPct val="100000"/>
-              </a:lnSpc>
-              <a:buNone/>
-            </a:pPr>
-            <a:r>
-              <a:rPr lang="en-US" sz="850" b="1" dirty="0">
-                <a:solidFill>
-                  <a:srgbClr val="000000"/>
-                </a:solidFill>
-                <a:latin typeface="Arial"/>
-                <a:ea typeface="Arial"/>
-                <a:cs typeface="Arial"/>
-              </a:rPr>
-              <a:t>OPPORTUNITY STATE, AFTER BOTH GATES</a:t>
-            </a:r>
-          </a:p>
-        </p:txBody>
-      </p:sp>
-      <p:sp>
-        <p:nvSpPr>
-          <p:cNvPr id="70" name="StateChip1"/>
-          <p:cNvSpPr txBox="1"/>
-          <p:nvPr/>
-        </p:nvSpPr>
-        <p:spPr>
-          <a:xfrm>
-            <a:off x="8024311" y="4748784"/>
-            <a:ext cx="1200467" cy="182880"/>
-          </a:xfrm>
-          <a:prstGeom prst="rect">
-            <a:avLst/>
-          </a:prstGeom>
-          <a:solidFill>
-            <a:srgbClr val="F2F2F2"/>
-          </a:solidFill>
-          <a:ln w="12700">
-            <a:solidFill>
-              <a:srgbClr val="000000"/>
-            </a:solidFill>
-          </a:ln>
-        </p:spPr>
-        <p:txBody>
-          <a:bodyPr wrap="square" anchor="ctr" lIns="45720" tIns="9144" rIns="45720" bIns="9144"/>
-          <a:lstStyle/>
-          <a:p>
-            <a:pPr algn="ctr">
-              <a:lnSpc>
-                <a:spcPct val="100000"/>
-              </a:lnSpc>
-              <a:buNone/>
-            </a:pPr>
-            <a:r>
-              <a:rPr lang="en-US" sz="850" dirty="0">
-                <a:solidFill>
-                  <a:srgbClr val="000000"/>
-                </a:solidFill>
-                <a:latin typeface="Arial"/>
-                <a:ea typeface="Arial"/>
-                <a:cs typeface="Arial"/>
-              </a:rPr>
-              <a:t>Open now</a:t>
-            </a:r>
-          </a:p>
-        </p:txBody>
-      </p:sp>
-      <p:sp>
-        <p:nvSpPr>
-          <p:cNvPr id="71" name="StateChip2"/>
-          <p:cNvSpPr txBox="1"/>
-          <p:nvPr/>
-        </p:nvSpPr>
-        <p:spPr>
-          <a:xfrm>
-            <a:off x="9279642" y="4748784"/>
-            <a:ext cx="1200467" cy="182880"/>
-          </a:xfrm>
-          <a:prstGeom prst="rect">
-            <a:avLst/>
-          </a:prstGeom>
-          <a:solidFill>
-            <a:srgbClr val="F2F2F2"/>
-          </a:solidFill>
-          <a:ln w="12700">
-            <a:solidFill>
-              <a:srgbClr val="000000"/>
-            </a:solidFill>
-          </a:ln>
-        </p:spPr>
-        <p:txBody>
-          <a:bodyPr wrap="square" anchor="ctr" lIns="45720" tIns="9144" rIns="45720" bIns="9144"/>
-          <a:lstStyle/>
-          <a:p>
-            <a:pPr algn="ctr">
-              <a:lnSpc>
-                <a:spcPct val="100000"/>
-              </a:lnSpc>
-              <a:buNone/>
-            </a:pPr>
-            <a:r>
-              <a:rPr lang="en-US" sz="850" dirty="0">
-                <a:solidFill>
-                  <a:srgbClr val="000000"/>
-                </a:solidFill>
-                <a:latin typeface="Arial"/>
-                <a:ea typeface="Arial"/>
-                <a:cs typeface="Arial"/>
-              </a:rPr>
-              <a:t>Option decision</a:t>
-            </a:r>
-          </a:p>
-        </p:txBody>
-      </p:sp>
-      <p:sp>
-        <p:nvSpPr>
-          <p:cNvPr id="72" name="StateChip3"/>
-          <p:cNvSpPr txBox="1"/>
-          <p:nvPr/>
-        </p:nvSpPr>
-        <p:spPr>
-          <a:xfrm>
-            <a:off x="10534973" y="4748784"/>
-            <a:ext cx="1200467" cy="182880"/>
-          </a:xfrm>
-          <a:prstGeom prst="rect">
-            <a:avLst/>
-          </a:prstGeom>
-          <a:solidFill>
-            <a:srgbClr val="F2F2F2"/>
-          </a:solidFill>
-          <a:ln w="12700">
-            <a:solidFill>
-              <a:srgbClr val="000000"/>
-            </a:solidFill>
-          </a:ln>
-        </p:spPr>
-        <p:txBody>
-          <a:bodyPr wrap="square" anchor="ctr" lIns="45720" tIns="9144" rIns="45720" bIns="9144"/>
-          <a:lstStyle/>
-          <a:p>
-            <a:pPr algn="ctr">
-              <a:lnSpc>
-                <a:spcPct val="100000"/>
-              </a:lnSpc>
-              <a:buNone/>
-            </a:pPr>
-            <a:r>
-              <a:rPr lang="en-US" sz="850" dirty="0">
-                <a:solidFill>
-                  <a:srgbClr val="000000"/>
-                </a:solidFill>
-                <a:latin typeface="Arial"/>
-                <a:ea typeface="Arial"/>
-                <a:cs typeface="Arial"/>
-              </a:rPr>
-              <a:t>Likely upcoming</a:t>
-            </a:r>
-          </a:p>
-        </p:txBody>
-      </p:sp>
-      <p:sp>
-        <p:nvSpPr>
-          <p:cNvPr id="73" name="StateChip4"/>
-          <p:cNvSpPr txBox="1"/>
-          <p:nvPr/>
-        </p:nvSpPr>
-        <p:spPr>
-          <a:xfrm>
-            <a:off x="8024311" y="4940808"/>
-            <a:ext cx="1200467" cy="182880"/>
-          </a:xfrm>
-          <a:prstGeom prst="rect">
-            <a:avLst/>
-          </a:prstGeom>
-          <a:solidFill>
-            <a:srgbClr val="F2F2F2"/>
-          </a:solidFill>
-          <a:ln w="12700">
-            <a:solidFill>
-              <a:srgbClr val="000000"/>
-            </a:solidFill>
-          </a:ln>
-        </p:spPr>
-        <p:txBody>
-          <a:bodyPr wrap="square" anchor="ctr" lIns="45720" tIns="9144" rIns="45720" bIns="9144"/>
-          <a:lstStyle/>
-          <a:p>
-            <a:pPr algn="ctr">
-              <a:lnSpc>
-                <a:spcPct val="100000"/>
-              </a:lnSpc>
-              <a:buNone/>
-            </a:pPr>
-            <a:r>
-              <a:rPr lang="en-US" sz="850" dirty="0">
-                <a:solidFill>
-                  <a:srgbClr val="000000"/>
-                </a:solidFill>
-                <a:latin typeface="Arial"/>
-                <a:ea typeface="Arial"/>
-                <a:cs typeface="Arial"/>
-              </a:rPr>
-              <a:t>Holders-only</a:t>
-            </a:r>
-          </a:p>
-        </p:txBody>
-      </p:sp>
-      <p:sp>
-        <p:nvSpPr>
-          <p:cNvPr id="74" name="StateChip5"/>
-          <p:cNvSpPr txBox="1"/>
-          <p:nvPr/>
-        </p:nvSpPr>
-        <p:spPr>
-          <a:xfrm>
-            <a:off x="9279642" y="4940808"/>
-            <a:ext cx="1200467" cy="182880"/>
-          </a:xfrm>
-          <a:prstGeom prst="rect">
-            <a:avLst/>
-          </a:prstGeom>
-          <a:solidFill>
-            <a:srgbClr val="F2F2F2"/>
-          </a:solidFill>
-          <a:ln w="12700">
-            <a:solidFill>
-              <a:srgbClr val="000000"/>
-            </a:solidFill>
-          </a:ln>
-        </p:spPr>
-        <p:txBody>
-          <a:bodyPr wrap="square" anchor="ctr" lIns="45720" tIns="9144" rIns="45720" bIns="9144"/>
-          <a:lstStyle/>
-          <a:p>
-            <a:pPr algn="ctr">
-              <a:lnSpc>
-                <a:spcPct val="100000"/>
-              </a:lnSpc>
-              <a:buNone/>
-            </a:pPr>
-            <a:r>
-              <a:rPr lang="en-US" sz="850" dirty="0">
-                <a:solidFill>
-                  <a:srgbClr val="000000"/>
-                </a:solidFill>
-                <a:latin typeface="Arial"/>
-                <a:ea typeface="Arial"/>
-                <a:cs typeface="Arial"/>
-              </a:rPr>
-              <a:t>Superseded</a:t>
-            </a:r>
-          </a:p>
-        </p:txBody>
-      </p:sp>
-      <p:sp>
-        <p:nvSpPr>
-          <p:cNvPr id="75" name="StateChip6"/>
-          <p:cNvSpPr txBox="1"/>
-          <p:nvPr/>
-        </p:nvSpPr>
-        <p:spPr>
-          <a:xfrm>
-            <a:off x="10534973" y="4940808"/>
-            <a:ext cx="1200467" cy="182880"/>
-          </a:xfrm>
-          <a:prstGeom prst="rect">
-            <a:avLst/>
-          </a:prstGeom>
-          <a:solidFill>
-            <a:srgbClr val="F2F2F2"/>
-          </a:solidFill>
-          <a:ln w="12700">
-            <a:solidFill>
-              <a:srgbClr val="000000"/>
-            </a:solidFill>
-          </a:ln>
-        </p:spPr>
-        <p:txBody>
-          <a:bodyPr wrap="square" anchor="ctr" lIns="45720" tIns="9144" rIns="45720" bIns="9144"/>
-          <a:lstStyle/>
-          <a:p>
-            <a:pPr algn="ctr">
-              <a:lnSpc>
-                <a:spcPct val="100000"/>
-              </a:lnSpc>
-              <a:buNone/>
-            </a:pPr>
-            <a:r>
-              <a:rPr lang="en-US" sz="850" dirty="0">
-                <a:solidFill>
-                  <a:srgbClr val="000000"/>
-                </a:solidFill>
-                <a:latin typeface="Arial"/>
-                <a:ea typeface="Arial"/>
-                <a:cs typeface="Arial"/>
-              </a:rPr>
-              <a:t>Research required</a:t>
-            </a:r>
-          </a:p>
-        </p:txBody>
-      </p:sp>
-      <p:cxnSp>
-        <p:nvCxnSpPr>
-          <p:cNvPr id="76" name="CaveatRailRule"/>
-          <p:cNvCxnSpPr/>
-          <p:nvPr/>
-        </p:nvCxnSpPr>
-        <p:spPr>
-          <a:xfrm>
-            <a:off x="453079" y="5394960"/>
-            <a:ext cx="11282362" cy="1"/>
-          </a:xfrm>
-          <a:prstGeom prst="line">
-            <a:avLst/>
-          </a:prstGeom>
-          <a:ln w="9525">
-            <a:solidFill>
-              <a:srgbClr val="000000"/>
-            </a:solidFill>
-          </a:ln>
-        </p:spPr>
-      </p:cxnSp>
-      <p:sp>
-        <p:nvSpPr>
-          <p:cNvPr id="77" name="CaveatRail"/>
-          <p:cNvSpPr txBox="1"/>
-          <p:nvPr/>
-        </p:nvSpPr>
-        <p:spPr>
-          <a:xfrm>
-            <a:off x="453079" y="5422392"/>
-            <a:ext cx="11282362" cy="393192"/>
-          </a:xfrm>
-          <a:prstGeom prst="rect">
-            <a:avLst/>
-          </a:prstGeom>
-          <a:noFill/>
-          <a:ln>
-            <a:noFill/>
-          </a:ln>
-        </p:spPr>
-        <p:txBody>
-          <a:bodyPr wrap="square" anchor="t" lIns="0" tIns="0" rIns="0" bIns="0"/>
-          <a:lstStyle/>
-          <a:p>
-            <a:pPr>
-              <a:lnSpc>
-                <a:spcPct val="100000"/>
-              </a:lnSpc>
-              <a:buNone/>
-            </a:pPr>
-            <a:r>
-              <a:rPr lang="en-US" sz="1000" b="1" dirty="0">
-                <a:solidFill>
-                  <a:srgbClr val="000000"/>
-                </a:solidFill>
-                <a:latin typeface="Arial"/>
-                <a:ea typeface="Arial"/>
-                <a:cs typeface="Arial"/>
-              </a:rPr>
-              <a:t>Timing is one of four reads. </a:t>
-            </a:r>
-            <a:r>
-              <a:rPr lang="en-US" sz="1000" dirty="0">
-                <a:solidFill>
-                  <a:srgbClr val="000000"/>
-                </a:solidFill>
-                <a:latin typeface="Arial"/>
-                <a:ea typeface="Arial"/>
-                <a:cs typeface="Arial"/>
-              </a:rPr>
-              <a:t>Requirement recurrence, authority lapse, competition route, and eligible bidder set are separate questions; the clock answers only the second.</a:t>
-            </a:r>
-          </a:p>
-          <a:p>
-            <a:pPr>
-              <a:lnSpc>
-                <a:spcPct val="100000"/>
-              </a:lnSpc>
-              <a:buNone/>
-            </a:pPr>
-            <a:r>
-              <a:rPr lang="en-US" sz="750" dirty="0">
-                <a:solidFill>
-                  <a:srgbClr val="7F7F7F"/>
-                </a:solidFill>
-                <a:latin typeface="Arial"/>
-                <a:ea typeface="Arial"/>
-                <a:cs typeface="Arial"/>
-              </a:rPr>
-              <a:t>Timing confidence varies by vehicle type | A Basic Ordering Agreement (BOA) nominal end is not a guaranteed recompete | A later Procurement Instrument Identifier (PIID) may already be the successor | Option value is capacity, not guaranteed revenue</a:t>
-            </a:r>
-          </a:p>
-        </p:txBody>
-      </p:sp>
-      <p:sp>
-        <p:nvSpPr>
-          <p:cNvPr id="9999" name="Sources"/>
-          <p:cNvSpPr txBox="1"/>
-          <p:nvPr/>
-        </p:nvSpPr>
-        <p:spPr>
-          <a:xfrm>
-            <a:off x="453079" y="5930000"/>
-            <a:ext cx="11282362" cy="540000"/>
-          </a:xfrm>
-          <a:prstGeom prst="rect">
-            <a:avLst/>
-          </a:prstGeom>
-          <a:noFill/>
-          <a:ln>
-            <a:noFill/>
-          </a:ln>
-        </p:spPr>
-        <p:txBody>
-          <a:bodyPr wrap="square" anchor="t" lIns="91440" tIns="45720" rIns="91440" bIns="45720"/>
-          <a:lstStyle/>
-          <a:p>
-            <a:r>
-              <a:rPr lang="en-US" sz="800" kern="1200" dirty="0">
-                <a:solidFill>
-                  <a:srgbClr val="162029"/>
-                </a:solidFill>
-                <a:latin typeface="Arial"/>
-                <a:ea typeface="Arial"/>
-                <a:cs typeface="Arial"/>
-              </a:rPr>
-              <a:t>Sources: SAM.gov Contract Awards API; FAR 16.505, 16.703, 17.207; FPDS and internal Army Market Mapping workbook. Figures illustrative of method; as of 2026-06-22</a:t>
-            </a:r>
-          </a:p>
-        </p:txBody>
-      </p:sp>
-    </p:spTree>
-  </p:cSld>
-  <p:clrMapOvr>
-    <a:masterClrMapping/>
-  </p:clrMapOvr>
-</p:sld>
-</file>
-
-<file path=ppt/slides/slide2.xml><?xml version="1.0" encoding="utf-8"?>
-<p:sld xmlns:a="http://schemas.openxmlformats.org/drawingml/2006/main" xmlns:r="http://schemas.openxmlformats.org/officeDocument/2006/relationships" xmlns:p="http://schemas.openxmlformats.org/presentationml/2006/main">
-  <p:cSld>
-    <p:spTree>
-      <p:nvGrpSpPr>
-        <p:cNvPr id="1" name=""/>
-        <p:cNvGrpSpPr/>
-        <p:nvPr/>
-      </p:nvGrpSpPr>
-      <p:grpSpPr>
-        <a:xfrm>
-          <a:off x="0" y="0"/>
-          <a:ext cx="0" cy="0"/>
-          <a:chOff x="0" y="0"/>
-          <a:chExt cx="0" cy="0"/>
-        </a:xfrm>
-      </p:grpSpPr>
-      <p:sp>
-        <p:nvSpPr>
-          <p:cNvPr id="2" name="Breadcrumb"/>
-          <p:cNvSpPr>
-            <a:spLocks noGrp="1"/>
-          </p:cNvSpPr>
-          <p:nvPr>
-            <p:ph type="body" sz="quarter" idx="10"/>
-          </p:nvPr>
-        </p:nvSpPr>
-        <p:spPr>
-          <a:xfrm>
-            <a:off x="453079" y="263452"/>
-            <a:ext cx="11282362" cy="153888"/>
-          </a:xfrm>
-        </p:spPr>
-        <p:txBody>
-          <a:bodyPr/>
-          <a:lstStyle/>
-          <a:p>
-            <a:r>
-              <a:rPr lang="en-US" sz="1000" b="1" kern="1200" dirty="0">
-                <a:solidFill>
-                  <a:srgbClr val="44505C"/>
-                </a:solidFill>
-                <a:latin typeface="Arial"/>
-                <a:ea typeface="Arial"/>
-                <a:cs typeface="Arial"/>
-              </a:rPr>
-              <a:t>Market Sizing</a:t>
-            </a:r>
-            <a:r>
-              <a:rPr lang="en-US" sz="1000" kern="1200" dirty="0">
-                <a:solidFill>
-                  <a:srgbClr val="44505C"/>
-                </a:solidFill>
-                <a:latin typeface="Arial"/>
-                <a:ea typeface="Arial"/>
-                <a:cs typeface="Arial"/>
-              </a:rPr>
-              <a:t> / Recompete Addressability</a:t>
-            </a:r>
-          </a:p>
-        </p:txBody>
-      </p:sp>
-      <p:sp>
-        <p:nvSpPr>
-          <p:cNvPr id="4" name="PrelimChip"/>
-          <p:cNvSpPr txBox="1"/>
-          <p:nvPr/>
-        </p:nvSpPr>
-        <p:spPr>
-          <a:xfrm>
-            <a:off x="10267829" y="111556"/>
-            <a:ext cx="1467612" cy="290000"/>
-          </a:xfrm>
-          <a:prstGeom prst="rect">
-            <a:avLst/>
-          </a:prstGeom>
-          <a:solidFill>
-            <a:srgbClr val="FFFFCC"/>
-          </a:solidFill>
-          <a:ln w="19050">
-            <a:solidFill>
-              <a:srgbClr val="000000"/>
-            </a:solidFill>
-          </a:ln>
-        </p:spPr>
-        <p:txBody>
-          <a:bodyPr wrap="square" anchor="ctr" lIns="45720" tIns="9144" rIns="45720" bIns="9144"/>
-          <a:lstStyle/>
-          <a:p>
-            <a:pPr algn="ctr"/>
-            <a:r>
-              <a:rPr lang="en-US" sz="1200" b="1" kern="1200" dirty="0">
-                <a:solidFill>
-                  <a:srgbClr val="000000"/>
-                </a:solidFill>
-                <a:latin typeface="Arial"/>
-                <a:ea typeface="Arial"/>
-                <a:cs typeface="Arial"/>
-              </a:rPr>
-              <a:t>Preliminary</a:t>
-            </a:r>
-          </a:p>
-        </p:txBody>
-      </p:sp>
-      <p:sp>
-        <p:nvSpPr>
-          <p:cNvPr id="3" name="Title"/>
-          <p:cNvSpPr>
-            <a:spLocks noGrp="1"/>
-          </p:cNvSpPr>
-          <p:nvPr>
-            <p:ph type="title"/>
-          </p:nvPr>
-        </p:nvSpPr>
-        <p:spPr>
-          <a:xfrm>
-            <a:off x="453079" y="554500"/>
-            <a:ext cx="11282362" cy="640080"/>
-          </a:xfrm>
-        </p:spPr>
-        <p:txBody>
-          <a:bodyPr rIns="0"/>
-          <a:lstStyle/>
-          <a:p>
-            <a:r>
-              <a:rPr lang="en-US" sz="2000" kern="1200" dirty="0">
-                <a:solidFill>
-                  <a:srgbClr val="162029"/>
-                </a:solidFill>
-                <a:latin typeface="Arial"/>
-                <a:ea typeface="Arial"/>
-                <a:cs typeface="Arial"/>
-              </a:rPr>
-              <a:t>Recompete Timing | A vehicle's last date to order sets the recompete clock, not its last task order's end date.</a:t>
-            </a:r>
-          </a:p>
-        </p:txBody>
-      </p:sp>
       <p:graphicFrame>
         <p:nvGraphicFramePr>
           <p:cNvPr id="10" name="RecompeteTimelineChart"/>
@@ -6632,7 +2905,229 @@
       </p:graphicFrame>
       <p:sp>
         <p:nvSpPr>
-          <p:cNvPr id="11" name="ClockReframe"/>
+          <p:cNvPr id="11" name="LaneLabel_1"/>
+          <p:cNvSpPr txBox="1"/>
+          <p:nvPr/>
+        </p:nvSpPr>
+        <p:spPr>
+          <a:xfrm>
+            <a:off x="453079" y="2525053"/>
+            <a:ext cx="1627632" cy="457200"/>
+          </a:xfrm>
+          <a:prstGeom prst="rect">
+            <a:avLst/>
+          </a:prstGeom>
+          <a:noFill/>
+          <a:ln>
+            <a:noFill/>
+          </a:ln>
+        </p:spPr>
+        <p:txBody>
+          <a:bodyPr wrap="square" anchor="ctr" lIns="0" tIns="0" rIns="0" bIns="0"/>
+          <a:lstStyle/>
+          <a:p>
+            <a:pPr algn="l">
+              <a:lnSpc>
+                <a:spcPct val="105000"/>
+              </a:lnSpc>
+              <a:buNone/>
+            </a:pPr>
+            <a:r>
+              <a:rPr lang="en-US" sz="850" b="1" i="0" dirty="0">
+                <a:solidFill>
+                  <a:srgbClr val="000000"/>
+                </a:solidFill>
+                <a:latin typeface="Arial"/>
+                <a:ea typeface="Arial"/>
+                <a:cs typeface="Arial"/>
+              </a:rPr>
+              <a:t>Standalone definitive
+contract</a:t>
+            </a:r>
+          </a:p>
+        </p:txBody>
+      </p:sp>
+      <p:sp>
+        <p:nvSpPr>
+          <p:cNvPr id="12" name="LaneLabel_2"/>
+          <p:cNvSpPr txBox="1"/>
+          <p:nvPr/>
+        </p:nvSpPr>
+        <p:spPr>
+          <a:xfrm>
+            <a:off x="453079" y="3040723"/>
+            <a:ext cx="1627632" cy="457200"/>
+          </a:xfrm>
+          <a:prstGeom prst="rect">
+            <a:avLst/>
+          </a:prstGeom>
+          <a:noFill/>
+          <a:ln>
+            <a:noFill/>
+          </a:ln>
+        </p:spPr>
+        <p:txBody>
+          <a:bodyPr wrap="square" anchor="ctr" lIns="0" tIns="0" rIns="0" bIns="0"/>
+          <a:lstStyle/>
+          <a:p>
+            <a:pPr algn="l">
+              <a:lnSpc>
+                <a:spcPct val="105000"/>
+              </a:lnSpc>
+              <a:buNone/>
+            </a:pPr>
+            <a:r>
+              <a:rPr lang="en-US" sz="850" b="1" i="0" dirty="0">
+                <a:solidFill>
+                  <a:srgbClr val="000000"/>
+                </a:solidFill>
+                <a:latin typeface="Arial"/>
+                <a:ea typeface="Arial"/>
+                <a:cs typeface="Arial"/>
+              </a:rPr>
+              <a:t>Single-award
+Indefinite-Delivery/
+Indefinite-Quantity (IDIQ)</a:t>
+            </a:r>
+          </a:p>
+        </p:txBody>
+      </p:sp>
+      <p:sp>
+        <p:nvSpPr>
+          <p:cNvPr id="13" name="LaneLabel_3"/>
+          <p:cNvSpPr txBox="1"/>
+          <p:nvPr/>
+        </p:nvSpPr>
+        <p:spPr>
+          <a:xfrm>
+            <a:off x="453079" y="3556393"/>
+            <a:ext cx="1627632" cy="457200"/>
+          </a:xfrm>
+          <a:prstGeom prst="rect">
+            <a:avLst/>
+          </a:prstGeom>
+          <a:noFill/>
+          <a:ln>
+            <a:noFill/>
+          </a:ln>
+        </p:spPr>
+        <p:txBody>
+          <a:bodyPr wrap="square" anchor="ctr" lIns="0" tIns="0" rIns="0" bIns="0"/>
+          <a:lstStyle/>
+          <a:p>
+            <a:pPr algn="l">
+              <a:lnSpc>
+                <a:spcPct val="105000"/>
+              </a:lnSpc>
+              <a:buNone/>
+            </a:pPr>
+            <a:r>
+              <a:rPr lang="en-US" sz="850" b="1" i="0" dirty="0">
+                <a:solidFill>
+                  <a:srgbClr val="000000"/>
+                </a:solidFill>
+                <a:latin typeface="Arial"/>
+                <a:ea typeface="Arial"/>
+                <a:cs typeface="Arial"/>
+              </a:rPr>
+              <a:t>Multiple-award
+Indefinite-Delivery/
+Indefinite-Quantity (IDIQ)</a:t>
+            </a:r>
+          </a:p>
+        </p:txBody>
+      </p:sp>
+      <p:sp>
+        <p:nvSpPr>
+          <p:cNvPr id="14" name="LaneLabel_4"/>
+          <p:cNvSpPr txBox="1"/>
+          <p:nvPr/>
+        </p:nvSpPr>
+        <p:spPr>
+          <a:xfrm>
+            <a:off x="453079" y="4072063"/>
+            <a:ext cx="1627632" cy="457200"/>
+          </a:xfrm>
+          <a:prstGeom prst="rect">
+            <a:avLst/>
+          </a:prstGeom>
+          <a:noFill/>
+          <a:ln>
+            <a:noFill/>
+          </a:ln>
+        </p:spPr>
+        <p:txBody>
+          <a:bodyPr wrap="square" anchor="ctr" lIns="0" tIns="0" rIns="0" bIns="0"/>
+          <a:lstStyle/>
+          <a:p>
+            <a:pPr algn="l">
+              <a:lnSpc>
+                <a:spcPct val="105000"/>
+              </a:lnSpc>
+              <a:buNone/>
+            </a:pPr>
+            <a:r>
+              <a:rPr lang="en-US" sz="850" b="1" i="0" dirty="0">
+                <a:solidFill>
+                  <a:srgbClr val="000000"/>
+                </a:solidFill>
+                <a:latin typeface="Arial"/>
+                <a:ea typeface="Arial"/>
+                <a:cs typeface="Arial"/>
+              </a:rPr>
+              <a:t>Blanket Purchase Agreement
+(BPA)</a:t>
+            </a:r>
+          </a:p>
+        </p:txBody>
+      </p:sp>
+      <p:sp>
+        <p:nvSpPr>
+          <p:cNvPr id="15" name="LaneLabel_5"/>
+          <p:cNvSpPr txBox="1"/>
+          <p:nvPr/>
+        </p:nvSpPr>
+        <p:spPr>
+          <a:xfrm>
+            <a:off x="453079" y="4587733"/>
+            <a:ext cx="1627632" cy="457200"/>
+          </a:xfrm>
+          <a:prstGeom prst="rect">
+            <a:avLst/>
+          </a:prstGeom>
+          <a:noFill/>
+          <a:ln>
+            <a:noFill/>
+          </a:ln>
+        </p:spPr>
+        <p:txBody>
+          <a:bodyPr wrap="square" anchor="ctr" lIns="0" tIns="0" rIns="0" bIns="0"/>
+          <a:lstStyle/>
+          <a:p>
+            <a:pPr algn="l">
+              <a:lnSpc>
+                <a:spcPct val="105000"/>
+              </a:lnSpc>
+              <a:buNone/>
+            </a:pPr>
+            <a:r>
+              <a:rPr lang="en-US" sz="850" b="1" i="0" dirty="0">
+                <a:solidFill>
+                  <a:srgbClr val="000000"/>
+                </a:solidFill>
+                <a:latin typeface="Arial"/>
+                <a:ea typeface="Arial"/>
+                <a:cs typeface="Arial"/>
+              </a:rPr>
+              <a:t>Other Transaction (OT)
+agreement</a:t>
+            </a:r>
+          </a:p>
+        </p:txBody>
+      </p:sp>
+      <p:sp>
+        <p:nvSpPr>
+          <p:cNvPr id="16" name="ClockReframe"/>
           <p:cNvSpPr txBox="1"/>
           <p:nvPr/>
         </p:nvSpPr>
@@ -6694,7 +3189,7 @@
       </p:sp>
       <p:cxnSp>
         <p:nvCxnSpPr>
-          <p:cNvPr id="12" name="SectionDivider"/>
+          <p:cNvPr id="17" name="SectionDivider"/>
           <p:cNvCxnSpPr/>
           <p:nvPr/>
         </p:nvCxnSpPr>
@@ -6715,7 +3210,7 @@
       </p:cxnSp>
       <p:cxnSp>
         <p:nvCxnSpPr>
-          <p:cNvPr id="13" name="TriggerLegendTick"/>
+          <p:cNvPr id="18" name="TriggerLegendTick"/>
           <p:cNvCxnSpPr/>
           <p:nvPr/>
         </p:nvCxnSpPr>
@@ -6736,7 +3231,7 @@
       </p:cxnSp>
       <p:sp>
         <p:nvSpPr>
-          <p:cNvPr id="14" name="TriggerLegend"/>
+          <p:cNvPr id="19" name="TriggerLegend"/>
           <p:cNvSpPr txBox="1"/>
           <p:nvPr/>
         </p:nvSpPr>
@@ -6780,7 +3275,7 @@
       </p:sp>
       <p:sp>
         <p:nvSpPr>
-          <p:cNvPr id="15" name="TailLegend"/>
+          <p:cNvPr id="20" name="TailLegend"/>
           <p:cNvSpPr txBox="1"/>
           <p:nvPr/>
         </p:nvSpPr>
@@ -6824,7 +3319,7 @@
       </p:sp>
       <p:cxnSp>
         <p:nvCxnSpPr>
-          <p:cNvPr id="16" name="TimeAxis"/>
+          <p:cNvPr id="21" name="TimeAxis"/>
           <p:cNvCxnSpPr/>
           <p:nvPr/>
         </p:nvCxnSpPr>
@@ -6846,7 +3341,7 @@
       </p:cxnSp>
       <p:cxnSp>
         <p:nvCxnSpPr>
-          <p:cNvPr id="17" name="TodayLine"/>
+          <p:cNvPr id="22" name="TodayLine"/>
           <p:cNvCxnSpPr/>
           <p:nvPr/>
         </p:nvCxnSpPr>
@@ -6868,7 +3363,7 @@
       </p:cxnSp>
       <p:cxnSp>
         <p:nvCxnSpPr>
-          <p:cNvPr id="18" name="DecisionHorizonLine"/>
+          <p:cNvPr id="23" name="DecisionHorizonLine"/>
           <p:cNvCxnSpPr/>
           <p:nvPr/>
         </p:nvCxnSpPr>
@@ -6890,7 +3385,7 @@
       </p:cxnSp>
       <p:sp>
         <p:nvSpPr>
-          <p:cNvPr id="19" name="TodayLabel"/>
+          <p:cNvPr id="24" name="TodayLabel"/>
           <p:cNvSpPr txBox="1"/>
           <p:nvPr/>
         </p:nvSpPr>
@@ -6933,7 +3428,7 @@
       </p:sp>
       <p:sp>
         <p:nvSpPr>
-          <p:cNvPr id="20" name="DecisionHorizonLabel"/>
+          <p:cNvPr id="25" name="DecisionHorizonLabel"/>
           <p:cNvSpPr txBox="1"/>
           <p:nvPr/>
         </p:nvSpPr>
@@ -6976,7 +3471,7 @@
       </p:sp>
       <p:sp>
         <p:nvSpPr>
-          <p:cNvPr id="21" name="BarLabel_Definitive"/>
+          <p:cNvPr id="26" name="BarLabel_Definitive"/>
           <p:cNvSpPr txBox="1"/>
           <p:nvPr/>
         </p:nvSpPr>
@@ -7019,7 +3514,7 @@
       </p:sp>
       <p:sp>
         <p:nvSpPr>
-          <p:cNvPr id="22" name="ExtLabel_Definitive"/>
+          <p:cNvPr id="27" name="ExtLabel_Definitive"/>
           <p:cNvSpPr txBox="1"/>
           <p:nvPr/>
         </p:nvSpPr>
@@ -7062,7 +3557,7 @@
       </p:sp>
       <p:cxnSp>
         <p:nvCxnSpPr>
-          <p:cNvPr id="23" name="Trigger_Definitive"/>
+          <p:cNvPr id="28" name="Trigger_Definitive"/>
           <p:cNvCxnSpPr/>
           <p:nvPr/>
         </p:nvCxnSpPr>
@@ -7083,7 +3578,7 @@
       </p:cxnSp>
       <p:cxnSp>
         <p:nvCxnSpPr>
-          <p:cNvPr id="24" name="TriggerDrop_Definitive"/>
+          <p:cNvPr id="29" name="TriggerDrop_Definitive"/>
           <p:cNvCxnSpPr/>
           <p:nvPr/>
         </p:nvCxnSpPr>
@@ -7104,7 +3599,7 @@
       </p:cxnSp>
       <p:cxnSp>
         <p:nvCxnSpPr>
-          <p:cNvPr id="25" name="RouteToGate_Definitive"/>
+          <p:cNvPr id="30" name="RouteToGate_Definitive"/>
           <p:cNvCxnSpPr/>
           <p:nvPr/>
         </p:nvCxnSpPr>
@@ -7126,7 +3621,7 @@
       </p:cxnSp>
       <p:sp>
         <p:nvSpPr>
-          <p:cNvPr id="26" name="BarLabel_SA_IDIQ"/>
+          <p:cNvPr id="31" name="BarLabel_SA_IDIQ"/>
           <p:cNvSpPr txBox="1"/>
           <p:nvPr/>
         </p:nvSpPr>
@@ -7169,7 +3664,7 @@
       </p:sp>
       <p:sp>
         <p:nvSpPr>
-          <p:cNvPr id="27" name="ChildLabel_SA_IDIQ"/>
+          <p:cNvPr id="32" name="ChildLabel_SA_IDIQ"/>
           <p:cNvSpPr txBox="1"/>
           <p:nvPr/>
         </p:nvSpPr>
@@ -7212,7 +3707,7 @@
       </p:sp>
       <p:sp>
         <p:nvSpPr>
-          <p:cNvPr id="28" name="ChildTail_SA_IDIQ_1"/>
+          <p:cNvPr id="33" name="ChildTail_SA_IDIQ_1"/>
           <p:cNvSpPr/>
           <p:nvPr/>
         </p:nvSpPr>
@@ -7234,7 +3729,7 @@
       </p:sp>
       <p:sp>
         <p:nvSpPr>
-          <p:cNvPr id="29" name="ChildTail_SA_IDIQ_2"/>
+          <p:cNvPr id="34" name="ChildTail_SA_IDIQ_2"/>
           <p:cNvSpPr/>
           <p:nvPr/>
         </p:nvSpPr>
@@ -7256,7 +3751,7 @@
       </p:sp>
       <p:cxnSp>
         <p:nvCxnSpPr>
-          <p:cNvPr id="30" name="Trigger_SA_IDIQ"/>
+          <p:cNvPr id="35" name="Trigger_SA_IDIQ"/>
           <p:cNvCxnSpPr/>
           <p:nvPr/>
         </p:nvCxnSpPr>
@@ -7277,7 +3772,7 @@
       </p:cxnSp>
       <p:cxnSp>
         <p:nvCxnSpPr>
-          <p:cNvPr id="31" name="RouteToGate_SA_IDIQ"/>
+          <p:cNvPr id="36" name="RouteToGate_SA_IDIQ"/>
           <p:cNvCxnSpPr/>
           <p:nvPr/>
         </p:nvCxnSpPr>
@@ -7299,7 +3794,7 @@
       </p:cxnSp>
       <p:sp>
         <p:nvSpPr>
-          <p:cNvPr id="32" name="BarLabel_MA_IDIQ"/>
+          <p:cNvPr id="37" name="BarLabel_MA_IDIQ"/>
           <p:cNvSpPr txBox="1"/>
           <p:nvPr/>
         </p:nvSpPr>
@@ -7342,7 +3837,7 @@
       </p:sp>
       <p:sp>
         <p:nvSpPr>
-          <p:cNvPr id="33" name="ChildLabel_MA_IDIQ"/>
+          <p:cNvPr id="38" name="ChildLabel_MA_IDIQ"/>
           <p:cNvSpPr txBox="1"/>
           <p:nvPr/>
         </p:nvSpPr>
@@ -7385,7 +3880,7 @@
       </p:sp>
       <p:sp>
         <p:nvSpPr>
-          <p:cNvPr id="34" name="ChildTail_MA_IDIQ_1"/>
+          <p:cNvPr id="39" name="ChildTail_MA_IDIQ_1"/>
           <p:cNvSpPr/>
           <p:nvPr/>
         </p:nvSpPr>
@@ -7407,7 +3902,7 @@
       </p:sp>
       <p:sp>
         <p:nvSpPr>
-          <p:cNvPr id="35" name="ChildTail_MA_IDIQ_2"/>
+          <p:cNvPr id="40" name="ChildTail_MA_IDIQ_2"/>
           <p:cNvSpPr/>
           <p:nvPr/>
         </p:nvSpPr>
@@ -7429,7 +3924,7 @@
       </p:sp>
       <p:sp>
         <p:nvSpPr>
-          <p:cNvPr id="36" name="ChildTail_MA_IDIQ_3"/>
+          <p:cNvPr id="41" name="ChildTail_MA_IDIQ_3"/>
           <p:cNvSpPr/>
           <p:nvPr/>
         </p:nvSpPr>
@@ -7451,7 +3946,7 @@
       </p:sp>
       <p:cxnSp>
         <p:nvCxnSpPr>
-          <p:cNvPr id="37" name="Trigger_MA_IDIQ"/>
+          <p:cNvPr id="42" name="Trigger_MA_IDIQ"/>
           <p:cNvCxnSpPr/>
           <p:nvPr/>
         </p:nvCxnSpPr>
@@ -7472,7 +3967,7 @@
       </p:cxnSp>
       <p:cxnSp>
         <p:nvCxnSpPr>
-          <p:cNvPr id="38" name="RouteToGate_MA_IDIQ"/>
+          <p:cNvPr id="43" name="RouteToGate_MA_IDIQ"/>
           <p:cNvCxnSpPr/>
           <p:nvPr/>
         </p:nvCxnSpPr>
@@ -7494,7 +3989,7 @@
       </p:cxnSp>
       <p:sp>
         <p:nvSpPr>
-          <p:cNvPr id="39" name="BarLabel_BPA"/>
+          <p:cNvPr id="44" name="BarLabel_BPA"/>
           <p:cNvSpPr txBox="1"/>
           <p:nvPr/>
         </p:nvSpPr>
@@ -7537,7 +4032,7 @@
       </p:sp>
       <p:sp>
         <p:nvSpPr>
-          <p:cNvPr id="40" name="ChildLabel_BPA"/>
+          <p:cNvPr id="45" name="ChildLabel_BPA"/>
           <p:cNvSpPr txBox="1"/>
           <p:nvPr/>
         </p:nvSpPr>
@@ -7580,7 +4075,7 @@
       </p:sp>
       <p:sp>
         <p:nvSpPr>
-          <p:cNvPr id="41" name="ChildTail_BPA_1"/>
+          <p:cNvPr id="46" name="ChildTail_BPA_1"/>
           <p:cNvSpPr/>
           <p:nvPr/>
         </p:nvSpPr>
@@ -7602,7 +4097,7 @@
       </p:sp>
       <p:sp>
         <p:nvSpPr>
-          <p:cNvPr id="42" name="ChildTail_BPA_2"/>
+          <p:cNvPr id="47" name="ChildTail_BPA_2"/>
           <p:cNvSpPr/>
           <p:nvPr/>
         </p:nvSpPr>
@@ -7624,7 +4119,7 @@
       </p:sp>
       <p:cxnSp>
         <p:nvCxnSpPr>
-          <p:cNvPr id="43" name="Trigger_BPA"/>
+          <p:cNvPr id="48" name="Trigger_BPA"/>
           <p:cNvCxnSpPr/>
           <p:nvPr/>
         </p:nvCxnSpPr>
@@ -7645,7 +4140,7 @@
       </p:cxnSp>
       <p:cxnSp>
         <p:nvCxnSpPr>
-          <p:cNvPr id="44" name="RouteToGate_BPA"/>
+          <p:cNvPr id="49" name="RouteToGate_BPA"/>
           <p:cNvCxnSpPr/>
           <p:nvPr/>
         </p:nvCxnSpPr>
@@ -7667,7 +4162,7 @@
       </p:cxnSp>
       <p:sp>
         <p:nvSpPr>
-          <p:cNvPr id="45" name="BarLabel_OT"/>
+          <p:cNvPr id="50" name="BarLabel_OT"/>
           <p:cNvSpPr txBox="1"/>
           <p:nvPr/>
         </p:nvSpPr>
@@ -7710,7 +4205,7 @@
       </p:sp>
       <p:sp>
         <p:nvSpPr>
-          <p:cNvPr id="46" name="ChildLabel_OT"/>
+          <p:cNvPr id="51" name="ChildLabel_OT"/>
           <p:cNvSpPr txBox="1"/>
           <p:nvPr/>
         </p:nvSpPr>
@@ -7753,7 +4248,7 @@
       </p:sp>
       <p:sp>
         <p:nvSpPr>
-          <p:cNvPr id="47" name="ChildTail_OT_1"/>
+          <p:cNvPr id="52" name="ChildTail_OT_1"/>
           <p:cNvSpPr/>
           <p:nvPr/>
         </p:nvSpPr>
@@ -7775,7 +4270,7 @@
       </p:sp>
       <p:cxnSp>
         <p:nvCxnSpPr>
-          <p:cNvPr id="48" name="Trigger_OT"/>
+          <p:cNvPr id="53" name="Trigger_OT"/>
           <p:cNvCxnSpPr/>
           <p:nvPr/>
         </p:nvCxnSpPr>
@@ -7796,7 +4291,7 @@
       </p:cxnSp>
       <p:cxnSp>
         <p:nvCxnSpPr>
-          <p:cNvPr id="49" name="RouteToGate_OT"/>
+          <p:cNvPr id="54" name="RouteToGate_OT"/>
           <p:cNvCxnSpPr/>
           <p:nvPr/>
         </p:nvCxnSpPr>
@@ -7818,13 +4313,13 @@
       </p:cxnSp>
       <p:sp>
         <p:nvSpPr>
-          <p:cNvPr id="50" name="StandaloneDecisionLabel"/>
+          <p:cNvPr id="55" name="StandaloneDecisionLabel"/>
           <p:cNvSpPr txBox="1"/>
           <p:nvPr/>
         </p:nvSpPr>
         <p:spPr>
           <a:xfrm>
-            <a:off x="3824100" y="2845093"/>
+            <a:off x="3824100" y="2771941"/>
             <a:ext cx="749808" cy="128016"/>
           </a:xfrm>
           <a:prstGeom prst="rect">
@@ -7861,13 +4356,13 @@
       </p:sp>
       <p:sp>
         <p:nvSpPr>
-          <p:cNvPr id="51" name="StandaloneUltimateLabel"/>
+          <p:cNvPr id="56" name="StandaloneUltimateLabel"/>
           <p:cNvSpPr txBox="1"/>
           <p:nvPr/>
         </p:nvSpPr>
         <p:spPr>
           <a:xfrm>
-            <a:off x="4964874" y="2845093"/>
+            <a:off x="4964874" y="2771941"/>
             <a:ext cx="841248" cy="128016"/>
           </a:xfrm>
           <a:prstGeom prst="rect">
@@ -7904,7 +4399,7 @@
       </p:sp>
       <p:sp>
         <p:nvSpPr>
-          <p:cNvPr id="52" name="AddressableBadge"/>
+          <p:cNvPr id="57" name="AddressableBadge"/>
           <p:cNvSpPr txBox="1"/>
           <p:nvPr/>
         </p:nvSpPr>
@@ -7926,7 +4421,7 @@
           </a:ln>
         </p:spPr>
         <p:txBody>
-          <a:bodyPr wrap="none" anchor="ctr" lIns="45720" tIns="9144" rIns="45720" bIns="9144"/>
+          <a:bodyPr wrap="none" anchor="ctr" lIns="36576" tIns="9144" rIns="36576" bIns="9144"/>
           <a:lstStyle/>
           <a:p>
             <a:pPr algn="ctr">
@@ -7936,7 +4431,7 @@
               <a:buNone/>
             </a:pPr>
             <a:r>
-              <a:rPr lang="en-US" sz="1400" b="1" dirty="0">
+              <a:rPr lang="en-US" sz="1300" b="1" dirty="0">
                 <a:solidFill>
                   <a:srgbClr val="FFFFFF"/>
                 </a:solidFill>
@@ -7951,7 +4446,7 @@
       </p:sp>
       <p:sp>
         <p:nvSpPr>
-          <p:cNvPr id="53" name="AddressableGuardrail"/>
+          <p:cNvPr id="58" name="AddressableGuardrail"/>
           <p:cNvSpPr txBox="1"/>
           <p:nvPr/>
         </p:nvSpPr>
@@ -8080,7 +4575,7 @@
       </p:sp>
       <p:graphicFrame>
         <p:nvGraphicFramePr>
-          <p:cNvPr id="54" name="VehicleClockRules"/>
+          <p:cNvPr id="59" name="VehicleClockRules"/>
           <p:cNvGraphicFramePr>
             <a:graphicFrameLocks noGrp="1"/>
           </p:cNvGraphicFramePr>
@@ -9298,7 +5793,7 @@
       </p:graphicFrame>
       <p:cxnSp>
         <p:nvCxnSpPr>
-          <p:cNvPr id="55" name="GateToStateClassification"/>
+          <p:cNvPr id="60" name="GateToStateClassification"/>
           <p:cNvCxnSpPr/>
           <p:nvPr/>
         </p:nvCxnSpPr>
@@ -9320,7 +5815,7 @@
       </p:cxnSp>
       <p:sp>
         <p:nvSpPr>
-          <p:cNvPr id="56" name="StateHeader"/>
+          <p:cNvPr id="61" name="StateHeader"/>
           <p:cNvSpPr txBox="1"/>
           <p:nvPr/>
         </p:nvSpPr>
@@ -9367,7 +5862,7 @@
       </p:sp>
       <p:sp>
         <p:nvSpPr>
-          <p:cNvPr id="57" name="StateChip1"/>
+          <p:cNvPr id="62" name="StateChip1"/>
           <p:cNvSpPr txBox="1"/>
           <p:nvPr/>
         </p:nvSpPr>
@@ -9414,7 +5909,7 @@
       </p:sp>
       <p:sp>
         <p:nvSpPr>
-          <p:cNvPr id="58" name="StateChip2"/>
+          <p:cNvPr id="63" name="StateChip2"/>
           <p:cNvSpPr txBox="1"/>
           <p:nvPr/>
         </p:nvSpPr>
@@ -9461,7 +5956,7 @@
       </p:sp>
       <p:sp>
         <p:nvSpPr>
-          <p:cNvPr id="59" name="StateChip3"/>
+          <p:cNvPr id="64" name="StateChip3"/>
           <p:cNvSpPr txBox="1"/>
           <p:nvPr/>
         </p:nvSpPr>
@@ -9508,7 +6003,7 @@
       </p:sp>
       <p:sp>
         <p:nvSpPr>
-          <p:cNvPr id="60" name="StateChip4"/>
+          <p:cNvPr id="65" name="StateChip4"/>
           <p:cNvSpPr txBox="1"/>
           <p:nvPr/>
         </p:nvSpPr>
@@ -9555,7 +6050,7 @@
       </p:sp>
       <p:sp>
         <p:nvSpPr>
-          <p:cNvPr id="61" name="StateChip5"/>
+          <p:cNvPr id="66" name="StateChip5"/>
           <p:cNvSpPr txBox="1"/>
           <p:nvPr/>
         </p:nvSpPr>
@@ -9602,7 +6097,7 @@
       </p:sp>
       <p:sp>
         <p:nvSpPr>
-          <p:cNvPr id="62" name="StateChip6"/>
+          <p:cNvPr id="67" name="StateChip6"/>
           <p:cNvSpPr txBox="1"/>
           <p:nvPr/>
         </p:nvSpPr>
@@ -9649,7 +6144,7 @@
       </p:sp>
       <p:cxnSp>
         <p:nvCxnSpPr>
-          <p:cNvPr id="63" name="CaveatRailRule"/>
+          <p:cNvPr id="68" name="CaveatRailRule"/>
           <p:cNvCxnSpPr/>
           <p:nvPr/>
         </p:nvCxnSpPr>
@@ -9670,7 +6165,7 @@
       </p:cxnSp>
       <p:sp>
         <p:nvSpPr>
-          <p:cNvPr id="64" name="CaveatRail"/>
+          <p:cNvPr id="69" name="CaveatRail"/>
           <p:cNvSpPr txBox="1"/>
           <p:nvPr/>
         </p:nvSpPr>
@@ -9786,7 +6281,7 @@
 </p:sld>
 </file>
 
-<file path=ppt/slides/slide3.xml><?xml version="1.0" encoding="utf-8"?>
+<file path=ppt/slides/slide2.xml><?xml version="1.0" encoding="utf-8"?>
 <p:sld xmlns:a="http://schemas.openxmlformats.org/drawingml/2006/main" xmlns:r="http://schemas.openxmlformats.org/officeDocument/2006/relationships" xmlns:p="http://schemas.openxmlformats.org/presentationml/2006/main">
   <p:cSld>
     <p:spTree>
@@ -12844,7 +9339,7 @@
 </p:sld>
 </file>
 
-<file path=ppt/slides/slide4.xml><?xml version="1.0" encoding="utf-8"?>
+<file path=ppt/slides/slide3.xml><?xml version="1.0" encoding="utf-8"?>
 <p:sld xmlns:a="http://schemas.openxmlformats.org/drawingml/2006/main" xmlns:r="http://schemas.openxmlformats.org/officeDocument/2006/relationships" xmlns:p="http://schemas.openxmlformats.org/presentationml/2006/main">
   <p:cSld>
     <p:spTree>

</xml_diff>

<commit_message>
Awards methodology deck: tighten recompete-timing lane labels
Abbreviate the vehicle lane labels (IDIQ / BPA / OT) on the recompete-timing
copy slide and tighten the plot-left inset so the bars stretch horizontally
(~1.16in per unit, was ~1.0); regenerate the pptx. Pre-existing working-tree
changes, committed at the user's request.

Co-Authored-By: Claude Opus 4.8 (1M context) <noreply@anthropic.com>
</commit_message>
<xml_diff>
--- a/projects/other/awards_methodology/20260622_Awards Methodology_vS.pptx
+++ b/projects/other/awards_methodology/20260622_Awards Methodology_vS.pptx
@@ -312,9 +312,9 @@
           <c:layoutTarget val="inner"/>
           <c:xMode val="edge"/>
           <c:yMode val="edge"/>
-          <c:x val="0.312"/>
+          <c:x val="0.201"/>
           <c:y val="0.089"/>
-          <c:w val="0.682"/>
+          <c:w val="0.793"/>
           <c:h val="0.898"/>
         </c:manualLayout>
       </c:layout>
@@ -14131,7 +14131,7 @@
         <p:spPr>
           <a:xfrm>
             <a:off x="453079" y="2525053"/>
-            <a:ext cx="1627632" cy="457200"/>
+            <a:ext cx="1051560" cy="457200"/>
           </a:xfrm>
           <a:prstGeom prst="rect">
             <a:avLst/>
@@ -14160,8 +14160,7 @@
                 <a:ea typeface="Arial"/>
                 <a:cs typeface="Arial"/>
               </a:rPr>
-              <a:t>Standalone definitive
-contract</a:t>
+              <a:t>Standalone definitive contract</a:t>
             </a:r>
           </a:p>
         </p:txBody>
@@ -14175,7 +14174,7 @@
         <p:spPr>
           <a:xfrm>
             <a:off x="453079" y="3040723"/>
-            <a:ext cx="1627632" cy="457200"/>
+            <a:ext cx="1051560" cy="457200"/>
           </a:xfrm>
           <a:prstGeom prst="rect">
             <a:avLst/>
@@ -14204,9 +14203,7 @@
                 <a:ea typeface="Arial"/>
                 <a:cs typeface="Arial"/>
               </a:rPr>
-              <a:t>Single-award
-Indefinite-Delivery/
-Indefinite-Quantity (IDIQ)</a:t>
+              <a:t>Single-award IDIQ</a:t>
             </a:r>
           </a:p>
         </p:txBody>
@@ -14220,7 +14217,7 @@
         <p:spPr>
           <a:xfrm>
             <a:off x="453079" y="3556393"/>
-            <a:ext cx="1627632" cy="457200"/>
+            <a:ext cx="1051560" cy="457200"/>
           </a:xfrm>
           <a:prstGeom prst="rect">
             <a:avLst/>
@@ -14249,9 +14246,7 @@
                 <a:ea typeface="Arial"/>
                 <a:cs typeface="Arial"/>
               </a:rPr>
-              <a:t>Multiple-award
-Indefinite-Delivery/
-Indefinite-Quantity (IDIQ)</a:t>
+              <a:t>Multiple-award IDIQ</a:t>
             </a:r>
           </a:p>
         </p:txBody>
@@ -14265,7 +14260,7 @@
         <p:spPr>
           <a:xfrm>
             <a:off x="453079" y="4072063"/>
-            <a:ext cx="1627632" cy="457200"/>
+            <a:ext cx="1051560" cy="457200"/>
           </a:xfrm>
           <a:prstGeom prst="rect">
             <a:avLst/>
@@ -14294,8 +14289,7 @@
                 <a:ea typeface="Arial"/>
                 <a:cs typeface="Arial"/>
               </a:rPr>
-              <a:t>Blanket Purchase Agreement
-(BPA)</a:t>
+              <a:t>BPA</a:t>
             </a:r>
           </a:p>
         </p:txBody>
@@ -14309,7 +14303,7 @@
         <p:spPr>
           <a:xfrm>
             <a:off x="453079" y="4587733"/>
-            <a:ext cx="1627632" cy="457200"/>
+            <a:ext cx="1051560" cy="457200"/>
           </a:xfrm>
           <a:prstGeom prst="rect">
             <a:avLst/>
@@ -14338,8 +14332,7 @@
                 <a:ea typeface="Arial"/>
                 <a:cs typeface="Arial"/>
               </a:rPr>
-              <a:t>Other Transaction (OT)
-agreement</a:t>
+              <a:t>OT</a:t>
             </a:r>
           </a:p>
         </p:txBody>
@@ -14544,8 +14537,8 @@
         </p:nvCxnSpPr>
         <p:spPr>
           <a:xfrm>
-            <a:off x="2227600" y="2395728"/>
-            <a:ext cx="3878921" cy="1"/>
+            <a:off x="1596280" y="2395728"/>
+            <a:ext cx="4510241" cy="1"/>
           </a:xfrm>
           <a:prstGeom prst="line">
             <a:avLst/>
@@ -14566,7 +14559,7 @@
         </p:nvCxnSpPr>
         <p:spPr>
           <a:xfrm>
-            <a:off x="2227600" y="2368296"/>
+            <a:off x="1596280" y="2368296"/>
             <a:ext cx="1" cy="2962656"/>
           </a:xfrm>
           <a:prstGeom prst="line">
@@ -14588,7 +14581,7 @@
         </p:nvCxnSpPr>
         <p:spPr>
           <a:xfrm>
-            <a:off x="5531528" y="2368296"/>
+            <a:off x="5437944" y="2368296"/>
             <a:ext cx="1" cy="2962656"/>
           </a:xfrm>
           <a:prstGeom prst="line">
@@ -14610,7 +14603,7 @@
         </p:nvSpPr>
         <p:spPr>
           <a:xfrm>
-            <a:off x="1989856" y="2176272"/>
+            <a:off x="1358536" y="2176272"/>
             <a:ext cx="530352" cy="164592"/>
           </a:xfrm>
           <a:prstGeom prst="rect">
@@ -14653,7 +14646,7 @@
         </p:nvSpPr>
         <p:spPr>
           <a:xfrm>
-            <a:off x="5110904" y="2414016"/>
+            <a:off x="5017320" y="2414016"/>
             <a:ext cx="841248" cy="128016"/>
           </a:xfrm>
           <a:prstGeom prst="rect">
@@ -14696,8 +14689,8 @@
         </p:nvSpPr>
         <p:spPr>
           <a:xfrm>
-            <a:off x="2227600" y="2685073"/>
-            <a:ext cx="1971404" cy="137160"/>
+            <a:off x="1596280" y="2685073"/>
+            <a:ext cx="2292263" cy="137160"/>
           </a:xfrm>
           <a:prstGeom prst="rect">
             <a:avLst/>
@@ -14739,8 +14732,8 @@
         </p:nvSpPr>
         <p:spPr>
           <a:xfrm>
-            <a:off x="4199004" y="2685073"/>
-            <a:ext cx="1186494" cy="137160"/>
+            <a:off x="3888543" y="2685073"/>
+            <a:ext cx="1379603" cy="137160"/>
           </a:xfrm>
           <a:prstGeom prst="rect">
             <a:avLst/>
@@ -14782,7 +14775,7 @@
         </p:nvCxnSpPr>
         <p:spPr>
           <a:xfrm>
-            <a:off x="4199004" y="2570773"/>
+            <a:off x="3888543" y="2570773"/>
             <a:ext cx="1" cy="393192"/>
           </a:xfrm>
           <a:prstGeom prst="line">
@@ -14803,7 +14796,7 @@
         </p:nvCxnSpPr>
         <p:spPr>
           <a:xfrm>
-            <a:off x="4199004" y="2822233"/>
+            <a:off x="3888543" y="2822233"/>
             <a:ext cx="1" cy="192024"/>
           </a:xfrm>
           <a:prstGeom prst="line">
@@ -14824,8 +14817,8 @@
         </p:nvCxnSpPr>
         <p:spPr>
           <a:xfrm>
-            <a:off x="4199004" y="3014257"/>
-            <a:ext cx="2033083" cy="1"/>
+            <a:off x="3888543" y="3014257"/>
+            <a:ext cx="2343544" cy="1"/>
           </a:xfrm>
           <a:prstGeom prst="line">
             <a:avLst/>
@@ -14846,8 +14839,8 @@
         </p:nvSpPr>
         <p:spPr>
           <a:xfrm>
-            <a:off x="2227600" y="3200743"/>
-            <a:ext cx="1834501" cy="137160"/>
+            <a:off x="1596280" y="3200743"/>
+            <a:ext cx="2133078" cy="137160"/>
           </a:xfrm>
           <a:prstGeom prst="rect">
             <a:avLst/>
@@ -14889,7 +14882,7 @@
         </p:nvSpPr>
         <p:spPr>
           <a:xfrm>
-            <a:off x="2227600" y="3333331"/>
+            <a:off x="1596280" y="3333331"/>
             <a:ext cx="438912" cy="118872"/>
           </a:xfrm>
           <a:prstGeom prst="rect">
@@ -14932,8 +14925,8 @@
         </p:nvSpPr>
         <p:spPr>
           <a:xfrm>
-            <a:off x="2702197" y="3342475"/>
-            <a:ext cx="2811077" cy="54864"/>
+            <a:off x="2148121" y="3342475"/>
+            <a:ext cx="3268598" cy="54864"/>
           </a:xfrm>
           <a:prstGeom prst="rect">
             <a:avLst/>
@@ -14954,8 +14947,8 @@
         </p:nvSpPr>
         <p:spPr>
           <a:xfrm>
-            <a:off x="3797422" y="3433915"/>
-            <a:ext cx="2126561" cy="54864"/>
+            <a:off x="3421601" y="3433915"/>
+            <a:ext cx="2472673" cy="54864"/>
           </a:xfrm>
           <a:prstGeom prst="rect">
             <a:avLst/>
@@ -14976,7 +14969,7 @@
         </p:nvCxnSpPr>
         <p:spPr>
           <a:xfrm>
-            <a:off x="5066057" y="3086443"/>
+            <a:off x="4896715" y="3086443"/>
             <a:ext cx="1" cy="393192"/>
           </a:xfrm>
           <a:prstGeom prst="line">
@@ -14997,8 +14990,8 @@
         </p:nvCxnSpPr>
         <p:spPr>
           <a:xfrm>
-            <a:off x="5066057" y="3269323"/>
-            <a:ext cx="1166030" cy="1"/>
+            <a:off x="4896715" y="3269323"/>
+            <a:ext cx="1335372" cy="1"/>
           </a:xfrm>
           <a:prstGeom prst="line">
             <a:avLst/>
@@ -15019,8 +15012,8 @@
         </p:nvSpPr>
         <p:spPr>
           <a:xfrm>
-            <a:off x="2227600" y="3716413"/>
-            <a:ext cx="1560695" cy="137160"/>
+            <a:off x="1596280" y="3716413"/>
+            <a:ext cx="1814708" cy="137160"/>
           </a:xfrm>
           <a:prstGeom prst="rect">
             <a:avLst/>
@@ -15062,7 +15055,7 @@
         </p:nvSpPr>
         <p:spPr>
           <a:xfrm>
-            <a:off x="2227600" y="3849001"/>
+            <a:off x="1596280" y="3849001"/>
             <a:ext cx="438912" cy="118872"/>
           </a:xfrm>
           <a:prstGeom prst="rect">
@@ -15105,8 +15098,8 @@
         </p:nvSpPr>
         <p:spPr>
           <a:xfrm>
-            <a:off x="2638309" y="3858145"/>
-            <a:ext cx="2601159" cy="54864"/>
+            <a:off x="2073834" y="3858145"/>
+            <a:ext cx="3024515" cy="54864"/>
           </a:xfrm>
           <a:prstGeom prst="rect">
             <a:avLst/>
@@ -15127,8 +15120,8 @@
         </p:nvSpPr>
         <p:spPr>
           <a:xfrm>
-            <a:off x="3505362" y="3949585"/>
-            <a:ext cx="2473382" cy="54864"/>
+            <a:off x="3082006" y="3949585"/>
+            <a:ext cx="2875942" cy="54864"/>
           </a:xfrm>
           <a:prstGeom prst="rect">
             <a:avLst/>
@@ -15149,8 +15142,8 @@
         </p:nvSpPr>
         <p:spPr>
           <a:xfrm>
-            <a:off x="4171623" y="4041025"/>
-            <a:ext cx="1825375" cy="54864"/>
+            <a:off x="3856706" y="4041025"/>
+            <a:ext cx="2122467" cy="54864"/>
           </a:xfrm>
           <a:prstGeom prst="rect">
             <a:avLst/>
@@ -15171,7 +15164,7 @@
         </p:nvCxnSpPr>
         <p:spPr>
           <a:xfrm>
-            <a:off x="4710109" y="3602113"/>
+            <a:off x="4482834" y="3602113"/>
             <a:ext cx="1" cy="393192"/>
           </a:xfrm>
           <a:prstGeom prst="line">
@@ -15192,8 +15185,8 @@
         </p:nvCxnSpPr>
         <p:spPr>
           <a:xfrm>
-            <a:off x="4710109" y="3784993"/>
-            <a:ext cx="1521978" cy="1"/>
+            <a:off x="4482834" y="3784993"/>
+            <a:ext cx="1749253" cy="1"/>
           </a:xfrm>
           <a:prstGeom prst="line">
             <a:avLst/>
@@ -15214,8 +15207,8 @@
         </p:nvSpPr>
         <p:spPr>
           <a:xfrm>
-            <a:off x="2227600" y="4232083"/>
-            <a:ext cx="1405538" cy="137160"/>
+            <a:off x="1596280" y="4232083"/>
+            <a:ext cx="1634299" cy="137160"/>
           </a:xfrm>
           <a:prstGeom prst="rect">
             <a:avLst/>
@@ -15257,7 +15250,7 @@
         </p:nvSpPr>
         <p:spPr>
           <a:xfrm>
-            <a:off x="2227600" y="4364671"/>
+            <a:off x="1596280" y="4364671"/>
             <a:ext cx="438912" cy="118872"/>
           </a:xfrm>
           <a:prstGeom prst="rect">
@@ -15300,8 +15293,8 @@
         </p:nvSpPr>
         <p:spPr>
           <a:xfrm>
-            <a:off x="2793466" y="4373815"/>
-            <a:ext cx="2519017" cy="54864"/>
+            <a:off x="2254244" y="4373815"/>
+            <a:ext cx="2929004" cy="54864"/>
           </a:xfrm>
           <a:prstGeom prst="rect">
             <a:avLst/>
@@ -15322,8 +15315,8 @@
         </p:nvSpPr>
         <p:spPr>
           <a:xfrm>
-            <a:off x="3687899" y="4465255"/>
-            <a:ext cx="2217830" cy="54864"/>
+            <a:off x="3294253" y="4465255"/>
+            <a:ext cx="2578796" cy="54864"/>
           </a:xfrm>
           <a:prstGeom prst="rect">
             <a:avLst/>
@@ -15344,7 +15337,7 @@
         </p:nvCxnSpPr>
         <p:spPr>
           <a:xfrm>
-            <a:off x="4491064" y="4117783"/>
+            <a:off x="4228138" y="4117783"/>
             <a:ext cx="1" cy="393192"/>
           </a:xfrm>
           <a:prstGeom prst="line">
@@ -15365,8 +15358,8 @@
         </p:nvCxnSpPr>
         <p:spPr>
           <a:xfrm>
-            <a:off x="4491064" y="4300663"/>
-            <a:ext cx="1741023" cy="1"/>
+            <a:off x="4228138" y="4300663"/>
+            <a:ext cx="2003949" cy="1"/>
           </a:xfrm>
           <a:prstGeom prst="line">
             <a:avLst/>
@@ -15387,8 +15380,8 @@
         </p:nvSpPr>
         <p:spPr>
           <a:xfrm>
-            <a:off x="2227600" y="4747753"/>
-            <a:ext cx="1925770" cy="137160"/>
+            <a:off x="1596280" y="4747753"/>
+            <a:ext cx="2239202" cy="137160"/>
           </a:xfrm>
           <a:prstGeom prst="rect">
             <a:avLst/>
@@ -15430,7 +15423,7 @@
         </p:nvSpPr>
         <p:spPr>
           <a:xfrm>
-            <a:off x="2227600" y="4880341"/>
+            <a:off x="1596280" y="4880341"/>
             <a:ext cx="438912" cy="118872"/>
           </a:xfrm>
           <a:prstGeom prst="rect">
@@ -15473,8 +15466,8 @@
         </p:nvSpPr>
         <p:spPr>
           <a:xfrm>
-            <a:off x="3185921" y="4889485"/>
-            <a:ext cx="2920600" cy="54864"/>
+            <a:off x="2710574" y="4889485"/>
+            <a:ext cx="3395947" cy="54864"/>
           </a:xfrm>
           <a:prstGeom prst="rect">
             <a:avLst/>
@@ -15495,7 +15488,7 @@
         </p:nvCxnSpPr>
         <p:spPr>
           <a:xfrm>
-            <a:off x="5266848" y="4633453"/>
+            <a:off x="5130186" y="4633453"/>
             <a:ext cx="1" cy="393192"/>
           </a:xfrm>
           <a:prstGeom prst="line">
@@ -15516,8 +15509,8 @@
         </p:nvCxnSpPr>
         <p:spPr>
           <a:xfrm>
-            <a:off x="5266848" y="4816333"/>
-            <a:ext cx="965239" cy="1"/>
+            <a:off x="5130186" y="4816333"/>
+            <a:ext cx="1101901" cy="1"/>
           </a:xfrm>
           <a:prstGeom prst="line">
             <a:avLst/>
@@ -15538,7 +15531,7 @@
         </p:nvSpPr>
         <p:spPr>
           <a:xfrm>
-            <a:off x="3824100" y="2771941"/>
+            <a:off x="3513639" y="2771941"/>
             <a:ext cx="749808" cy="128016"/>
           </a:xfrm>
           <a:prstGeom prst="rect">
@@ -15581,7 +15574,7 @@
         </p:nvSpPr>
         <p:spPr>
           <a:xfrm>
-            <a:off x="4964874" y="2771941"/>
+            <a:off x="4847522" y="2771941"/>
             <a:ext cx="841248" cy="128016"/>
           </a:xfrm>
           <a:prstGeom prst="rect">
@@ -15845,7 +15838,7 @@
         </p:nvGraphicFramePr>
         <p:xfrm>
           <a:off x="7804855" y="1517904"/>
-          <a:ext cx="3930586" cy="2743200"/>
+          <a:ext cx="3930586" cy="2857500"/>
         </p:xfrm>
         <a:graphic>
           <a:graphicData uri="http://schemas.openxmlformats.org/drawingml/2006/table">
@@ -16565,7 +16558,7 @@
                           <a:ea typeface="Arial"/>
                           <a:cs typeface="Arial"/>
                         </a:rPr>
-                        <a:t>BPA</a:t>
+                        <a:t>Blanket Purchase Agreement (BPA)</a:t>
                       </a:r>
                     </a:p>
                   </a:txBody>
@@ -16737,7 +16730,7 @@
                           <a:ea typeface="Arial"/>
                           <a:cs typeface="Arial"/>
                         </a:rPr>
-                        <a:t>OT agreement or order</a:t>
+                        <a:t>Other Transaction (OT)</a:t>
                       </a:r>
                     </a:p>
                   </a:txBody>
@@ -17061,7 +17054,7 @@
                   </a:tcPr>
                 </a:tc>
               </a:tr>
-              <a:tr h="320040">
+              <a:tr h="434340">
                 <a:tc>
                   <a:txBody>
                     <a:bodyPr anchor="ctr"/>
@@ -17081,7 +17074,7 @@
                           <a:ea typeface="Arial"/>
                           <a:cs typeface="Arial"/>
                         </a:rPr>
-                        <a:t>BOA  (not charted)</a:t>
+                        <a:t>Basic Ordering Agreement (BOA)  (not charted)</a:t>
                       </a:r>
                     </a:p>
                   </a:txBody>

</xml_diff>

<commit_message>
Awards methodology deck: SAM -> SAM.gov labels; title-case stage labels
Pre-existing working-tree copy edit on the Award Data Sourcing slide (not authored this session): qualify the 'SAM' source names as 'SAM.gov' and convert the PULL/ENRICH/VALIDATE/OUTPUTS stage labels to title case; rebuilt deck pptx.

Co-Authored-By: Claude Opus 4.8 (1M context) <noreply@anthropic.com>
</commit_message>
<xml_diff>
--- a/projects/other/awards_methodology/20260622_Awards Methodology_vS.pptx
+++ b/projects/other/awards_methodology/20260622_Awards Methodology_vS.pptx
@@ -20899,7 +20899,7 @@
                 <a:ea typeface="Arial"/>
                 <a:cs typeface="Arial"/>
               </a:rPr>
-              <a:t>Award Data Sourcing | SAM Contract Awards anchors the pull; funding and subaward layers enrich it, and validation precedes any total.</a:t>
+              <a:t>Award Data Sourcing | SAM.gov Contract Awards anchors the pull; funding and subaward layers enrich it, and validation precedes any total.</a:t>
             </a:r>
           </a:p>
         </p:txBody>
@@ -21047,7 +21047,7 @@
                 <a:ea typeface="Arial"/>
                 <a:cs typeface="Arial"/>
               </a:rPr>
-              <a:t>PULL</a:t>
+              <a:t>Pull</a:t>
             </a:r>
           </a:p>
         </p:txBody>
@@ -21090,7 +21090,7 @@
                 <a:ea typeface="Arial"/>
                 <a:cs typeface="Arial"/>
               </a:rPr>
-              <a:t>ENRICH</a:t>
+              <a:t>Enrich</a:t>
             </a:r>
           </a:p>
         </p:txBody>
@@ -21133,7 +21133,7 @@
                 <a:ea typeface="Arial"/>
                 <a:cs typeface="Arial"/>
               </a:rPr>
-              <a:t>VALIDATE</a:t>
+              <a:t>Validate</a:t>
             </a:r>
           </a:p>
         </p:txBody>
@@ -21176,7 +21176,7 @@
                 <a:ea typeface="Arial"/>
                 <a:cs typeface="Arial"/>
               </a:rPr>
-              <a:t>OUTPUTS</a:t>
+              <a:t>Outputs</a:t>
             </a:r>
           </a:p>
         </p:txBody>
@@ -21219,7 +21219,7 @@
                 <a:ea typeface="Arial"/>
                 <a:cs typeface="Arial"/>
               </a:rPr>
-              <a:t>The modern base pull is SAM Contract Awards, not the FPDS Atom feed.</a:t>
+              <a:t>The modern base pull is SAM.gov Contract Awards, not the FPDS Atom feed.</a:t>
             </a:r>
           </a:p>
           <a:p>
@@ -21328,7 +21328,7 @@
                 <a:ea typeface="Arial"/>
                 <a:cs typeface="Arial"/>
               </a:rPr>
-              <a:t>ADD</a:t>
+              <a:t>Add</a:t>
             </a:r>
           </a:p>
         </p:txBody>
@@ -21418,7 +21418,7 @@
                 <a:ea typeface="Arial"/>
                 <a:cs typeface="Arial"/>
               </a:rPr>
-              <a:t>LINK</a:t>
+              <a:t>Link</a:t>
             </a:r>
           </a:p>
         </p:txBody>
@@ -21508,7 +21508,7 @@
                 <a:ea typeface="Arial"/>
                 <a:cs typeface="Arial"/>
               </a:rPr>
-              <a:t>PULL</a:t>
+              <a:t>Pull</a:t>
             </a:r>
           </a:p>
         </p:txBody>
@@ -21598,7 +21598,7 @@
                 <a:ea typeface="Arial"/>
                 <a:cs typeface="Arial"/>
               </a:rPr>
-              <a:t>RESOLVE</a:t>
+              <a:t>Resolve</a:t>
             </a:r>
           </a:p>
         </p:txBody>
@@ -21645,7 +21645,7 @@
                 <a:ea typeface="Arial"/>
                 <a:cs typeface="Arial"/>
               </a:rPr>
-              <a:t>USASPENDING</a:t>
+              <a:t>USAspending</a:t>
             </a:r>
           </a:p>
           <a:p>
@@ -21711,7 +21711,7 @@
                 <a:ea typeface="Arial"/>
                 <a:cs typeface="Arial"/>
               </a:rPr>
-              <a:t>VEHICLE FAMILY</a:t>
+              <a:t>Vehicle Family</a:t>
             </a:r>
           </a:p>
           <a:p>
@@ -21777,7 +21777,7 @@
                 <a:ea typeface="Arial"/>
                 <a:cs typeface="Arial"/>
               </a:rPr>
-              <a:t>SAM SUBAWARDS</a:t>
+              <a:t>SAM.gov Subawards</a:t>
             </a:r>
           </a:p>
           <a:p>
@@ -21843,7 +21843,7 @@
                 <a:ea typeface="Arial"/>
                 <a:cs typeface="Arial"/>
               </a:rPr>
-              <a:t>SAM ENTITY</a:t>
+              <a:t>SAM.gov Entity</a:t>
             </a:r>
           </a:p>
           <a:p>
@@ -21909,7 +21909,7 @@
                 <a:ea typeface="Arial"/>
                 <a:cs typeface="Arial"/>
               </a:rPr>
-              <a:t>BUDGET BRIDGE</a:t>
+              <a:t>Budget Bridge</a:t>
             </a:r>
           </a:p>
           <a:p>
@@ -21928,7 +21928,7 @@
                 <a:ea typeface="Arial"/>
                 <a:cs typeface="Arial"/>
               </a:rPr>
-              <a:t>FY obligations and TAS; reconcile to SAM.</a:t>
+              <a:t>FY obligations and TAS; reconcile to SAM.gov.</a:t>
             </a:r>
           </a:p>
         </p:txBody>
@@ -21975,7 +21975,7 @@
                 <a:ea typeface="Arial"/>
                 <a:cs typeface="Arial"/>
               </a:rPr>
-              <a:t>DIFFERENT QUESTION</a:t>
+              <a:t>Different Question</a:t>
             </a:r>
           </a:p>
           <a:p>
@@ -22171,7 +22171,7 @@
                 <a:ea typeface="Arial"/>
                 <a:cs typeface="Arial"/>
               </a:rPr>
-              <a:t>PRESIDENT'S BUDGET</a:t>
+              <a:t>President's Budget</a:t>
             </a:r>
           </a:p>
           <a:p>
@@ -22237,7 +22237,7 @@
                 <a:ea typeface="Arial"/>
                 <a:cs typeface="Arial"/>
               </a:rPr>
-              <a:t>SAM CONTRACT AWARDS</a:t>
+              <a:t>SAM.gov Contract Awards</a:t>
             </a:r>
           </a:p>
           <a:p>
@@ -22346,7 +22346,7 @@
                 <a:ea typeface="Arial"/>
                 <a:cs typeface="Arial"/>
               </a:rPr>
-              <a:t>DEFINE</a:t>
+              <a:t>Define</a:t>
             </a:r>
           </a:p>
         </p:txBody>
@@ -22436,7 +22436,7 @@
                 <a:ea typeface="Arial"/>
                 <a:cs typeface="Arial"/>
               </a:rPr>
-              <a:t>PULL</a:t>
+              <a:t>Pull</a:t>
             </a:r>
           </a:p>
         </p:txBody>
@@ -22505,7 +22505,7 @@
                 <a:ea typeface="Arial"/>
                 <a:cs typeface="Arial"/>
               </a:rPr>
-              <a:t>VALIDATION</a:t>
+              <a:t>Validation</a:t>
             </a:r>
           </a:p>
           <a:p>
@@ -22524,7 +22524,7 @@
                 <a:ea typeface="Arial"/>
                 <a:cs typeface="Arial"/>
               </a:rPr>
-              <a:t>GATE</a:t>
+              <a:t>Gate</a:t>
             </a:r>
           </a:p>
           <a:p>
@@ -22633,7 +22633,7 @@
                 <a:ea typeface="Arial"/>
                 <a:cs typeface="Arial"/>
               </a:rPr>
-              <a:t>VALIDATE</a:t>
+              <a:t>Validate</a:t>
             </a:r>
           </a:p>
         </p:txBody>
@@ -22701,7 +22701,7 @@
                 <a:ea typeface="Arial"/>
                 <a:cs typeface="Arial"/>
               </a:rPr>
-              <a:t>FPDS ATOM | legacy lineage and validation; retiring FY2026</a:t>
+              <a:t>FPDS Atom | legacy lineage and validation; retiring FY2026</a:t>
             </a:r>
           </a:p>
         </p:txBody>
@@ -22770,7 +22770,7 @@
                 <a:ea typeface="Arial"/>
                 <a:cs typeface="Arial"/>
               </a:rPr>
-              <a:t>EXTERNAL PROGRAM EVIDENCE</a:t>
+              <a:t>External Program Evidence</a:t>
             </a:r>
           </a:p>
           <a:p>
@@ -22923,7 +22923,7 @@
                 <a:ea typeface="Arial"/>
                 <a:cs typeface="Arial"/>
               </a:rPr>
-              <a:t>MARKET SIZE</a:t>
+              <a:t>Market Size</a:t>
             </a:r>
           </a:p>
           <a:p>
@@ -22989,7 +22989,7 @@
                 <a:ea typeface="Arial"/>
                 <a:cs typeface="Arial"/>
               </a:rPr>
-              <a:t>OPPORTUNITY MAP</a:t>
+              <a:t>Opportunity Map</a:t>
             </a:r>
           </a:p>
           <a:p>
@@ -23008,7 +23008,7 @@
                 <a:ea typeface="Arial"/>
                 <a:cs typeface="Arial"/>
               </a:rPr>
-              <a:t>SAM Opportunities, vehicles and incumbents</a:t>
+              <a:t>SAM.gov Opportunities, vehicles and incumbents</a:t>
             </a:r>
           </a:p>
         </p:txBody>
@@ -23055,7 +23055,7 @@
                 <a:ea typeface="Arial"/>
                 <a:cs typeface="Arial"/>
               </a:rPr>
-              <a:t>END-USER READ</a:t>
+              <a:t>End-User Read</a:t>
             </a:r>
           </a:p>
           <a:p>
@@ -23220,7 +23220,7 @@
                 <a:ea typeface="Arial"/>
                 <a:cs typeface="Arial"/>
               </a:rPr>
-              <a:t>VALIDATION IS THE METHOD.</a:t>
+              <a:t>Validation is the method.</a:t>
             </a:r>
           </a:p>
           <a:p>
@@ -23448,7 +23448,7 @@
                 <a:ea typeface="Arial"/>
                 <a:cs typeface="Arial"/>
               </a:rPr>
-              <a:t>Sources: SAM.gov Contract Awards API; USAspending; SAM Acquisition Subaward Reporting; SAM Entity Management and Opportunities; President's Budget P-1 / R-1; external program and operational reporting; FPDS Atom (legacy validation, slated to retire FY2026) | As of 2026-06-22</a:t>
+              <a:t>Sources: SAM.gov Contract Awards API; USAspending; SAM.gov Acquisition Subaward Reporting; SAM.gov Entity Management and Opportunities; President's Budget P-1 / R-1; external program and operational reporting; FPDS Atom (legacy validation, slated to retire FY2026) | As of 2026-06-22</a:t>
             </a:r>
           </a:p>
         </p:txBody>

</xml_diff>